<commit_message>
Fix seaborn chart rendering and compile comprehensive 8-slide PPTX deck
</commit_message>
<xml_diff>
--- a/docs/Week4_AA_AB_Testing_Summary.pptx
+++ b/docs/Week4_AA_AB_Testing_Summary.pptx
@@ -5,11 +5,15 @@
     <p:sldMasterId id="2147483648" r:id="rId1"/>
   </p:sldMasterIdLst>
   <p:sldIdLst>
-    <p:sldId id="256" r:id="rId7"/>
-    <p:sldId id="257" r:id="rId8"/>
-    <p:sldId id="258" r:id="rId9"/>
-    <p:sldId id="259" r:id="rId10"/>
-    <p:sldId id="260" r:id="rId11"/>
+    <p:sldId id="256" r:id="rId2"/>
+    <p:sldId id="257" r:id="rId3"/>
+    <p:sldId id="258" r:id="rId4"/>
+    <p:sldId id="259" r:id="rId5"/>
+    <p:sldId id="262" r:id="rId6"/>
+    <p:sldId id="263" r:id="rId7"/>
+    <p:sldId id="264" r:id="rId8"/>
+    <p:sldId id="265" r:id="rId9"/>
+    <p:sldId id="266" r:id="rId10"/>
   </p:sldIdLst>
   <p:sldSz cx="9144000" cy="6858000" type="screen4x3"/>
   <p:notesSz cx="6858000" cy="9144000"/>
@@ -108,6 +112,22 @@
       </a:defRPr>
     </a:lvl9pPr>
   </p:defaultTextStyle>
+  <p:extLst>
+    <p:ext uri="{EFAFB233-063F-42B5-8137-9DF3F51BA10A}">
+      <p15:sldGuideLst xmlns:p15="http://schemas.microsoft.com/office/powerpoint/2012/main">
+        <p15:guide id="1" orient="horz" pos="2160">
+          <p15:clr>
+            <a:srgbClr val="A4A3A4"/>
+          </p15:clr>
+        </p15:guide>
+        <p15:guide id="2" pos="2880">
+          <p15:clr>
+            <a:srgbClr val="A4A3A4"/>
+          </p15:clr>
+        </p15:guide>
+      </p15:sldGuideLst>
+    </p:ext>
+  </p:extLst>
 </p:presentation>
 </file>
 
@@ -149,10 +169,9 @@
           <a:lstStyle/>
           <a:p>
             <a:r>
-              <a:rPr lang="en-US" smtClean="0"/>
+              <a:rPr lang="en-US"/>
               <a:t>Click to edit Master title style</a:t>
             </a:r>
-            <a:endParaRPr lang="en-US"/>
           </a:p>
         </p:txBody>
       </p:sp>
@@ -268,10 +287,9 @@
           </a:lstStyle>
           <a:p>
             <a:r>
-              <a:rPr lang="en-US" smtClean="0"/>
+              <a:rPr lang="en-US"/>
               <a:t>Click to edit Master subtitle style</a:t>
             </a:r>
-            <a:endParaRPr lang="en-US"/>
           </a:p>
         </p:txBody>
       </p:sp>
@@ -292,7 +310,7 @@
           <a:p>
             <a:fld id="{5BCAD085-E8A6-8845-BD4E-CB4CCA059FC4}" type="datetimeFigureOut">
               <a:rPr lang="en-US" smtClean="0"/>
-              <a:t>1/27/13</a:t>
+              <a:t>8/10/2026</a:t>
             </a:fld>
             <a:endParaRPr lang="en-US"/>
           </a:p>
@@ -386,10 +404,9 @@
           <a:lstStyle/>
           <a:p>
             <a:r>
-              <a:rPr lang="en-US" smtClean="0"/>
+              <a:rPr lang="en-US"/>
               <a:t>Click to edit Master title style</a:t>
             </a:r>
-            <a:endParaRPr lang="en-US"/>
           </a:p>
         </p:txBody>
       </p:sp>
@@ -410,38 +427,37 @@
           <a:p>
             <a:pPr lvl="0"/>
             <a:r>
-              <a:rPr lang="en-US" smtClean="0"/>
+              <a:rPr lang="en-US"/>
               <a:t>Click to edit Master text styles</a:t>
             </a:r>
           </a:p>
           <a:p>
             <a:pPr lvl="1"/>
             <a:r>
-              <a:rPr lang="en-US" smtClean="0"/>
+              <a:rPr lang="en-US"/>
               <a:t>Second level</a:t>
             </a:r>
           </a:p>
           <a:p>
             <a:pPr lvl="2"/>
             <a:r>
-              <a:rPr lang="en-US" smtClean="0"/>
+              <a:rPr lang="en-US"/>
               <a:t>Third level</a:t>
             </a:r>
           </a:p>
           <a:p>
             <a:pPr lvl="3"/>
             <a:r>
-              <a:rPr lang="en-US" smtClean="0"/>
+              <a:rPr lang="en-US"/>
               <a:t>Fourth level</a:t>
             </a:r>
           </a:p>
           <a:p>
             <a:pPr lvl="4"/>
             <a:r>
-              <a:rPr lang="en-US" smtClean="0"/>
+              <a:rPr lang="en-US"/>
               <a:t>Fifth level</a:t>
             </a:r>
-            <a:endParaRPr lang="en-US"/>
           </a:p>
         </p:txBody>
       </p:sp>
@@ -462,7 +478,7 @@
           <a:p>
             <a:fld id="{5BCAD085-E8A6-8845-BD4E-CB4CCA059FC4}" type="datetimeFigureOut">
               <a:rPr lang="en-US" smtClean="0"/>
-              <a:t>1/27/13</a:t>
+              <a:t>8/10/2026</a:t>
             </a:fld>
             <a:endParaRPr lang="en-US"/>
           </a:p>
@@ -561,10 +577,9 @@
           <a:lstStyle/>
           <a:p>
             <a:r>
-              <a:rPr lang="en-US" smtClean="0"/>
+              <a:rPr lang="en-US"/>
               <a:t>Click to edit Master title style</a:t>
             </a:r>
-            <a:endParaRPr lang="en-US"/>
           </a:p>
         </p:txBody>
       </p:sp>
@@ -590,38 +605,37 @@
           <a:p>
             <a:pPr lvl="0"/>
             <a:r>
-              <a:rPr lang="en-US" smtClean="0"/>
+              <a:rPr lang="en-US"/>
               <a:t>Click to edit Master text styles</a:t>
             </a:r>
           </a:p>
           <a:p>
             <a:pPr lvl="1"/>
             <a:r>
-              <a:rPr lang="en-US" smtClean="0"/>
+              <a:rPr lang="en-US"/>
               <a:t>Second level</a:t>
             </a:r>
           </a:p>
           <a:p>
             <a:pPr lvl="2"/>
             <a:r>
-              <a:rPr lang="en-US" smtClean="0"/>
+              <a:rPr lang="en-US"/>
               <a:t>Third level</a:t>
             </a:r>
           </a:p>
           <a:p>
             <a:pPr lvl="3"/>
             <a:r>
-              <a:rPr lang="en-US" smtClean="0"/>
+              <a:rPr lang="en-US"/>
               <a:t>Fourth level</a:t>
             </a:r>
           </a:p>
           <a:p>
             <a:pPr lvl="4"/>
             <a:r>
-              <a:rPr lang="en-US" smtClean="0"/>
+              <a:rPr lang="en-US"/>
               <a:t>Fifth level</a:t>
             </a:r>
-            <a:endParaRPr lang="en-US"/>
           </a:p>
         </p:txBody>
       </p:sp>
@@ -642,7 +656,7 @@
           <a:p>
             <a:fld id="{5BCAD085-E8A6-8845-BD4E-CB4CCA059FC4}" type="datetimeFigureOut">
               <a:rPr lang="en-US" smtClean="0"/>
-              <a:t>1/27/13</a:t>
+              <a:t>8/10/2026</a:t>
             </a:fld>
             <a:endParaRPr lang="en-US"/>
           </a:p>
@@ -736,10 +750,9 @@
           <a:lstStyle/>
           <a:p>
             <a:r>
-              <a:rPr lang="en-US" smtClean="0"/>
+              <a:rPr lang="en-US"/>
               <a:t>Click to edit Master title style</a:t>
             </a:r>
-            <a:endParaRPr lang="en-US"/>
           </a:p>
         </p:txBody>
       </p:sp>
@@ -760,38 +773,37 @@
           <a:p>
             <a:pPr lvl="0"/>
             <a:r>
-              <a:rPr lang="en-US" smtClean="0"/>
+              <a:rPr lang="en-US"/>
               <a:t>Click to edit Master text styles</a:t>
             </a:r>
           </a:p>
           <a:p>
             <a:pPr lvl="1"/>
             <a:r>
-              <a:rPr lang="en-US" smtClean="0"/>
+              <a:rPr lang="en-US"/>
               <a:t>Second level</a:t>
             </a:r>
           </a:p>
           <a:p>
             <a:pPr lvl="2"/>
             <a:r>
-              <a:rPr lang="en-US" smtClean="0"/>
+              <a:rPr lang="en-US"/>
               <a:t>Third level</a:t>
             </a:r>
           </a:p>
           <a:p>
             <a:pPr lvl="3"/>
             <a:r>
-              <a:rPr lang="en-US" smtClean="0"/>
+              <a:rPr lang="en-US"/>
               <a:t>Fourth level</a:t>
             </a:r>
           </a:p>
           <a:p>
             <a:pPr lvl="4"/>
             <a:r>
-              <a:rPr lang="en-US" smtClean="0"/>
+              <a:rPr lang="en-US"/>
               <a:t>Fifth level</a:t>
             </a:r>
-            <a:endParaRPr lang="en-US"/>
           </a:p>
         </p:txBody>
       </p:sp>
@@ -812,7 +824,7 @@
           <a:p>
             <a:fld id="{5BCAD085-E8A6-8845-BD4E-CB4CCA059FC4}" type="datetimeFigureOut">
               <a:rPr lang="en-US" smtClean="0"/>
-              <a:t>1/27/13</a:t>
+              <a:t>8/10/2026</a:t>
             </a:fld>
             <a:endParaRPr lang="en-US"/>
           </a:p>
@@ -915,10 +927,9 @@
           </a:lstStyle>
           <a:p>
             <a:r>
-              <a:rPr lang="en-US" smtClean="0"/>
+              <a:rPr lang="en-US"/>
               <a:t>Click to edit Master title style</a:t>
             </a:r>
-            <a:endParaRPr lang="en-US"/>
           </a:p>
         </p:txBody>
       </p:sp>
@@ -1035,7 +1046,7 @@
           <a:p>
             <a:pPr lvl="0"/>
             <a:r>
-              <a:rPr lang="en-US" smtClean="0"/>
+              <a:rPr lang="en-US"/>
               <a:t>Click to edit Master text styles</a:t>
             </a:r>
           </a:p>
@@ -1058,7 +1069,7 @@
           <a:p>
             <a:fld id="{5BCAD085-E8A6-8845-BD4E-CB4CCA059FC4}" type="datetimeFigureOut">
               <a:rPr lang="en-US" smtClean="0"/>
-              <a:t>1/27/13</a:t>
+              <a:t>8/10/2026</a:t>
             </a:fld>
             <a:endParaRPr lang="en-US"/>
           </a:p>
@@ -1152,10 +1163,9 @@
           <a:lstStyle/>
           <a:p>
             <a:r>
-              <a:rPr lang="en-US" smtClean="0"/>
+              <a:rPr lang="en-US"/>
               <a:t>Click to edit Master title style</a:t>
             </a:r>
-            <a:endParaRPr lang="en-US"/>
           </a:p>
         </p:txBody>
       </p:sp>
@@ -1209,38 +1219,37 @@
           <a:p>
             <a:pPr lvl="0"/>
             <a:r>
-              <a:rPr lang="en-US" smtClean="0"/>
+              <a:rPr lang="en-US"/>
               <a:t>Click to edit Master text styles</a:t>
             </a:r>
           </a:p>
           <a:p>
             <a:pPr lvl="1"/>
             <a:r>
-              <a:rPr lang="en-US" smtClean="0"/>
+              <a:rPr lang="en-US"/>
               <a:t>Second level</a:t>
             </a:r>
           </a:p>
           <a:p>
             <a:pPr lvl="2"/>
             <a:r>
-              <a:rPr lang="en-US" smtClean="0"/>
+              <a:rPr lang="en-US"/>
               <a:t>Third level</a:t>
             </a:r>
           </a:p>
           <a:p>
             <a:pPr lvl="3"/>
             <a:r>
-              <a:rPr lang="en-US" smtClean="0"/>
+              <a:rPr lang="en-US"/>
               <a:t>Fourth level</a:t>
             </a:r>
           </a:p>
           <a:p>
             <a:pPr lvl="4"/>
             <a:r>
-              <a:rPr lang="en-US" smtClean="0"/>
+              <a:rPr lang="en-US"/>
               <a:t>Fifth level</a:t>
             </a:r>
-            <a:endParaRPr lang="en-US"/>
           </a:p>
         </p:txBody>
       </p:sp>
@@ -1294,38 +1303,37 @@
           <a:p>
             <a:pPr lvl="0"/>
             <a:r>
-              <a:rPr lang="en-US" smtClean="0"/>
+              <a:rPr lang="en-US"/>
               <a:t>Click to edit Master text styles</a:t>
             </a:r>
           </a:p>
           <a:p>
             <a:pPr lvl="1"/>
             <a:r>
-              <a:rPr lang="en-US" smtClean="0"/>
+              <a:rPr lang="en-US"/>
               <a:t>Second level</a:t>
             </a:r>
           </a:p>
           <a:p>
             <a:pPr lvl="2"/>
             <a:r>
-              <a:rPr lang="en-US" smtClean="0"/>
+              <a:rPr lang="en-US"/>
               <a:t>Third level</a:t>
             </a:r>
           </a:p>
           <a:p>
             <a:pPr lvl="3"/>
             <a:r>
-              <a:rPr lang="en-US" smtClean="0"/>
+              <a:rPr lang="en-US"/>
               <a:t>Fourth level</a:t>
             </a:r>
           </a:p>
           <a:p>
             <a:pPr lvl="4"/>
             <a:r>
-              <a:rPr lang="en-US" smtClean="0"/>
+              <a:rPr lang="en-US"/>
               <a:t>Fifth level</a:t>
             </a:r>
-            <a:endParaRPr lang="en-US"/>
           </a:p>
         </p:txBody>
       </p:sp>
@@ -1346,7 +1354,7 @@
           <a:p>
             <a:fld id="{5BCAD085-E8A6-8845-BD4E-CB4CCA059FC4}" type="datetimeFigureOut">
               <a:rPr lang="en-US" smtClean="0"/>
-              <a:t>1/27/13</a:t>
+              <a:t>8/10/2026</a:t>
             </a:fld>
             <a:endParaRPr lang="en-US"/>
           </a:p>
@@ -1444,10 +1452,9 @@
           </a:lstStyle>
           <a:p>
             <a:r>
-              <a:rPr lang="en-US" smtClean="0"/>
+              <a:rPr lang="en-US"/>
               <a:t>Click to edit Master title style</a:t>
             </a:r>
-            <a:endParaRPr lang="en-US"/>
           </a:p>
         </p:txBody>
       </p:sp>
@@ -1510,7 +1517,7 @@
           <a:p>
             <a:pPr lvl="0"/>
             <a:r>
-              <a:rPr lang="en-US" smtClean="0"/>
+              <a:rPr lang="en-US"/>
               <a:t>Click to edit Master text styles</a:t>
             </a:r>
           </a:p>
@@ -1566,38 +1573,37 @@
           <a:p>
             <a:pPr lvl="0"/>
             <a:r>
-              <a:rPr lang="en-US" smtClean="0"/>
+              <a:rPr lang="en-US"/>
               <a:t>Click to edit Master text styles</a:t>
             </a:r>
           </a:p>
           <a:p>
             <a:pPr lvl="1"/>
             <a:r>
-              <a:rPr lang="en-US" smtClean="0"/>
+              <a:rPr lang="en-US"/>
               <a:t>Second level</a:t>
             </a:r>
           </a:p>
           <a:p>
             <a:pPr lvl="2"/>
             <a:r>
-              <a:rPr lang="en-US" smtClean="0"/>
+              <a:rPr lang="en-US"/>
               <a:t>Third level</a:t>
             </a:r>
           </a:p>
           <a:p>
             <a:pPr lvl="3"/>
             <a:r>
-              <a:rPr lang="en-US" smtClean="0"/>
+              <a:rPr lang="en-US"/>
               <a:t>Fourth level</a:t>
             </a:r>
           </a:p>
           <a:p>
             <a:pPr lvl="4"/>
             <a:r>
-              <a:rPr lang="en-US" smtClean="0"/>
+              <a:rPr lang="en-US"/>
               <a:t>Fifth level</a:t>
             </a:r>
-            <a:endParaRPr lang="en-US"/>
           </a:p>
         </p:txBody>
       </p:sp>
@@ -1660,7 +1666,7 @@
           <a:p>
             <a:pPr lvl="0"/>
             <a:r>
-              <a:rPr lang="en-US" smtClean="0"/>
+              <a:rPr lang="en-US"/>
               <a:t>Click to edit Master text styles</a:t>
             </a:r>
           </a:p>
@@ -1716,38 +1722,37 @@
           <a:p>
             <a:pPr lvl="0"/>
             <a:r>
-              <a:rPr lang="en-US" smtClean="0"/>
+              <a:rPr lang="en-US"/>
               <a:t>Click to edit Master text styles</a:t>
             </a:r>
           </a:p>
           <a:p>
             <a:pPr lvl="1"/>
             <a:r>
-              <a:rPr lang="en-US" smtClean="0"/>
+              <a:rPr lang="en-US"/>
               <a:t>Second level</a:t>
             </a:r>
           </a:p>
           <a:p>
             <a:pPr lvl="2"/>
             <a:r>
-              <a:rPr lang="en-US" smtClean="0"/>
+              <a:rPr lang="en-US"/>
               <a:t>Third level</a:t>
             </a:r>
           </a:p>
           <a:p>
             <a:pPr lvl="3"/>
             <a:r>
-              <a:rPr lang="en-US" smtClean="0"/>
+              <a:rPr lang="en-US"/>
               <a:t>Fourth level</a:t>
             </a:r>
           </a:p>
           <a:p>
             <a:pPr lvl="4"/>
             <a:r>
-              <a:rPr lang="en-US" smtClean="0"/>
+              <a:rPr lang="en-US"/>
               <a:t>Fifth level</a:t>
             </a:r>
-            <a:endParaRPr lang="en-US"/>
           </a:p>
         </p:txBody>
       </p:sp>
@@ -1768,7 +1773,7 @@
           <a:p>
             <a:fld id="{5BCAD085-E8A6-8845-BD4E-CB4CCA059FC4}" type="datetimeFigureOut">
               <a:rPr lang="en-US" smtClean="0"/>
-              <a:t>1/27/13</a:t>
+              <a:t>8/10/2026</a:t>
             </a:fld>
             <a:endParaRPr lang="en-US"/>
           </a:p>
@@ -1862,10 +1867,9 @@
           <a:lstStyle/>
           <a:p>
             <a:r>
-              <a:rPr lang="en-US" smtClean="0"/>
+              <a:rPr lang="en-US"/>
               <a:t>Click to edit Master title style</a:t>
             </a:r>
-            <a:endParaRPr lang="en-US"/>
           </a:p>
         </p:txBody>
       </p:sp>
@@ -1886,7 +1890,7 @@
           <a:p>
             <a:fld id="{5BCAD085-E8A6-8845-BD4E-CB4CCA059FC4}" type="datetimeFigureOut">
               <a:rPr lang="en-US" smtClean="0"/>
-              <a:t>1/27/13</a:t>
+              <a:t>8/10/2026</a:t>
             </a:fld>
             <a:endParaRPr lang="en-US"/>
           </a:p>
@@ -1981,7 +1985,7 @@
           <a:p>
             <a:fld id="{5BCAD085-E8A6-8845-BD4E-CB4CCA059FC4}" type="datetimeFigureOut">
               <a:rPr lang="en-US" smtClean="0"/>
-              <a:t>1/27/13</a:t>
+              <a:t>8/10/2026</a:t>
             </a:fld>
             <a:endParaRPr lang="en-US"/>
           </a:p>
@@ -2084,10 +2088,9 @@
           </a:lstStyle>
           <a:p>
             <a:r>
-              <a:rPr lang="en-US" smtClean="0"/>
+              <a:rPr lang="en-US"/>
               <a:t>Click to edit Master title style</a:t>
             </a:r>
-            <a:endParaRPr lang="en-US"/>
           </a:p>
         </p:txBody>
       </p:sp>
@@ -2141,38 +2144,37 @@
           <a:p>
             <a:pPr lvl="0"/>
             <a:r>
-              <a:rPr lang="en-US" smtClean="0"/>
+              <a:rPr lang="en-US"/>
               <a:t>Click to edit Master text styles</a:t>
             </a:r>
           </a:p>
           <a:p>
             <a:pPr lvl="1"/>
             <a:r>
-              <a:rPr lang="en-US" smtClean="0"/>
+              <a:rPr lang="en-US"/>
               <a:t>Second level</a:t>
             </a:r>
           </a:p>
           <a:p>
             <a:pPr lvl="2"/>
             <a:r>
-              <a:rPr lang="en-US" smtClean="0"/>
+              <a:rPr lang="en-US"/>
               <a:t>Third level</a:t>
             </a:r>
           </a:p>
           <a:p>
             <a:pPr lvl="3"/>
             <a:r>
-              <a:rPr lang="en-US" smtClean="0"/>
+              <a:rPr lang="en-US"/>
               <a:t>Fourth level</a:t>
             </a:r>
           </a:p>
           <a:p>
             <a:pPr lvl="4"/>
             <a:r>
-              <a:rPr lang="en-US" smtClean="0"/>
+              <a:rPr lang="en-US"/>
               <a:t>Fifth level</a:t>
             </a:r>
-            <a:endParaRPr lang="en-US"/>
           </a:p>
         </p:txBody>
       </p:sp>
@@ -2235,7 +2237,7 @@
           <a:p>
             <a:pPr lvl="0"/>
             <a:r>
-              <a:rPr lang="en-US" smtClean="0"/>
+              <a:rPr lang="en-US"/>
               <a:t>Click to edit Master text styles</a:t>
             </a:r>
           </a:p>
@@ -2258,7 +2260,7 @@
           <a:p>
             <a:fld id="{5BCAD085-E8A6-8845-BD4E-CB4CCA059FC4}" type="datetimeFigureOut">
               <a:rPr lang="en-US" smtClean="0"/>
-              <a:t>1/27/13</a:t>
+              <a:t>8/10/2026</a:t>
             </a:fld>
             <a:endParaRPr lang="en-US"/>
           </a:p>
@@ -2361,10 +2363,9 @@
           </a:lstStyle>
           <a:p>
             <a:r>
-              <a:rPr lang="en-US" smtClean="0"/>
+              <a:rPr lang="en-US"/>
               <a:t>Click to edit Master title style</a:t>
             </a:r>
-            <a:endParaRPr lang="en-US"/>
           </a:p>
         </p:txBody>
       </p:sp>
@@ -2488,7 +2489,7 @@
           <a:p>
             <a:pPr lvl="0"/>
             <a:r>
-              <a:rPr lang="en-US" smtClean="0"/>
+              <a:rPr lang="en-US"/>
               <a:t>Click to edit Master text styles</a:t>
             </a:r>
           </a:p>
@@ -2511,7 +2512,7 @@
           <a:p>
             <a:fld id="{5BCAD085-E8A6-8845-BD4E-CB4CCA059FC4}" type="datetimeFigureOut">
               <a:rPr lang="en-US" smtClean="0"/>
-              <a:t>1/27/13</a:t>
+              <a:t>8/10/2026</a:t>
             </a:fld>
             <a:endParaRPr lang="en-US"/>
           </a:p>
@@ -2620,10 +2621,9 @@
           <a:lstStyle/>
           <a:p>
             <a:r>
-              <a:rPr lang="en-US" smtClean="0"/>
+              <a:rPr lang="en-US"/>
               <a:t>Click to edit Master title style</a:t>
             </a:r>
-            <a:endParaRPr lang="en-US"/>
           </a:p>
         </p:txBody>
       </p:sp>
@@ -2654,38 +2654,37 @@
           <a:p>
             <a:pPr lvl="0"/>
             <a:r>
-              <a:rPr lang="en-US" smtClean="0"/>
+              <a:rPr lang="en-US"/>
               <a:t>Click to edit Master text styles</a:t>
             </a:r>
           </a:p>
           <a:p>
             <a:pPr lvl="1"/>
             <a:r>
-              <a:rPr lang="en-US" smtClean="0"/>
+              <a:rPr lang="en-US"/>
               <a:t>Second level</a:t>
             </a:r>
           </a:p>
           <a:p>
             <a:pPr lvl="2"/>
             <a:r>
-              <a:rPr lang="en-US" smtClean="0"/>
+              <a:rPr lang="en-US"/>
               <a:t>Third level</a:t>
             </a:r>
           </a:p>
           <a:p>
             <a:pPr lvl="3"/>
             <a:r>
-              <a:rPr lang="en-US" smtClean="0"/>
+              <a:rPr lang="en-US"/>
               <a:t>Fourth level</a:t>
             </a:r>
           </a:p>
           <a:p>
             <a:pPr lvl="4"/>
             <a:r>
-              <a:rPr lang="en-US" smtClean="0"/>
+              <a:rPr lang="en-US"/>
               <a:t>Fifth level</a:t>
             </a:r>
-            <a:endParaRPr lang="en-US"/>
           </a:p>
         </p:txBody>
       </p:sp>
@@ -2724,7 +2723,7 @@
           <a:p>
             <a:fld id="{5BCAD085-E8A6-8845-BD4E-CB4CCA059FC4}" type="datetimeFigureOut">
               <a:rPr lang="en-US" smtClean="0"/>
-              <a:t>1/27/13</a:t>
+              <a:t>8/10/2026</a:t>
             </a:fld>
             <a:endParaRPr lang="en-US"/>
           </a:p>
@@ -3083,7 +3082,7 @@
 </file>
 
 <file path=ppt/slides/slide1.xml><?xml version="1.0" encoding="utf-8"?>
-<p:sld xmlns:a="http://schemas.openxmlformats.org/drawingml/2006/main" xmlns:p="http://schemas.openxmlformats.org/presentationml/2006/main" xmlns:r="http://schemas.openxmlformats.org/officeDocument/2006/relationships">
+<p:sld xmlns:a="http://schemas.openxmlformats.org/drawingml/2006/main" xmlns:r="http://schemas.openxmlformats.org/officeDocument/2006/relationships" xmlns:p="http://schemas.openxmlformats.org/presentationml/2006/main">
   <p:cSld>
     <p:bg>
       <p:bgPr>
@@ -3099,7 +3098,14 @@
         <p:cNvGrpSpPr/>
         <p:nvPr/>
       </p:nvGrpSpPr>
-      <p:grpSpPr/>
+      <p:grpSpPr>
+        <a:xfrm>
+          <a:off x="0" y="0"/>
+          <a:ext cx="0" cy="0"/>
+          <a:chOff x="0" y="0"/>
+          <a:chExt cx="0" cy="0"/>
+        </a:xfrm>
+      </p:grpSpPr>
       <p:sp>
         <p:nvSpPr>
           <p:cNvPr id="2" name="TextBox 1"/>
@@ -3122,8 +3128,16 @@
           </a:bodyPr>
           <a:lstStyle/>
           <a:p>
-            <a:r>
-              <a:t>BÁO CÁO TUẦN 4: A/A &amp; A/B TESTING</a:t>
+            <a:pPr algn="ctr">
+              <a:defRPr sz="3600" b="1">
+                <a:solidFill>
+                  <a:srgbClr val="FFFFFF"/>
+                </a:solidFill>
+                <a:latin typeface="Segoe UI"/>
+              </a:defRPr>
+            </a:pPr>
+            <a:r>
+              <a:t>BÁO CÁO TUẦN 5: A/A TESTING</a:t>
             </a:r>
           </a:p>
         </p:txBody>
@@ -3168,6 +3182,7 @@
           <a:lstStyle/>
           <a:p>
             <a:pPr algn="ctr"/>
+            <a:endParaRPr/>
           </a:p>
         </p:txBody>
       </p:sp>
@@ -3193,8 +3208,16 @@
           </a:bodyPr>
           <a:lstStyle/>
           <a:p>
-            <a:r>
-              <a:t>Chứng minh Dữ liệu Thực nghiệm &amp; Phân tích ROI</a:t>
+            <a:pPr algn="ctr">
+              <a:defRPr sz="1800">
+                <a:solidFill>
+                  <a:srgbClr val="38BDF8"/>
+                </a:solidFill>
+                <a:latin typeface="Segoe UI"/>
+              </a:defRPr>
+            </a:pPr>
+            <a:r>
+              <a:t>Kiểm định Độ tin cậy &amp; Trustworthiness Checklist</a:t>
             </a:r>
           </a:p>
         </p:txBody>
@@ -3208,7 +3231,7 @@
 </file>
 
 <file path=ppt/slides/slide2.xml><?xml version="1.0" encoding="utf-8"?>
-<p:sld xmlns:a="http://schemas.openxmlformats.org/drawingml/2006/main" xmlns:p="http://schemas.openxmlformats.org/presentationml/2006/main" xmlns:r="http://schemas.openxmlformats.org/officeDocument/2006/relationships">
+<p:sld xmlns:a="http://schemas.openxmlformats.org/drawingml/2006/main" xmlns:r="http://schemas.openxmlformats.org/officeDocument/2006/relationships" xmlns:p="http://schemas.openxmlformats.org/presentationml/2006/main">
   <p:cSld>
     <p:bg>
       <p:bgPr>
@@ -3224,7 +3247,14 @@
         <p:cNvGrpSpPr/>
         <p:nvPr/>
       </p:nvGrpSpPr>
-      <p:grpSpPr/>
+      <p:grpSpPr>
+        <a:xfrm>
+          <a:off x="0" y="0"/>
+          <a:ext cx="0" cy="0"/>
+          <a:chOff x="0" y="0"/>
+          <a:chExt cx="0" cy="0"/>
+        </a:xfrm>
+      </p:grpSpPr>
       <p:sp>
         <p:nvSpPr>
           <p:cNvPr id="2" name="Rectangle 1"/>
@@ -3265,6 +3295,7 @@
           <a:lstStyle/>
           <a:p>
             <a:pPr algn="ctr"/>
+            <a:endParaRPr/>
           </a:p>
         </p:txBody>
       </p:sp>
@@ -3290,8 +3321,16 @@
           </a:bodyPr>
           <a:lstStyle/>
           <a:p>
-            <a:r>
-              <a:t>1. Hiệu chuẩn Hệ thống (A/A Test)</a:t>
+            <a:pPr>
+              <a:defRPr sz="2600" b="1">
+                <a:solidFill>
+                  <a:srgbClr val="FFFFFF"/>
+                </a:solidFill>
+                <a:latin typeface="Segoe UI"/>
+              </a:defRPr>
+            </a:pPr>
+            <a:r>
+              <a:t>1. Tầm quan trọng của A/A Test</a:t>
             </a:r>
           </a:p>
         </p:txBody>
@@ -3318,8 +3357,16 @@
           </a:bodyPr>
           <a:lstStyle/>
           <a:p>
-            <a:r>
-              <a:t>Kết quả Mô phỏng</a:t>
+            <a:pPr>
+              <a:defRPr sz="1300">
+                <a:solidFill>
+                  <a:srgbClr val="FFB800"/>
+                </a:solidFill>
+                <a:latin typeface="Segoe UI"/>
+              </a:defRPr>
+            </a:pPr>
+            <a:r>
+              <a:t>Sanity Check Cốt lõi</a:t>
             </a:r>
           </a:p>
         </p:txBody>
@@ -3364,6 +3411,7 @@
           <a:lstStyle/>
           <a:p>
             <a:pPr algn="ctr"/>
+            <a:endParaRPr/>
           </a:p>
         </p:txBody>
       </p:sp>
@@ -3407,6 +3455,7 @@
           <a:lstStyle/>
           <a:p>
             <a:pPr algn="ctr"/>
+            <a:endParaRPr/>
           </a:p>
         </p:txBody>
       </p:sp>
@@ -3486,6 +3535,7 @@
           <a:lstStyle/>
           <a:p>
             <a:pPr algn="ctr"/>
+            <a:endParaRPr/>
           </a:p>
         </p:txBody>
       </p:sp>
@@ -3601,6 +3651,7 @@
           <a:lstStyle/>
           <a:p>
             <a:pPr algn="ctr"/>
+            <a:endParaRPr/>
           </a:p>
         </p:txBody>
       </p:sp>
@@ -3644,6 +3695,7 @@
           <a:lstStyle/>
           <a:p>
             <a:pPr algn="ctr"/>
+            <a:endParaRPr/>
           </a:p>
         </p:txBody>
       </p:sp>
@@ -3762,6 +3814,7 @@
           <a:lstStyle/>
           <a:p>
             <a:pPr algn="ctr"/>
+            <a:endParaRPr/>
           </a:p>
         </p:txBody>
       </p:sp>
@@ -3805,6 +3858,7 @@
           <a:lstStyle/>
           <a:p>
             <a:pPr algn="ctr"/>
+            <a:endParaRPr/>
           </a:p>
         </p:txBody>
       </p:sp>
@@ -3892,7 +3946,7 @@
 </file>
 
 <file path=ppt/slides/slide3.xml><?xml version="1.0" encoding="utf-8"?>
-<p:sld xmlns:a="http://schemas.openxmlformats.org/drawingml/2006/main" xmlns:p="http://schemas.openxmlformats.org/presentationml/2006/main" xmlns:r="http://schemas.openxmlformats.org/officeDocument/2006/relationships">
+<p:sld xmlns:a="http://schemas.openxmlformats.org/drawingml/2006/main" xmlns:r="http://schemas.openxmlformats.org/officeDocument/2006/relationships" xmlns:p="http://schemas.openxmlformats.org/presentationml/2006/main">
   <p:cSld>
     <p:bg>
       <p:bgPr>
@@ -3908,7 +3962,14 @@
         <p:cNvGrpSpPr/>
         <p:nvPr/>
       </p:nvGrpSpPr>
-      <p:grpSpPr/>
+      <p:grpSpPr>
+        <a:xfrm>
+          <a:off x="0" y="0"/>
+          <a:ext cx="0" cy="0"/>
+          <a:chOff x="0" y="0"/>
+          <a:chExt cx="0" cy="0"/>
+        </a:xfrm>
+      </p:grpSpPr>
       <p:sp>
         <p:nvSpPr>
           <p:cNvPr id="2" name="Rectangle 1"/>
@@ -3949,6 +4010,7 @@
           <a:lstStyle/>
           <a:p>
             <a:pPr algn="ctr"/>
+            <a:endParaRPr/>
           </a:p>
         </p:txBody>
       </p:sp>
@@ -3974,8 +4036,16 @@
           </a:bodyPr>
           <a:lstStyle/>
           <a:p>
-            <a:r>
-              <a:t>2. Kết quả A/B Test (OEC)</a:t>
+            <a:pPr>
+              <a:defRPr sz="2600" b="1">
+                <a:solidFill>
+                  <a:srgbClr val="FFFFFF"/>
+                </a:solidFill>
+                <a:latin typeface="Segoe UI"/>
+              </a:defRPr>
+            </a:pPr>
+            <a:r>
+              <a:t>2. Kiểm tra Covariate Balance</a:t>
             </a:r>
           </a:p>
         </p:txBody>
@@ -4002,8 +4072,16 @@
           </a:bodyPr>
           <a:lstStyle/>
           <a:p>
-            <a:r>
-              <a:t>Đánh giá Chiến dịch Voucher 15%</a:t>
+            <a:pPr>
+              <a:defRPr sz="1300">
+                <a:solidFill>
+                  <a:srgbClr val="FFB800"/>
+                </a:solidFill>
+                <a:latin typeface="Segoe UI"/>
+              </a:defRPr>
+            </a:pPr>
+            <a:r>
+              <a:t>Sự cân bằng của các Đặc tính</a:t>
             </a:r>
           </a:p>
         </p:txBody>
@@ -4048,6 +4126,7 @@
           <a:lstStyle/>
           <a:p>
             <a:pPr algn="ctr"/>
+            <a:endParaRPr/>
           </a:p>
         </p:txBody>
       </p:sp>
@@ -4091,6 +4170,7 @@
           <a:lstStyle/>
           <a:p>
             <a:pPr algn="ctr"/>
+            <a:endParaRPr/>
           </a:p>
         </p:txBody>
       </p:sp>
@@ -4170,6 +4250,7 @@
           <a:lstStyle/>
           <a:p>
             <a:pPr algn="ctr"/>
+            <a:endParaRPr/>
           </a:p>
         </p:txBody>
       </p:sp>
@@ -4285,6 +4366,7 @@
           <a:lstStyle/>
           <a:p>
             <a:pPr algn="ctr"/>
+            <a:endParaRPr/>
           </a:p>
         </p:txBody>
       </p:sp>
@@ -4328,6 +4410,7 @@
           <a:lstStyle/>
           <a:p>
             <a:pPr algn="ctr"/>
+            <a:endParaRPr/>
           </a:p>
         </p:txBody>
       </p:sp>
@@ -4446,6 +4529,7 @@
           <a:lstStyle/>
           <a:p>
             <a:pPr algn="ctr"/>
+            <a:endParaRPr/>
           </a:p>
         </p:txBody>
       </p:sp>
@@ -4489,6 +4573,7 @@
           <a:lstStyle/>
           <a:p>
             <a:pPr algn="ctr"/>
+            <a:endParaRPr/>
           </a:p>
         </p:txBody>
       </p:sp>
@@ -4600,7 +4685,7 @@
 </file>
 
 <file path=ppt/slides/slide4.xml><?xml version="1.0" encoding="utf-8"?>
-<p:sld xmlns:a="http://schemas.openxmlformats.org/drawingml/2006/main" xmlns:p="http://schemas.openxmlformats.org/presentationml/2006/main" xmlns:r="http://schemas.openxmlformats.org/officeDocument/2006/relationships">
+<p:sld xmlns:a="http://schemas.openxmlformats.org/drawingml/2006/main" xmlns:r="http://schemas.openxmlformats.org/officeDocument/2006/relationships" xmlns:p="http://schemas.openxmlformats.org/presentationml/2006/main">
   <p:cSld>
     <p:bg>
       <p:bgPr>
@@ -4616,7 +4701,14 @@
         <p:cNvGrpSpPr/>
         <p:nvPr/>
       </p:nvGrpSpPr>
-      <p:grpSpPr/>
+      <p:grpSpPr>
+        <a:xfrm>
+          <a:off x="0" y="0"/>
+          <a:ext cx="0" cy="0"/>
+          <a:chOff x="0" y="0"/>
+          <a:chExt cx="0" cy="0"/>
+        </a:xfrm>
+      </p:grpSpPr>
       <p:sp>
         <p:nvSpPr>
           <p:cNvPr id="2" name="Rectangle 1"/>
@@ -4657,6 +4749,7 @@
           <a:lstStyle/>
           <a:p>
             <a:pPr algn="ctr"/>
+            <a:endParaRPr/>
           </a:p>
         </p:txBody>
       </p:sp>
@@ -4682,8 +4775,16 @@
           </a:bodyPr>
           <a:lstStyle/>
           <a:p>
-            <a:r>
-              <a:t>3. ROI Theo Phân Khúc K-Means</a:t>
+            <a:pPr>
+              <a:defRPr sz="2600" b="1">
+                <a:solidFill>
+                  <a:srgbClr val="FFFFFF"/>
+                </a:solidFill>
+                <a:latin typeface="Segoe UI"/>
+              </a:defRPr>
+            </a:pPr>
+            <a:r>
+              <a:t>3. Kháng lỗi Dương tính giả (False Positives)</a:t>
             </a:r>
           </a:p>
         </p:txBody>
@@ -4710,8 +4811,16 @@
           </a:bodyPr>
           <a:lstStyle/>
           <a:p>
-            <a:r>
-              <a:t>Tìm kiếm Sweet Spot</a:t>
+            <a:pPr>
+              <a:defRPr sz="1300">
+                <a:solidFill>
+                  <a:srgbClr val="FFB800"/>
+                </a:solidFill>
+                <a:latin typeface="Segoe UI"/>
+              </a:defRPr>
+            </a:pPr>
+            <a:r>
+              <a:t>Mô phỏng Monte Carlo</a:t>
             </a:r>
           </a:p>
         </p:txBody>
@@ -4756,6 +4865,7 @@
           <a:lstStyle/>
           <a:p>
             <a:pPr algn="ctr"/>
+            <a:endParaRPr/>
           </a:p>
         </p:txBody>
       </p:sp>
@@ -4799,6 +4909,7 @@
           <a:lstStyle/>
           <a:p>
             <a:pPr algn="ctr"/>
+            <a:endParaRPr/>
           </a:p>
         </p:txBody>
       </p:sp>
@@ -4878,6 +4989,7 @@
           <a:lstStyle/>
           <a:p>
             <a:pPr algn="ctr"/>
+            <a:endParaRPr/>
           </a:p>
         </p:txBody>
       </p:sp>
@@ -4993,6 +5105,7 @@
           <a:lstStyle/>
           <a:p>
             <a:pPr algn="ctr"/>
+            <a:endParaRPr/>
           </a:p>
         </p:txBody>
       </p:sp>
@@ -5036,6 +5149,7 @@
           <a:lstStyle/>
           <a:p>
             <a:pPr algn="ctr"/>
+            <a:endParaRPr/>
           </a:p>
         </p:txBody>
       </p:sp>
@@ -5154,6 +5268,7 @@
           <a:lstStyle/>
           <a:p>
             <a:pPr algn="ctr"/>
+            <a:endParaRPr/>
           </a:p>
         </p:txBody>
       </p:sp>
@@ -5197,6 +5312,7 @@
           <a:lstStyle/>
           <a:p>
             <a:pPr algn="ctr"/>
+            <a:endParaRPr/>
           </a:p>
         </p:txBody>
       </p:sp>
@@ -5273,23 +5389,22 @@
 </file>
 
 <file path=ppt/slides/slide5.xml><?xml version="1.0" encoding="utf-8"?>
-<p:sld xmlns:a="http://schemas.openxmlformats.org/drawingml/2006/main" xmlns:p="http://schemas.openxmlformats.org/presentationml/2006/main" xmlns:r="http://schemas.openxmlformats.org/officeDocument/2006/relationships">
+<p:sld xmlns:a="http://schemas.openxmlformats.org/drawingml/2006/main" xmlns:r="http://schemas.openxmlformats.org/officeDocument/2006/relationships" xmlns:p="http://schemas.openxmlformats.org/presentationml/2006/main">
   <p:cSld>
-    <p:bg>
-      <p:bgPr>
-        <a:solidFill>
-          <a:srgbClr val="0B1320"/>
-        </a:solidFill>
-        <a:effectLst/>
-      </p:bgPr>
-    </p:bg>
     <p:spTree>
       <p:nvGrpSpPr>
         <p:cNvPr id="1" name=""/>
         <p:cNvGrpSpPr/>
         <p:nvPr/>
       </p:nvGrpSpPr>
-      <p:grpSpPr/>
+      <p:grpSpPr>
+        <a:xfrm>
+          <a:off x="0" y="0"/>
+          <a:ext cx="0" cy="0"/>
+          <a:chOff x="0" y="0"/>
+          <a:chExt cx="0" cy="0"/>
+        </a:xfrm>
+      </p:grpSpPr>
       <p:sp>
         <p:nvSpPr>
           <p:cNvPr id="2" name="Rectangle 1"/>
@@ -5330,6 +5445,7 @@
           <a:lstStyle/>
           <a:p>
             <a:pPr algn="ctr"/>
+            <a:endParaRPr/>
           </a:p>
         </p:txBody>
       </p:sp>
@@ -5355,8 +5471,16 @@
           </a:bodyPr>
           <a:lstStyle/>
           <a:p>
-            <a:r>
-              <a:t>4. Kết luận &amp; Điểm yếu của K-Means</a:t>
+            <a:pPr>
+              <a:defRPr sz="2600" b="1">
+                <a:solidFill>
+                  <a:srgbClr val="FFFFFF"/>
+                </a:solidFill>
+                <a:latin typeface="Segoe UI"/>
+              </a:defRPr>
+            </a:pPr>
+            <a:r>
+              <a:t>1. Nền tảng Thống kê (Frequentist Testing)</a:t>
             </a:r>
           </a:p>
         </p:txBody>
@@ -5383,8 +5507,16 @@
           </a:bodyPr>
           <a:lstStyle/>
           <a:p>
-            <a:r>
-              <a:t>Bài học Cốt lõi</a:t>
+            <a:pPr>
+              <a:defRPr sz="1300">
+                <a:solidFill>
+                  <a:srgbClr val="FFB800"/>
+                </a:solidFill>
+                <a:latin typeface="Segoe UI"/>
+              </a:defRPr>
+            </a:pPr>
+            <a:r>
+              <a:t>Kiểm định Giả thuyết</a:t>
             </a:r>
           </a:p>
         </p:txBody>
@@ -5429,6 +5561,7 @@
           <a:lstStyle/>
           <a:p>
             <a:pPr algn="ctr"/>
+            <a:endParaRPr/>
           </a:p>
         </p:txBody>
       </p:sp>
@@ -5472,6 +5605,7 @@
           <a:lstStyle/>
           <a:p>
             <a:pPr algn="ctr"/>
+            <a:endParaRPr/>
           </a:p>
         </p:txBody>
       </p:sp>
@@ -5551,6 +5685,7 @@
           <a:lstStyle/>
           <a:p>
             <a:pPr algn="ctr"/>
+            <a:endParaRPr/>
           </a:p>
         </p:txBody>
       </p:sp>
@@ -5621,7 +5756,7 @@
               </a:defRPr>
             </a:pPr>
             <a:r>
-              <a:t>04 / 04</a:t>
+              <a:t>01 / 05</a:t>
             </a:r>
           </a:p>
         </p:txBody>
@@ -5666,6 +5801,7 @@
           <a:lstStyle/>
           <a:p>
             <a:pPr algn="ctr"/>
+            <a:endParaRPr/>
           </a:p>
         </p:txBody>
       </p:sp>
@@ -5709,6 +5845,7 @@
           <a:lstStyle/>
           <a:p>
             <a:pPr algn="ctr"/>
+            <a:endParaRPr/>
           </a:p>
         </p:txBody>
       </p:sp>
@@ -5743,7 +5880,7 @@
               </a:defRPr>
             </a:pPr>
             <a:r>
-              <a:t>P-value Uniformity</a:t>
+              <a:t>Giả thuyết Không (H0)</a:t>
             </a:r>
           </a:p>
         </p:txBody>
@@ -5782,7 +5919,7 @@
               </a:defRPr>
             </a:pPr>
             <a:r>
-              <a:t>• Giá trị P-value trải dài đều đặn (Uniform Distribution), chứng tỏ hệ thống đo lường không bị lệch (Bias).</a:t>
+              <a:t>• Giả định rằng Voucher không tạo ra sự khác biệt nào giữa 2 nhóm (Tác động = 0).</a:t>
             </a:r>
           </a:p>
         </p:txBody>
@@ -5827,6 +5964,751 @@
           <a:lstStyle/>
           <a:p>
             <a:pPr algn="ctr"/>
+            <a:endParaRPr/>
+          </a:p>
+        </p:txBody>
+      </p:sp>
+      <p:sp>
+        <p:nvSpPr>
+          <p:cNvPr id="16" name="Rectangle 15"/>
+          <p:cNvSpPr/>
+          <p:nvPr/>
+        </p:nvSpPr>
+        <p:spPr>
+          <a:xfrm>
+            <a:off x="4983480" y="2194560"/>
+            <a:ext cx="3749040" cy="36576"/>
+          </a:xfrm>
+          <a:prstGeom prst="rect">
+            <a:avLst/>
+          </a:prstGeom>
+          <a:solidFill>
+            <a:srgbClr val="38BDF8"/>
+          </a:solidFill>
+          <a:ln>
+            <a:noFill/>
+          </a:ln>
+        </p:spPr>
+        <p:style>
+          <a:lnRef idx="1">
+            <a:schemeClr val="accent1"/>
+          </a:lnRef>
+          <a:fillRef idx="3">
+            <a:schemeClr val="accent1"/>
+          </a:fillRef>
+          <a:effectRef idx="2">
+            <a:schemeClr val="accent1"/>
+          </a:effectRef>
+          <a:fontRef idx="minor">
+            <a:schemeClr val="lt1"/>
+          </a:fontRef>
+        </p:style>
+        <p:txBody>
+          <a:bodyPr rtlCol="0" anchor="ctr"/>
+          <a:lstStyle/>
+          <a:p>
+            <a:pPr algn="ctr"/>
+            <a:endParaRPr/>
+          </a:p>
+        </p:txBody>
+      </p:sp>
+      <p:sp>
+        <p:nvSpPr>
+          <p:cNvPr id="17" name="TextBox 16"/>
+          <p:cNvSpPr txBox="1"/>
+          <p:nvPr/>
+        </p:nvSpPr>
+        <p:spPr>
+          <a:xfrm>
+            <a:off x="4892040" y="1691640"/>
+            <a:ext cx="3931920" cy="502920"/>
+          </a:xfrm>
+          <a:prstGeom prst="rect">
+            <a:avLst/>
+          </a:prstGeom>
+          <a:noFill/>
+        </p:spPr>
+        <p:txBody>
+          <a:bodyPr wrap="square">
+            <a:spAutoFit/>
+          </a:bodyPr>
+          <a:lstStyle/>
+          <a:p>
+            <a:pPr>
+              <a:defRPr sz="1600" b="1">
+                <a:solidFill>
+                  <a:srgbClr val="38BDF8"/>
+                </a:solidFill>
+                <a:latin typeface="Segoe UI"/>
+              </a:defRPr>
+            </a:pPr>
+            <a:r>
+              <a:t>P-value</a:t>
+            </a:r>
+          </a:p>
+        </p:txBody>
+      </p:sp>
+      <p:sp>
+        <p:nvSpPr>
+          <p:cNvPr id="18" name="TextBox 17"/>
+          <p:cNvSpPr txBox="1"/>
+          <p:nvPr/>
+        </p:nvSpPr>
+        <p:spPr>
+          <a:xfrm>
+            <a:off x="4892040" y="2286000"/>
+            <a:ext cx="3931920" cy="3383280"/>
+          </a:xfrm>
+          <a:prstGeom prst="rect">
+            <a:avLst/>
+          </a:prstGeom>
+          <a:noFill/>
+        </p:spPr>
+        <p:txBody>
+          <a:bodyPr wrap="square">
+            <a:spAutoFit/>
+          </a:bodyPr>
+          <a:lstStyle/>
+          <a:p>
+            <a:pPr>
+              <a:spcAft>
+                <a:spcPts val="600"/>
+              </a:spcAft>
+              <a:defRPr sz="1500">
+                <a:solidFill>
+                  <a:srgbClr val="FFFFFF"/>
+                </a:solidFill>
+                <a:latin typeface="Segoe UI"/>
+              </a:defRPr>
+            </a:pPr>
+            <a:r>
+              <a:t>• Đại diện cho xác suất thu được chênh lệch do ngẫu nhiên.</a:t>
+            </a:r>
+          </a:p>
+          <a:p>
+            <a:pPr>
+              <a:spcAft>
+                <a:spcPts val="600"/>
+              </a:spcAft>
+              <a:defRPr sz="1500">
+                <a:solidFill>
+                  <a:srgbClr val="FFFFFF"/>
+                </a:solidFill>
+                <a:latin typeface="Segoe UI"/>
+              </a:defRPr>
+            </a:pPr>
+            <a:r>
+              <a:t>• Ngưỡng Alpha = 0.05 là tiêu chuẩn để bác bỏ H0.</a:t>
+            </a:r>
+          </a:p>
+        </p:txBody>
+      </p:sp>
+    </p:spTree>
+    <p:extLst>
+      <p:ext uri="{BB962C8B-B14F-4D97-AF65-F5344CB8AC3E}">
+        <p14:creationId xmlns:p14="http://schemas.microsoft.com/office/powerpoint/2010/main" val="1135580762"/>
+      </p:ext>
+    </p:extLst>
+  </p:cSld>
+  <p:clrMapOvr>
+    <a:masterClrMapping/>
+  </p:clrMapOvr>
+</p:sld>
+</file>
+
+<file path=ppt/slides/slide6.xml><?xml version="1.0" encoding="utf-8"?>
+<p:sld xmlns:a="http://schemas.openxmlformats.org/drawingml/2006/main" xmlns:r="http://schemas.openxmlformats.org/officeDocument/2006/relationships" xmlns:p="http://schemas.openxmlformats.org/presentationml/2006/main">
+  <p:cSld>
+    <p:spTree>
+      <p:nvGrpSpPr>
+        <p:cNvPr id="1" name=""/>
+        <p:cNvGrpSpPr/>
+        <p:nvPr/>
+      </p:nvGrpSpPr>
+      <p:grpSpPr>
+        <a:xfrm>
+          <a:off x="0" y="0"/>
+          <a:ext cx="0" cy="0"/>
+          <a:chOff x="0" y="0"/>
+          <a:chExt cx="0" cy="0"/>
+        </a:xfrm>
+      </p:grpSpPr>
+      <p:sp>
+        <p:nvSpPr>
+          <p:cNvPr id="2" name="Rectangle 1"/>
+          <p:cNvSpPr/>
+          <p:nvPr/>
+        </p:nvSpPr>
+        <p:spPr>
+          <a:xfrm>
+            <a:off x="365760" y="0"/>
+            <a:ext cx="137160" cy="6858000"/>
+          </a:xfrm>
+          <a:prstGeom prst="rect">
+            <a:avLst/>
+          </a:prstGeom>
+          <a:solidFill>
+            <a:srgbClr val="FFB800"/>
+          </a:solidFill>
+          <a:ln>
+            <a:noFill/>
+          </a:ln>
+        </p:spPr>
+        <p:style>
+          <a:lnRef idx="1">
+            <a:schemeClr val="accent1"/>
+          </a:lnRef>
+          <a:fillRef idx="3">
+            <a:schemeClr val="accent1"/>
+          </a:fillRef>
+          <a:effectRef idx="2">
+            <a:schemeClr val="accent1"/>
+          </a:effectRef>
+          <a:fontRef idx="minor">
+            <a:schemeClr val="lt1"/>
+          </a:fontRef>
+        </p:style>
+        <p:txBody>
+          <a:bodyPr rtlCol="0" anchor="ctr"/>
+          <a:lstStyle/>
+          <a:p>
+            <a:pPr algn="ctr"/>
+            <a:endParaRPr/>
+          </a:p>
+        </p:txBody>
+      </p:sp>
+      <p:sp>
+        <p:nvSpPr>
+          <p:cNvPr id="3" name="TextBox 2"/>
+          <p:cNvSpPr txBox="1"/>
+          <p:nvPr/>
+        </p:nvSpPr>
+        <p:spPr>
+          <a:xfrm>
+            <a:off x="640080" y="182880"/>
+            <a:ext cx="7772400" cy="731520"/>
+          </a:xfrm>
+          <a:prstGeom prst="rect">
+            <a:avLst/>
+          </a:prstGeom>
+          <a:noFill/>
+        </p:spPr>
+        <p:txBody>
+          <a:bodyPr wrap="none">
+            <a:spAutoFit/>
+          </a:bodyPr>
+          <a:lstStyle/>
+          <a:p>
+            <a:pPr>
+              <a:defRPr sz="2600" b="1">
+                <a:solidFill>
+                  <a:srgbClr val="FFFFFF"/>
+                </a:solidFill>
+                <a:latin typeface="Segoe UI"/>
+              </a:defRPr>
+            </a:pPr>
+            <a:r>
+              <a:t>2. Hai Tiêu chí Đánh giá Độc lập</a:t>
+            </a:r>
+          </a:p>
+        </p:txBody>
+      </p:sp>
+      <p:sp>
+        <p:nvSpPr>
+          <p:cNvPr id="4" name="TextBox 3"/>
+          <p:cNvSpPr txBox="1"/>
+          <p:nvPr/>
+        </p:nvSpPr>
+        <p:spPr>
+          <a:xfrm>
+            <a:off x="640080" y="731520"/>
+            <a:ext cx="7772400" cy="365760"/>
+          </a:xfrm>
+          <a:prstGeom prst="rect">
+            <a:avLst/>
+          </a:prstGeom>
+          <a:noFill/>
+        </p:spPr>
+        <p:txBody>
+          <a:bodyPr wrap="none">
+            <a:spAutoFit/>
+          </a:bodyPr>
+          <a:lstStyle/>
+          <a:p>
+            <a:pPr>
+              <a:defRPr sz="1300">
+                <a:solidFill>
+                  <a:srgbClr val="FFB800"/>
+                </a:solidFill>
+                <a:latin typeface="Segoe UI"/>
+              </a:defRPr>
+            </a:pPr>
+            <a:r>
+              <a:t>Sanity vs OEC</a:t>
+            </a:r>
+          </a:p>
+        </p:txBody>
+      </p:sp>
+      <p:sp>
+        <p:nvSpPr>
+          <p:cNvPr id="5" name="Rectangle 4"/>
+          <p:cNvSpPr/>
+          <p:nvPr/>
+        </p:nvSpPr>
+        <p:spPr>
+          <a:xfrm>
+            <a:off x="640080" y="1188720"/>
+            <a:ext cx="2286000" cy="36576"/>
+          </a:xfrm>
+          <a:prstGeom prst="rect">
+            <a:avLst/>
+          </a:prstGeom>
+          <a:solidFill>
+            <a:srgbClr val="FFB800"/>
+          </a:solidFill>
+          <a:ln>
+            <a:noFill/>
+          </a:ln>
+        </p:spPr>
+        <p:style>
+          <a:lnRef idx="1">
+            <a:schemeClr val="accent1"/>
+          </a:lnRef>
+          <a:fillRef idx="3">
+            <a:schemeClr val="accent1"/>
+          </a:fillRef>
+          <a:effectRef idx="2">
+            <a:schemeClr val="accent1"/>
+          </a:effectRef>
+          <a:fontRef idx="minor">
+            <a:schemeClr val="lt1"/>
+          </a:fontRef>
+        </p:style>
+        <p:txBody>
+          <a:bodyPr rtlCol="0" anchor="ctr"/>
+          <a:lstStyle/>
+          <a:p>
+            <a:pPr algn="ctr"/>
+            <a:endParaRPr/>
+          </a:p>
+        </p:txBody>
+      </p:sp>
+      <p:sp>
+        <p:nvSpPr>
+          <p:cNvPr id="6" name="Rectangle 5"/>
+          <p:cNvSpPr/>
+          <p:nvPr/>
+        </p:nvSpPr>
+        <p:spPr>
+          <a:xfrm>
+            <a:off x="365760" y="6217920"/>
+            <a:ext cx="8778240" cy="365760"/>
+          </a:xfrm>
+          <a:prstGeom prst="rect">
+            <a:avLst/>
+          </a:prstGeom>
+          <a:solidFill>
+            <a:srgbClr val="1C4E80"/>
+          </a:solidFill>
+          <a:ln>
+            <a:noFill/>
+          </a:ln>
+        </p:spPr>
+        <p:style>
+          <a:lnRef idx="1">
+            <a:schemeClr val="accent1"/>
+          </a:lnRef>
+          <a:fillRef idx="3">
+            <a:schemeClr val="accent1"/>
+          </a:fillRef>
+          <a:effectRef idx="2">
+            <a:schemeClr val="accent1"/>
+          </a:effectRef>
+          <a:fontRef idx="minor">
+            <a:schemeClr val="lt1"/>
+          </a:fontRef>
+        </p:style>
+        <p:txBody>
+          <a:bodyPr rtlCol="0" anchor="ctr"/>
+          <a:lstStyle/>
+          <a:p>
+            <a:pPr algn="ctr"/>
+            <a:endParaRPr/>
+          </a:p>
+        </p:txBody>
+      </p:sp>
+      <p:sp>
+        <p:nvSpPr>
+          <p:cNvPr id="7" name="TextBox 6"/>
+          <p:cNvSpPr txBox="1"/>
+          <p:nvPr/>
+        </p:nvSpPr>
+        <p:spPr>
+          <a:xfrm>
+            <a:off x="457200" y="6217920"/>
+            <a:ext cx="7315200" cy="365760"/>
+          </a:xfrm>
+          <a:prstGeom prst="rect">
+            <a:avLst/>
+          </a:prstGeom>
+          <a:noFill/>
+        </p:spPr>
+        <p:txBody>
+          <a:bodyPr wrap="none" anchor="ctr">
+            <a:spAutoFit/>
+          </a:bodyPr>
+          <a:lstStyle/>
+          <a:p>
+            <a:pPr>
+              <a:defRPr sz="1000">
+                <a:solidFill>
+                  <a:srgbClr val="FFFFFF"/>
+                </a:solidFill>
+                <a:latin typeface="Segoe UI"/>
+              </a:defRPr>
+            </a:pPr>
+            <a:r>
+              <a:t>GSM Promotion Experimentation • Báo cáo Chuyên môn • Data Science Team</a:t>
+            </a:r>
+          </a:p>
+        </p:txBody>
+      </p:sp>
+      <p:sp>
+        <p:nvSpPr>
+          <p:cNvPr id="8" name="Rectangle 7"/>
+          <p:cNvSpPr/>
+          <p:nvPr/>
+        </p:nvSpPr>
+        <p:spPr>
+          <a:xfrm>
+            <a:off x="365760" y="6583680"/>
+            <a:ext cx="8778240" cy="274320"/>
+          </a:xfrm>
+          <a:prstGeom prst="rect">
+            <a:avLst/>
+          </a:prstGeom>
+          <a:solidFill>
+            <a:srgbClr val="070D17"/>
+          </a:solidFill>
+          <a:ln>
+            <a:noFill/>
+          </a:ln>
+        </p:spPr>
+        <p:style>
+          <a:lnRef idx="1">
+            <a:schemeClr val="accent1"/>
+          </a:lnRef>
+          <a:fillRef idx="3">
+            <a:schemeClr val="accent1"/>
+          </a:fillRef>
+          <a:effectRef idx="2">
+            <a:schemeClr val="accent1"/>
+          </a:effectRef>
+          <a:fontRef idx="minor">
+            <a:schemeClr val="lt1"/>
+          </a:fontRef>
+        </p:style>
+        <p:txBody>
+          <a:bodyPr rtlCol="0" anchor="ctr"/>
+          <a:lstStyle/>
+          <a:p>
+            <a:pPr algn="ctr"/>
+            <a:endParaRPr/>
+          </a:p>
+        </p:txBody>
+      </p:sp>
+      <p:sp>
+        <p:nvSpPr>
+          <p:cNvPr id="9" name="TextBox 8"/>
+          <p:cNvSpPr txBox="1"/>
+          <p:nvPr/>
+        </p:nvSpPr>
+        <p:spPr>
+          <a:xfrm>
+            <a:off x="457200" y="6583680"/>
+            <a:ext cx="4572000" cy="274320"/>
+          </a:xfrm>
+          <a:prstGeom prst="rect">
+            <a:avLst/>
+          </a:prstGeom>
+          <a:noFill/>
+        </p:spPr>
+        <p:txBody>
+          <a:bodyPr wrap="none" anchor="ctr">
+            <a:spAutoFit/>
+          </a:bodyPr>
+          <a:lstStyle/>
+          <a:p>
+            <a:pPr>
+              <a:defRPr sz="900">
+                <a:solidFill>
+                  <a:srgbClr val="38BDF8"/>
+                </a:solidFill>
+                <a:latin typeface="Segoe UI"/>
+              </a:defRPr>
+            </a:pPr>
+            <a:r>
+              <a:t>Project: Uplift Modeling &amp; Causal Inference</a:t>
+            </a:r>
+          </a:p>
+        </p:txBody>
+      </p:sp>
+      <p:sp>
+        <p:nvSpPr>
+          <p:cNvPr id="10" name="TextBox 9"/>
+          <p:cNvSpPr txBox="1"/>
+          <p:nvPr/>
+        </p:nvSpPr>
+        <p:spPr>
+          <a:xfrm>
+            <a:off x="7772400" y="6583680"/>
+            <a:ext cx="1280160" cy="274320"/>
+          </a:xfrm>
+          <a:prstGeom prst="rect">
+            <a:avLst/>
+          </a:prstGeom>
+          <a:noFill/>
+        </p:spPr>
+        <p:txBody>
+          <a:bodyPr wrap="none" anchor="ctr">
+            <a:spAutoFit/>
+          </a:bodyPr>
+          <a:lstStyle/>
+          <a:p>
+            <a:pPr algn="r">
+              <a:defRPr sz="900" b="1">
+                <a:solidFill>
+                  <a:srgbClr val="FFFFFF"/>
+                </a:solidFill>
+                <a:latin typeface="Segoe UI"/>
+              </a:defRPr>
+            </a:pPr>
+            <a:r>
+              <a:t>02 / 05</a:t>
+            </a:r>
+          </a:p>
+        </p:txBody>
+      </p:sp>
+      <p:sp>
+        <p:nvSpPr>
+          <p:cNvPr id="11" name="Rounded Rectangle 10"/>
+          <p:cNvSpPr/>
+          <p:nvPr/>
+        </p:nvSpPr>
+        <p:spPr>
+          <a:xfrm>
+            <a:off x="640080" y="1645920"/>
+            <a:ext cx="4023360" cy="4114800"/>
+          </a:xfrm>
+          <a:prstGeom prst="roundRect">
+            <a:avLst/>
+          </a:prstGeom>
+          <a:solidFill>
+            <a:srgbClr val="172545"/>
+          </a:solidFill>
+          <a:ln>
+            <a:noFill/>
+          </a:ln>
+        </p:spPr>
+        <p:style>
+          <a:lnRef idx="1">
+            <a:schemeClr val="accent1"/>
+          </a:lnRef>
+          <a:fillRef idx="3">
+            <a:schemeClr val="accent1"/>
+          </a:fillRef>
+          <a:effectRef idx="2">
+            <a:schemeClr val="accent1"/>
+          </a:effectRef>
+          <a:fontRef idx="minor">
+            <a:schemeClr val="lt1"/>
+          </a:fontRef>
+        </p:style>
+        <p:txBody>
+          <a:bodyPr rtlCol="0" anchor="ctr"/>
+          <a:lstStyle/>
+          <a:p>
+            <a:pPr algn="ctr"/>
+            <a:endParaRPr/>
+          </a:p>
+        </p:txBody>
+      </p:sp>
+      <p:sp>
+        <p:nvSpPr>
+          <p:cNvPr id="12" name="Rectangle 11"/>
+          <p:cNvSpPr/>
+          <p:nvPr/>
+        </p:nvSpPr>
+        <p:spPr>
+          <a:xfrm>
+            <a:off x="777240" y="2194560"/>
+            <a:ext cx="3749040" cy="36576"/>
+          </a:xfrm>
+          <a:prstGeom prst="rect">
+            <a:avLst/>
+          </a:prstGeom>
+          <a:solidFill>
+            <a:srgbClr val="F472B6"/>
+          </a:solidFill>
+          <a:ln>
+            <a:noFill/>
+          </a:ln>
+        </p:spPr>
+        <p:style>
+          <a:lnRef idx="1">
+            <a:schemeClr val="accent1"/>
+          </a:lnRef>
+          <a:fillRef idx="3">
+            <a:schemeClr val="accent1"/>
+          </a:fillRef>
+          <a:effectRef idx="2">
+            <a:schemeClr val="accent1"/>
+          </a:effectRef>
+          <a:fontRef idx="minor">
+            <a:schemeClr val="lt1"/>
+          </a:fontRef>
+        </p:style>
+        <p:txBody>
+          <a:bodyPr rtlCol="0" anchor="ctr"/>
+          <a:lstStyle/>
+          <a:p>
+            <a:pPr algn="ctr"/>
+            <a:endParaRPr/>
+          </a:p>
+        </p:txBody>
+      </p:sp>
+      <p:sp>
+        <p:nvSpPr>
+          <p:cNvPr id="13" name="TextBox 12"/>
+          <p:cNvSpPr txBox="1"/>
+          <p:nvPr/>
+        </p:nvSpPr>
+        <p:spPr>
+          <a:xfrm>
+            <a:off x="685800" y="1691640"/>
+            <a:ext cx="3931920" cy="502920"/>
+          </a:xfrm>
+          <a:prstGeom prst="rect">
+            <a:avLst/>
+          </a:prstGeom>
+          <a:noFill/>
+        </p:spPr>
+        <p:txBody>
+          <a:bodyPr wrap="square">
+            <a:spAutoFit/>
+          </a:bodyPr>
+          <a:lstStyle/>
+          <a:p>
+            <a:pPr>
+              <a:defRPr sz="1600" b="1">
+                <a:solidFill>
+                  <a:srgbClr val="F472B6"/>
+                </a:solidFill>
+                <a:latin typeface="Segoe UI"/>
+              </a:defRPr>
+            </a:pPr>
+            <a:r>
+              <a:t>Sanity Checks</a:t>
+            </a:r>
+          </a:p>
+        </p:txBody>
+      </p:sp>
+      <p:sp>
+        <p:nvSpPr>
+          <p:cNvPr id="14" name="TextBox 13"/>
+          <p:cNvSpPr txBox="1"/>
+          <p:nvPr/>
+        </p:nvSpPr>
+        <p:spPr>
+          <a:xfrm>
+            <a:off x="685800" y="2286000"/>
+            <a:ext cx="3931920" cy="3383280"/>
+          </a:xfrm>
+          <a:prstGeom prst="rect">
+            <a:avLst/>
+          </a:prstGeom>
+          <a:noFill/>
+        </p:spPr>
+        <p:txBody>
+          <a:bodyPr wrap="square">
+            <a:spAutoFit/>
+          </a:bodyPr>
+          <a:lstStyle/>
+          <a:p>
+            <a:pPr>
+              <a:spcAft>
+                <a:spcPts val="600"/>
+              </a:spcAft>
+              <a:defRPr sz="1500">
+                <a:solidFill>
+                  <a:srgbClr val="FFFFFF"/>
+                </a:solidFill>
+                <a:latin typeface="Segoe UI"/>
+              </a:defRPr>
+            </a:pPr>
+            <a:r>
+              <a:t>• Kiểm tra độ cân bằng hệ thống (Sample Ratio, Covariates).</a:t>
+            </a:r>
+          </a:p>
+          <a:p>
+            <a:pPr>
+              <a:spcAft>
+                <a:spcPts val="600"/>
+              </a:spcAft>
+              <a:defRPr sz="1500">
+                <a:solidFill>
+                  <a:srgbClr val="FFFFFF"/>
+                </a:solidFill>
+                <a:latin typeface="Segoe UI"/>
+              </a:defRPr>
+            </a:pPr>
+            <a:r>
+              <a:t>• Kỳ vọng P-value &gt; 0.05 (Không bác bỏ H0) để chứng minh hệ thống không bị lệch.</a:t>
+            </a:r>
+          </a:p>
+        </p:txBody>
+      </p:sp>
+      <p:sp>
+        <p:nvSpPr>
+          <p:cNvPr id="15" name="Rounded Rectangle 14"/>
+          <p:cNvSpPr/>
+          <p:nvPr/>
+        </p:nvSpPr>
+        <p:spPr>
+          <a:xfrm>
+            <a:off x="4846320" y="1645920"/>
+            <a:ext cx="4023360" cy="4114800"/>
+          </a:xfrm>
+          <a:prstGeom prst="roundRect">
+            <a:avLst/>
+          </a:prstGeom>
+          <a:solidFill>
+            <a:srgbClr val="172545"/>
+          </a:solidFill>
+          <a:ln>
+            <a:noFill/>
+          </a:ln>
+        </p:spPr>
+        <p:style>
+          <a:lnRef idx="1">
+            <a:schemeClr val="accent1"/>
+          </a:lnRef>
+          <a:fillRef idx="3">
+            <a:schemeClr val="accent1"/>
+          </a:fillRef>
+          <a:effectRef idx="2">
+            <a:schemeClr val="accent1"/>
+          </a:effectRef>
+          <a:fontRef idx="minor">
+            <a:schemeClr val="lt1"/>
+          </a:fontRef>
+        </p:style>
+        <p:txBody>
+          <a:bodyPr rtlCol="0" anchor="ctr"/>
+          <a:lstStyle/>
+          <a:p>
+            <a:pPr algn="ctr"/>
+            <a:endParaRPr/>
           </a:p>
         </p:txBody>
       </p:sp>
@@ -5870,6 +6752,7 @@
           <a:lstStyle/>
           <a:p>
             <a:pPr algn="ctr"/>
+            <a:endParaRPr/>
           </a:p>
         </p:txBody>
       </p:sp>
@@ -5904,7 +6787,7 @@
               </a:defRPr>
             </a:pPr>
             <a:r>
-              <a:t>Green Light</a:t>
+              <a:t>OEC Evaluation</a:t>
             </a:r>
           </a:p>
         </p:txBody>
@@ -5943,12 +6826,2241 @@
               </a:defRPr>
             </a:pPr>
             <a:r>
-              <a:t>• Nền tảng đạt chuẩn quốc tế, hoàn toàn đủ tin cậy để triển khai các chiến dịch A/B Test tốn hàng tỷ đồng.</a:t>
+              <a:t>• Đo lường tác động lên chỉ số cốt lõi (Incremental Rides).</a:t>
+            </a:r>
+          </a:p>
+          <a:p>
+            <a:pPr>
+              <a:spcAft>
+                <a:spcPts val="600"/>
+              </a:spcAft>
+              <a:defRPr sz="1500">
+                <a:solidFill>
+                  <a:srgbClr val="FFFFFF"/>
+                </a:solidFill>
+                <a:latin typeface="Segoe UI"/>
+              </a:defRPr>
+            </a:pPr>
+            <a:r>
+              <a:t>• Kỳ vọng P-value &lt; 0.05 (Bác bỏ H0) để chứng minh Voucher có hiệu quả.</a:t>
             </a:r>
           </a:p>
         </p:txBody>
       </p:sp>
     </p:spTree>
+    <p:extLst>
+      <p:ext uri="{BB962C8B-B14F-4D97-AF65-F5344CB8AC3E}">
+        <p14:creationId xmlns:p14="http://schemas.microsoft.com/office/powerpoint/2010/main" val="1035731957"/>
+      </p:ext>
+    </p:extLst>
+  </p:cSld>
+  <p:clrMapOvr>
+    <a:masterClrMapping/>
+  </p:clrMapOvr>
+</p:sld>
+</file>
+
+<file path=ppt/slides/slide7.xml><?xml version="1.0" encoding="utf-8"?>
+<p:sld xmlns:a="http://schemas.openxmlformats.org/drawingml/2006/main" xmlns:r="http://schemas.openxmlformats.org/officeDocument/2006/relationships" xmlns:p="http://schemas.openxmlformats.org/presentationml/2006/main">
+  <p:cSld>
+    <p:spTree>
+      <p:nvGrpSpPr>
+        <p:cNvPr id="1" name=""/>
+        <p:cNvGrpSpPr/>
+        <p:nvPr/>
+      </p:nvGrpSpPr>
+      <p:grpSpPr>
+        <a:xfrm>
+          <a:off x="0" y="0"/>
+          <a:ext cx="0" cy="0"/>
+          <a:chOff x="0" y="0"/>
+          <a:chExt cx="0" cy="0"/>
+        </a:xfrm>
+      </p:grpSpPr>
+      <p:sp>
+        <p:nvSpPr>
+          <p:cNvPr id="2" name="Rectangle 1"/>
+          <p:cNvSpPr/>
+          <p:nvPr/>
+        </p:nvSpPr>
+        <p:spPr>
+          <a:xfrm>
+            <a:off x="365760" y="0"/>
+            <a:ext cx="137160" cy="6858000"/>
+          </a:xfrm>
+          <a:prstGeom prst="rect">
+            <a:avLst/>
+          </a:prstGeom>
+          <a:solidFill>
+            <a:srgbClr val="FFB800"/>
+          </a:solidFill>
+          <a:ln>
+            <a:noFill/>
+          </a:ln>
+        </p:spPr>
+        <p:style>
+          <a:lnRef idx="1">
+            <a:schemeClr val="accent1"/>
+          </a:lnRef>
+          <a:fillRef idx="3">
+            <a:schemeClr val="accent1"/>
+          </a:fillRef>
+          <a:effectRef idx="2">
+            <a:schemeClr val="accent1"/>
+          </a:effectRef>
+          <a:fontRef idx="minor">
+            <a:schemeClr val="lt1"/>
+          </a:fontRef>
+        </p:style>
+        <p:txBody>
+          <a:bodyPr rtlCol="0" anchor="ctr"/>
+          <a:lstStyle/>
+          <a:p>
+            <a:pPr algn="ctr"/>
+            <a:endParaRPr/>
+          </a:p>
+        </p:txBody>
+      </p:sp>
+      <p:sp>
+        <p:nvSpPr>
+          <p:cNvPr id="3" name="TextBox 2"/>
+          <p:cNvSpPr txBox="1"/>
+          <p:nvPr/>
+        </p:nvSpPr>
+        <p:spPr>
+          <a:xfrm>
+            <a:off x="640080" y="182880"/>
+            <a:ext cx="7772400" cy="731520"/>
+          </a:xfrm>
+          <a:prstGeom prst="rect">
+            <a:avLst/>
+          </a:prstGeom>
+          <a:noFill/>
+        </p:spPr>
+        <p:txBody>
+          <a:bodyPr wrap="none">
+            <a:spAutoFit/>
+          </a:bodyPr>
+          <a:lstStyle/>
+          <a:p>
+            <a:pPr>
+              <a:defRPr sz="2600" b="1">
+                <a:solidFill>
+                  <a:srgbClr val="FFFFFF"/>
+                </a:solidFill>
+                <a:latin typeface="Segoe UI"/>
+              </a:defRPr>
+            </a:pPr>
+            <a:r>
+              <a:t>3. Đánh giá Tác động Ban đầu</a:t>
+            </a:r>
+          </a:p>
+        </p:txBody>
+      </p:sp>
+      <p:sp>
+        <p:nvSpPr>
+          <p:cNvPr id="4" name="TextBox 3"/>
+          <p:cNvSpPr txBox="1"/>
+          <p:nvPr/>
+        </p:nvSpPr>
+        <p:spPr>
+          <a:xfrm>
+            <a:off x="640080" y="731520"/>
+            <a:ext cx="7772400" cy="365760"/>
+          </a:xfrm>
+          <a:prstGeom prst="rect">
+            <a:avLst/>
+          </a:prstGeom>
+          <a:noFill/>
+        </p:spPr>
+        <p:txBody>
+          <a:bodyPr wrap="none">
+            <a:spAutoFit/>
+          </a:bodyPr>
+          <a:lstStyle/>
+          <a:p>
+            <a:pPr>
+              <a:defRPr sz="1300">
+                <a:solidFill>
+                  <a:srgbClr val="FFB800"/>
+                </a:solidFill>
+                <a:latin typeface="Segoe UI"/>
+              </a:defRPr>
+            </a:pPr>
+            <a:r>
+              <a:t>Chênh lệch giữa Control và Treatment</a:t>
+            </a:r>
+          </a:p>
+        </p:txBody>
+      </p:sp>
+      <p:sp>
+        <p:nvSpPr>
+          <p:cNvPr id="5" name="Rectangle 4"/>
+          <p:cNvSpPr/>
+          <p:nvPr/>
+        </p:nvSpPr>
+        <p:spPr>
+          <a:xfrm>
+            <a:off x="640080" y="1188720"/>
+            <a:ext cx="2286000" cy="36576"/>
+          </a:xfrm>
+          <a:prstGeom prst="rect">
+            <a:avLst/>
+          </a:prstGeom>
+          <a:solidFill>
+            <a:srgbClr val="FFB800"/>
+          </a:solidFill>
+          <a:ln>
+            <a:noFill/>
+          </a:ln>
+        </p:spPr>
+        <p:style>
+          <a:lnRef idx="1">
+            <a:schemeClr val="accent1"/>
+          </a:lnRef>
+          <a:fillRef idx="3">
+            <a:schemeClr val="accent1"/>
+          </a:fillRef>
+          <a:effectRef idx="2">
+            <a:schemeClr val="accent1"/>
+          </a:effectRef>
+          <a:fontRef idx="minor">
+            <a:schemeClr val="lt1"/>
+          </a:fontRef>
+        </p:style>
+        <p:txBody>
+          <a:bodyPr rtlCol="0" anchor="ctr"/>
+          <a:lstStyle/>
+          <a:p>
+            <a:pPr algn="ctr"/>
+            <a:endParaRPr/>
+          </a:p>
+        </p:txBody>
+      </p:sp>
+      <p:sp>
+        <p:nvSpPr>
+          <p:cNvPr id="6" name="Rectangle 5"/>
+          <p:cNvSpPr/>
+          <p:nvPr/>
+        </p:nvSpPr>
+        <p:spPr>
+          <a:xfrm>
+            <a:off x="365760" y="6217920"/>
+            <a:ext cx="8778240" cy="365760"/>
+          </a:xfrm>
+          <a:prstGeom prst="rect">
+            <a:avLst/>
+          </a:prstGeom>
+          <a:solidFill>
+            <a:srgbClr val="1C4E80"/>
+          </a:solidFill>
+          <a:ln>
+            <a:noFill/>
+          </a:ln>
+        </p:spPr>
+        <p:style>
+          <a:lnRef idx="1">
+            <a:schemeClr val="accent1"/>
+          </a:lnRef>
+          <a:fillRef idx="3">
+            <a:schemeClr val="accent1"/>
+          </a:fillRef>
+          <a:effectRef idx="2">
+            <a:schemeClr val="accent1"/>
+          </a:effectRef>
+          <a:fontRef idx="minor">
+            <a:schemeClr val="lt1"/>
+          </a:fontRef>
+        </p:style>
+        <p:txBody>
+          <a:bodyPr rtlCol="0" anchor="ctr"/>
+          <a:lstStyle/>
+          <a:p>
+            <a:pPr algn="ctr"/>
+            <a:endParaRPr/>
+          </a:p>
+        </p:txBody>
+      </p:sp>
+      <p:sp>
+        <p:nvSpPr>
+          <p:cNvPr id="7" name="TextBox 6"/>
+          <p:cNvSpPr txBox="1"/>
+          <p:nvPr/>
+        </p:nvSpPr>
+        <p:spPr>
+          <a:xfrm>
+            <a:off x="457200" y="6217920"/>
+            <a:ext cx="7315200" cy="365760"/>
+          </a:xfrm>
+          <a:prstGeom prst="rect">
+            <a:avLst/>
+          </a:prstGeom>
+          <a:noFill/>
+        </p:spPr>
+        <p:txBody>
+          <a:bodyPr wrap="none" anchor="ctr">
+            <a:spAutoFit/>
+          </a:bodyPr>
+          <a:lstStyle/>
+          <a:p>
+            <a:pPr>
+              <a:defRPr sz="1000">
+                <a:solidFill>
+                  <a:srgbClr val="FFFFFF"/>
+                </a:solidFill>
+                <a:latin typeface="Segoe UI"/>
+              </a:defRPr>
+            </a:pPr>
+            <a:r>
+              <a:t>GSM Promotion Experimentation • Báo cáo Chuyên môn • Data Science Team</a:t>
+            </a:r>
+          </a:p>
+        </p:txBody>
+      </p:sp>
+      <p:sp>
+        <p:nvSpPr>
+          <p:cNvPr id="8" name="Rectangle 7"/>
+          <p:cNvSpPr/>
+          <p:nvPr/>
+        </p:nvSpPr>
+        <p:spPr>
+          <a:xfrm>
+            <a:off x="365760" y="6583680"/>
+            <a:ext cx="8778240" cy="274320"/>
+          </a:xfrm>
+          <a:prstGeom prst="rect">
+            <a:avLst/>
+          </a:prstGeom>
+          <a:solidFill>
+            <a:srgbClr val="070D17"/>
+          </a:solidFill>
+          <a:ln>
+            <a:noFill/>
+          </a:ln>
+        </p:spPr>
+        <p:style>
+          <a:lnRef idx="1">
+            <a:schemeClr val="accent1"/>
+          </a:lnRef>
+          <a:fillRef idx="3">
+            <a:schemeClr val="accent1"/>
+          </a:fillRef>
+          <a:effectRef idx="2">
+            <a:schemeClr val="accent1"/>
+          </a:effectRef>
+          <a:fontRef idx="minor">
+            <a:schemeClr val="lt1"/>
+          </a:fontRef>
+        </p:style>
+        <p:txBody>
+          <a:bodyPr rtlCol="0" anchor="ctr"/>
+          <a:lstStyle/>
+          <a:p>
+            <a:pPr algn="ctr"/>
+            <a:endParaRPr/>
+          </a:p>
+        </p:txBody>
+      </p:sp>
+      <p:sp>
+        <p:nvSpPr>
+          <p:cNvPr id="9" name="TextBox 8"/>
+          <p:cNvSpPr txBox="1"/>
+          <p:nvPr/>
+        </p:nvSpPr>
+        <p:spPr>
+          <a:xfrm>
+            <a:off x="457200" y="6583680"/>
+            <a:ext cx="4572000" cy="274320"/>
+          </a:xfrm>
+          <a:prstGeom prst="rect">
+            <a:avLst/>
+          </a:prstGeom>
+          <a:noFill/>
+        </p:spPr>
+        <p:txBody>
+          <a:bodyPr wrap="none" anchor="ctr">
+            <a:spAutoFit/>
+          </a:bodyPr>
+          <a:lstStyle/>
+          <a:p>
+            <a:pPr>
+              <a:defRPr sz="900">
+                <a:solidFill>
+                  <a:srgbClr val="38BDF8"/>
+                </a:solidFill>
+                <a:latin typeface="Segoe UI"/>
+              </a:defRPr>
+            </a:pPr>
+            <a:r>
+              <a:t>Project: Uplift Modeling &amp; Causal Inference</a:t>
+            </a:r>
+          </a:p>
+        </p:txBody>
+      </p:sp>
+      <p:sp>
+        <p:nvSpPr>
+          <p:cNvPr id="10" name="TextBox 9"/>
+          <p:cNvSpPr txBox="1"/>
+          <p:nvPr/>
+        </p:nvSpPr>
+        <p:spPr>
+          <a:xfrm>
+            <a:off x="7772400" y="6583680"/>
+            <a:ext cx="1280160" cy="274320"/>
+          </a:xfrm>
+          <a:prstGeom prst="rect">
+            <a:avLst/>
+          </a:prstGeom>
+          <a:noFill/>
+        </p:spPr>
+        <p:txBody>
+          <a:bodyPr wrap="none" anchor="ctr">
+            <a:spAutoFit/>
+          </a:bodyPr>
+          <a:lstStyle/>
+          <a:p>
+            <a:pPr algn="r">
+              <a:defRPr sz="900" b="1">
+                <a:solidFill>
+                  <a:srgbClr val="FFFFFF"/>
+                </a:solidFill>
+                <a:latin typeface="Segoe UI"/>
+              </a:defRPr>
+            </a:pPr>
+            <a:r>
+              <a:t>03 / 05</a:t>
+            </a:r>
+          </a:p>
+        </p:txBody>
+      </p:sp>
+      <p:sp>
+        <p:nvSpPr>
+          <p:cNvPr id="11" name="Rounded Rectangle 10"/>
+          <p:cNvSpPr/>
+          <p:nvPr/>
+        </p:nvSpPr>
+        <p:spPr>
+          <a:xfrm>
+            <a:off x="640080" y="1463040"/>
+            <a:ext cx="3840480" cy="2240280"/>
+          </a:xfrm>
+          <a:prstGeom prst="roundRect">
+            <a:avLst/>
+          </a:prstGeom>
+          <a:solidFill>
+            <a:srgbClr val="172545"/>
+          </a:solidFill>
+          <a:ln>
+            <a:noFill/>
+          </a:ln>
+        </p:spPr>
+        <p:style>
+          <a:lnRef idx="1">
+            <a:schemeClr val="accent1"/>
+          </a:lnRef>
+          <a:fillRef idx="3">
+            <a:schemeClr val="accent1"/>
+          </a:fillRef>
+          <a:effectRef idx="2">
+            <a:schemeClr val="accent1"/>
+          </a:effectRef>
+          <a:fontRef idx="minor">
+            <a:schemeClr val="lt1"/>
+          </a:fontRef>
+        </p:style>
+        <p:txBody>
+          <a:bodyPr rtlCol="0" anchor="ctr"/>
+          <a:lstStyle/>
+          <a:p>
+            <a:pPr algn="ctr"/>
+            <a:endParaRPr/>
+          </a:p>
+        </p:txBody>
+      </p:sp>
+      <p:sp>
+        <p:nvSpPr>
+          <p:cNvPr id="12" name="Rectangle 11"/>
+          <p:cNvSpPr/>
+          <p:nvPr/>
+        </p:nvSpPr>
+        <p:spPr>
+          <a:xfrm>
+            <a:off x="777240" y="1828800"/>
+            <a:ext cx="3566160" cy="36576"/>
+          </a:xfrm>
+          <a:prstGeom prst="rect">
+            <a:avLst/>
+          </a:prstGeom>
+          <a:solidFill>
+            <a:srgbClr val="34D399"/>
+          </a:solidFill>
+          <a:ln>
+            <a:noFill/>
+          </a:ln>
+        </p:spPr>
+        <p:style>
+          <a:lnRef idx="1">
+            <a:schemeClr val="accent1"/>
+          </a:lnRef>
+          <a:fillRef idx="3">
+            <a:schemeClr val="accent1"/>
+          </a:fillRef>
+          <a:effectRef idx="2">
+            <a:schemeClr val="accent1"/>
+          </a:effectRef>
+          <a:fontRef idx="minor">
+            <a:schemeClr val="lt1"/>
+          </a:fontRef>
+        </p:style>
+        <p:txBody>
+          <a:bodyPr rtlCol="0" anchor="ctr"/>
+          <a:lstStyle/>
+          <a:p>
+            <a:pPr algn="ctr"/>
+            <a:endParaRPr/>
+          </a:p>
+        </p:txBody>
+      </p:sp>
+      <p:sp>
+        <p:nvSpPr>
+          <p:cNvPr id="13" name="TextBox 12"/>
+          <p:cNvSpPr txBox="1"/>
+          <p:nvPr/>
+        </p:nvSpPr>
+        <p:spPr>
+          <a:xfrm>
+            <a:off x="685800" y="1508760"/>
+            <a:ext cx="3749040" cy="365760"/>
+          </a:xfrm>
+          <a:prstGeom prst="rect">
+            <a:avLst/>
+          </a:prstGeom>
+          <a:noFill/>
+        </p:spPr>
+        <p:txBody>
+          <a:bodyPr wrap="square">
+            <a:spAutoFit/>
+          </a:bodyPr>
+          <a:lstStyle/>
+          <a:p>
+            <a:pPr>
+              <a:defRPr sz="1600" b="1">
+                <a:solidFill>
+                  <a:srgbClr val="34D399"/>
+                </a:solidFill>
+                <a:latin typeface="Segoe UI"/>
+              </a:defRPr>
+            </a:pPr>
+            <a:r>
+              <a:t>Quan sát trực quan</a:t>
+            </a:r>
+          </a:p>
+        </p:txBody>
+      </p:sp>
+      <p:sp>
+        <p:nvSpPr>
+          <p:cNvPr id="14" name="TextBox 13"/>
+          <p:cNvSpPr txBox="1"/>
+          <p:nvPr/>
+        </p:nvSpPr>
+        <p:spPr>
+          <a:xfrm>
+            <a:off x="685800" y="1874520"/>
+            <a:ext cx="3749040" cy="1783080"/>
+          </a:xfrm>
+          <a:prstGeom prst="rect">
+            <a:avLst/>
+          </a:prstGeom>
+          <a:noFill/>
+        </p:spPr>
+        <p:txBody>
+          <a:bodyPr wrap="square">
+            <a:spAutoFit/>
+          </a:bodyPr>
+          <a:lstStyle/>
+          <a:p>
+            <a:pPr>
+              <a:spcAft>
+                <a:spcPts val="400"/>
+              </a:spcAft>
+              <a:defRPr sz="1400">
+                <a:solidFill>
+                  <a:srgbClr val="FFFFFF"/>
+                </a:solidFill>
+                <a:latin typeface="Segoe UI"/>
+              </a:defRPr>
+            </a:pPr>
+            <a:r>
+              <a:t>• Biểu đồ cho thấy nhóm được nhận khuyến mãi (Treatment) có sự dịch chuyển tích cực về tần suất đặt xe.</a:t>
+            </a:r>
+          </a:p>
+        </p:txBody>
+      </p:sp>
+      <p:sp>
+        <p:nvSpPr>
+          <p:cNvPr id="15" name="Rounded Rectangle 14"/>
+          <p:cNvSpPr/>
+          <p:nvPr/>
+        </p:nvSpPr>
+        <p:spPr>
+          <a:xfrm>
+            <a:off x="640080" y="3840480"/>
+            <a:ext cx="3840480" cy="2240280"/>
+          </a:xfrm>
+          <a:prstGeom prst="roundRect">
+            <a:avLst/>
+          </a:prstGeom>
+          <a:solidFill>
+            <a:srgbClr val="172545"/>
+          </a:solidFill>
+          <a:ln>
+            <a:noFill/>
+          </a:ln>
+        </p:spPr>
+        <p:style>
+          <a:lnRef idx="1">
+            <a:schemeClr val="accent1"/>
+          </a:lnRef>
+          <a:fillRef idx="3">
+            <a:schemeClr val="accent1"/>
+          </a:fillRef>
+          <a:effectRef idx="2">
+            <a:schemeClr val="accent1"/>
+          </a:effectRef>
+          <a:fontRef idx="minor">
+            <a:schemeClr val="lt1"/>
+          </a:fontRef>
+        </p:style>
+        <p:txBody>
+          <a:bodyPr rtlCol="0" anchor="ctr"/>
+          <a:lstStyle/>
+          <a:p>
+            <a:pPr algn="ctr"/>
+            <a:endParaRPr/>
+          </a:p>
+        </p:txBody>
+      </p:sp>
+      <p:sp>
+        <p:nvSpPr>
+          <p:cNvPr id="16" name="Rectangle 15"/>
+          <p:cNvSpPr/>
+          <p:nvPr/>
+        </p:nvSpPr>
+        <p:spPr>
+          <a:xfrm>
+            <a:off x="777240" y="4206240"/>
+            <a:ext cx="3566160" cy="36576"/>
+          </a:xfrm>
+          <a:prstGeom prst="rect">
+            <a:avLst/>
+          </a:prstGeom>
+          <a:solidFill>
+            <a:srgbClr val="38BDF8"/>
+          </a:solidFill>
+          <a:ln>
+            <a:noFill/>
+          </a:ln>
+        </p:spPr>
+        <p:style>
+          <a:lnRef idx="1">
+            <a:schemeClr val="accent1"/>
+          </a:lnRef>
+          <a:fillRef idx="3">
+            <a:schemeClr val="accent1"/>
+          </a:fillRef>
+          <a:effectRef idx="2">
+            <a:schemeClr val="accent1"/>
+          </a:effectRef>
+          <a:fontRef idx="minor">
+            <a:schemeClr val="lt1"/>
+          </a:fontRef>
+        </p:style>
+        <p:txBody>
+          <a:bodyPr rtlCol="0" anchor="ctr"/>
+          <a:lstStyle/>
+          <a:p>
+            <a:pPr algn="ctr"/>
+            <a:endParaRPr/>
+          </a:p>
+        </p:txBody>
+      </p:sp>
+      <p:sp>
+        <p:nvSpPr>
+          <p:cNvPr id="17" name="TextBox 16"/>
+          <p:cNvSpPr txBox="1"/>
+          <p:nvPr/>
+        </p:nvSpPr>
+        <p:spPr>
+          <a:xfrm>
+            <a:off x="685800" y="3886200"/>
+            <a:ext cx="3749040" cy="365760"/>
+          </a:xfrm>
+          <a:prstGeom prst="rect">
+            <a:avLst/>
+          </a:prstGeom>
+          <a:noFill/>
+        </p:spPr>
+        <p:txBody>
+          <a:bodyPr wrap="square">
+            <a:spAutoFit/>
+          </a:bodyPr>
+          <a:lstStyle/>
+          <a:p>
+            <a:pPr>
+              <a:defRPr sz="1600" b="1">
+                <a:solidFill>
+                  <a:srgbClr val="38BDF8"/>
+                </a:solidFill>
+                <a:latin typeface="Segoe UI"/>
+              </a:defRPr>
+            </a:pPr>
+            <a:r>
+              <a:t>Khẳng định</a:t>
+            </a:r>
+          </a:p>
+        </p:txBody>
+      </p:sp>
+      <p:sp>
+        <p:nvSpPr>
+          <p:cNvPr id="18" name="TextBox 17"/>
+          <p:cNvSpPr txBox="1"/>
+          <p:nvPr/>
+        </p:nvSpPr>
+        <p:spPr>
+          <a:xfrm>
+            <a:off x="685800" y="4251960"/>
+            <a:ext cx="3749040" cy="1783080"/>
+          </a:xfrm>
+          <a:prstGeom prst="rect">
+            <a:avLst/>
+          </a:prstGeom>
+          <a:noFill/>
+        </p:spPr>
+        <p:txBody>
+          <a:bodyPr wrap="square">
+            <a:spAutoFit/>
+          </a:bodyPr>
+          <a:lstStyle/>
+          <a:p>
+            <a:pPr>
+              <a:spcAft>
+                <a:spcPts val="400"/>
+              </a:spcAft>
+              <a:defRPr sz="1400">
+                <a:solidFill>
+                  <a:srgbClr val="FFFFFF"/>
+                </a:solidFill>
+                <a:latin typeface="Segoe UI"/>
+              </a:defRPr>
+            </a:pPr>
+            <a:r>
+              <a:t>• Bằng chứng ban đầu xác nhận Voucher thực sự tạo ra Tác động Nhân quả (Causal Effect).</a:t>
+            </a:r>
+          </a:p>
+        </p:txBody>
+      </p:sp>
+      <p:pic>
+        <p:nvPicPr>
+          <p:cNvPr id="19" name="Picture 18" descr="week4_ab_testing_0.png"/>
+          <p:cNvPicPr>
+            <a:picLocks noChangeAspect="1"/>
+          </p:cNvPicPr>
+          <p:nvPr/>
+        </p:nvPicPr>
+        <p:blipFill>
+          <a:blip r:embed="rId2"/>
+          <a:stretch>
+            <a:fillRect/>
+          </a:stretch>
+        </p:blipFill>
+        <p:spPr>
+          <a:xfrm>
+            <a:off x="4572000" y="2286000"/>
+            <a:ext cx="4206240" cy="2272824"/>
+          </a:xfrm>
+          <a:prstGeom prst="rect">
+            <a:avLst/>
+          </a:prstGeom>
+        </p:spPr>
+      </p:pic>
+    </p:spTree>
+    <p:extLst>
+      <p:ext uri="{BB962C8B-B14F-4D97-AF65-F5344CB8AC3E}">
+        <p14:creationId xmlns:p14="http://schemas.microsoft.com/office/powerpoint/2010/main" val="522403372"/>
+      </p:ext>
+    </p:extLst>
+  </p:cSld>
+  <p:clrMapOvr>
+    <a:masterClrMapping/>
+  </p:clrMapOvr>
+</p:sld>
+</file>
+
+<file path=ppt/slides/slide8.xml><?xml version="1.0" encoding="utf-8"?>
+<p:sld xmlns:a="http://schemas.openxmlformats.org/drawingml/2006/main" xmlns:r="http://schemas.openxmlformats.org/officeDocument/2006/relationships" xmlns:p="http://schemas.openxmlformats.org/presentationml/2006/main">
+  <p:cSld>
+    <p:spTree>
+      <p:nvGrpSpPr>
+        <p:cNvPr id="1" name=""/>
+        <p:cNvGrpSpPr/>
+        <p:nvPr/>
+      </p:nvGrpSpPr>
+      <p:grpSpPr>
+        <a:xfrm>
+          <a:off x="0" y="0"/>
+          <a:ext cx="0" cy="0"/>
+          <a:chOff x="0" y="0"/>
+          <a:chExt cx="0" cy="0"/>
+        </a:xfrm>
+      </p:grpSpPr>
+      <p:sp>
+        <p:nvSpPr>
+          <p:cNvPr id="2" name="Rectangle 1"/>
+          <p:cNvSpPr/>
+          <p:nvPr/>
+        </p:nvSpPr>
+        <p:spPr>
+          <a:xfrm>
+            <a:off x="365760" y="0"/>
+            <a:ext cx="137160" cy="6858000"/>
+          </a:xfrm>
+          <a:prstGeom prst="rect">
+            <a:avLst/>
+          </a:prstGeom>
+          <a:solidFill>
+            <a:srgbClr val="FFB800"/>
+          </a:solidFill>
+          <a:ln>
+            <a:noFill/>
+          </a:ln>
+        </p:spPr>
+        <p:style>
+          <a:lnRef idx="1">
+            <a:schemeClr val="accent1"/>
+          </a:lnRef>
+          <a:fillRef idx="3">
+            <a:schemeClr val="accent1"/>
+          </a:fillRef>
+          <a:effectRef idx="2">
+            <a:schemeClr val="accent1"/>
+          </a:effectRef>
+          <a:fontRef idx="minor">
+            <a:schemeClr val="lt1"/>
+          </a:fontRef>
+        </p:style>
+        <p:txBody>
+          <a:bodyPr rtlCol="0" anchor="ctr"/>
+          <a:lstStyle/>
+          <a:p>
+            <a:pPr algn="ctr"/>
+            <a:endParaRPr/>
+          </a:p>
+        </p:txBody>
+      </p:sp>
+      <p:sp>
+        <p:nvSpPr>
+          <p:cNvPr id="3" name="TextBox 2"/>
+          <p:cNvSpPr txBox="1"/>
+          <p:nvPr/>
+        </p:nvSpPr>
+        <p:spPr>
+          <a:xfrm>
+            <a:off x="640080" y="182880"/>
+            <a:ext cx="7772400" cy="731520"/>
+          </a:xfrm>
+          <a:prstGeom prst="rect">
+            <a:avLst/>
+          </a:prstGeom>
+          <a:noFill/>
+        </p:spPr>
+        <p:txBody>
+          <a:bodyPr wrap="none">
+            <a:spAutoFit/>
+          </a:bodyPr>
+          <a:lstStyle/>
+          <a:p>
+            <a:pPr>
+              <a:defRPr sz="2600" b="1">
+                <a:solidFill>
+                  <a:srgbClr val="FFFFFF"/>
+                </a:solidFill>
+                <a:latin typeface="Segoe UI"/>
+              </a:defRPr>
+            </a:pPr>
+            <a:r>
+              <a:t>4. Phân tích Hồi quy Tuyến tính (OLS)</a:t>
+            </a:r>
+          </a:p>
+        </p:txBody>
+      </p:sp>
+      <p:sp>
+        <p:nvSpPr>
+          <p:cNvPr id="4" name="TextBox 3"/>
+          <p:cNvSpPr txBox="1"/>
+          <p:nvPr/>
+        </p:nvSpPr>
+        <p:spPr>
+          <a:xfrm>
+            <a:off x="640080" y="731520"/>
+            <a:ext cx="7772400" cy="365760"/>
+          </a:xfrm>
+          <a:prstGeom prst="rect">
+            <a:avLst/>
+          </a:prstGeom>
+          <a:noFill/>
+        </p:spPr>
+        <p:txBody>
+          <a:bodyPr wrap="none">
+            <a:spAutoFit/>
+          </a:bodyPr>
+          <a:lstStyle/>
+          <a:p>
+            <a:pPr>
+              <a:defRPr sz="1300">
+                <a:solidFill>
+                  <a:srgbClr val="FFB800"/>
+                </a:solidFill>
+                <a:latin typeface="Segoe UI"/>
+              </a:defRPr>
+            </a:pPr>
+            <a:r>
+              <a:t>Đo lường Net Effect</a:t>
+            </a:r>
+          </a:p>
+        </p:txBody>
+      </p:sp>
+      <p:sp>
+        <p:nvSpPr>
+          <p:cNvPr id="5" name="Rectangle 4"/>
+          <p:cNvSpPr/>
+          <p:nvPr/>
+        </p:nvSpPr>
+        <p:spPr>
+          <a:xfrm>
+            <a:off x="640080" y="1188720"/>
+            <a:ext cx="2286000" cy="36576"/>
+          </a:xfrm>
+          <a:prstGeom prst="rect">
+            <a:avLst/>
+          </a:prstGeom>
+          <a:solidFill>
+            <a:srgbClr val="FFB800"/>
+          </a:solidFill>
+          <a:ln>
+            <a:noFill/>
+          </a:ln>
+        </p:spPr>
+        <p:style>
+          <a:lnRef idx="1">
+            <a:schemeClr val="accent1"/>
+          </a:lnRef>
+          <a:fillRef idx="3">
+            <a:schemeClr val="accent1"/>
+          </a:fillRef>
+          <a:effectRef idx="2">
+            <a:schemeClr val="accent1"/>
+          </a:effectRef>
+          <a:fontRef idx="minor">
+            <a:schemeClr val="lt1"/>
+          </a:fontRef>
+        </p:style>
+        <p:txBody>
+          <a:bodyPr rtlCol="0" anchor="ctr"/>
+          <a:lstStyle/>
+          <a:p>
+            <a:pPr algn="ctr"/>
+            <a:endParaRPr/>
+          </a:p>
+        </p:txBody>
+      </p:sp>
+      <p:sp>
+        <p:nvSpPr>
+          <p:cNvPr id="6" name="Rectangle 5"/>
+          <p:cNvSpPr/>
+          <p:nvPr/>
+        </p:nvSpPr>
+        <p:spPr>
+          <a:xfrm>
+            <a:off x="365760" y="6217920"/>
+            <a:ext cx="8778240" cy="365760"/>
+          </a:xfrm>
+          <a:prstGeom prst="rect">
+            <a:avLst/>
+          </a:prstGeom>
+          <a:solidFill>
+            <a:srgbClr val="1C4E80"/>
+          </a:solidFill>
+          <a:ln>
+            <a:noFill/>
+          </a:ln>
+        </p:spPr>
+        <p:style>
+          <a:lnRef idx="1">
+            <a:schemeClr val="accent1"/>
+          </a:lnRef>
+          <a:fillRef idx="3">
+            <a:schemeClr val="accent1"/>
+          </a:fillRef>
+          <a:effectRef idx="2">
+            <a:schemeClr val="accent1"/>
+          </a:effectRef>
+          <a:fontRef idx="minor">
+            <a:schemeClr val="lt1"/>
+          </a:fontRef>
+        </p:style>
+        <p:txBody>
+          <a:bodyPr rtlCol="0" anchor="ctr"/>
+          <a:lstStyle/>
+          <a:p>
+            <a:pPr algn="ctr"/>
+            <a:endParaRPr/>
+          </a:p>
+        </p:txBody>
+      </p:sp>
+      <p:sp>
+        <p:nvSpPr>
+          <p:cNvPr id="7" name="TextBox 6"/>
+          <p:cNvSpPr txBox="1"/>
+          <p:nvPr/>
+        </p:nvSpPr>
+        <p:spPr>
+          <a:xfrm>
+            <a:off x="457200" y="6217920"/>
+            <a:ext cx="7315200" cy="365760"/>
+          </a:xfrm>
+          <a:prstGeom prst="rect">
+            <a:avLst/>
+          </a:prstGeom>
+          <a:noFill/>
+        </p:spPr>
+        <p:txBody>
+          <a:bodyPr wrap="none" anchor="ctr">
+            <a:spAutoFit/>
+          </a:bodyPr>
+          <a:lstStyle/>
+          <a:p>
+            <a:pPr>
+              <a:defRPr sz="1000">
+                <a:solidFill>
+                  <a:srgbClr val="FFFFFF"/>
+                </a:solidFill>
+                <a:latin typeface="Segoe UI"/>
+              </a:defRPr>
+            </a:pPr>
+            <a:r>
+              <a:t>GSM Promotion Experimentation • Báo cáo Chuyên môn • Data Science Team</a:t>
+            </a:r>
+          </a:p>
+        </p:txBody>
+      </p:sp>
+      <p:sp>
+        <p:nvSpPr>
+          <p:cNvPr id="8" name="Rectangle 7"/>
+          <p:cNvSpPr/>
+          <p:nvPr/>
+        </p:nvSpPr>
+        <p:spPr>
+          <a:xfrm>
+            <a:off x="365760" y="6583680"/>
+            <a:ext cx="8778240" cy="274320"/>
+          </a:xfrm>
+          <a:prstGeom prst="rect">
+            <a:avLst/>
+          </a:prstGeom>
+          <a:solidFill>
+            <a:srgbClr val="070D17"/>
+          </a:solidFill>
+          <a:ln>
+            <a:noFill/>
+          </a:ln>
+        </p:spPr>
+        <p:style>
+          <a:lnRef idx="1">
+            <a:schemeClr val="accent1"/>
+          </a:lnRef>
+          <a:fillRef idx="3">
+            <a:schemeClr val="accent1"/>
+          </a:fillRef>
+          <a:effectRef idx="2">
+            <a:schemeClr val="accent1"/>
+          </a:effectRef>
+          <a:fontRef idx="minor">
+            <a:schemeClr val="lt1"/>
+          </a:fontRef>
+        </p:style>
+        <p:txBody>
+          <a:bodyPr rtlCol="0" anchor="ctr"/>
+          <a:lstStyle/>
+          <a:p>
+            <a:pPr algn="ctr"/>
+            <a:endParaRPr/>
+          </a:p>
+        </p:txBody>
+      </p:sp>
+      <p:sp>
+        <p:nvSpPr>
+          <p:cNvPr id="9" name="TextBox 8"/>
+          <p:cNvSpPr txBox="1"/>
+          <p:nvPr/>
+        </p:nvSpPr>
+        <p:spPr>
+          <a:xfrm>
+            <a:off x="457200" y="6583680"/>
+            <a:ext cx="4572000" cy="274320"/>
+          </a:xfrm>
+          <a:prstGeom prst="rect">
+            <a:avLst/>
+          </a:prstGeom>
+          <a:noFill/>
+        </p:spPr>
+        <p:txBody>
+          <a:bodyPr wrap="none" anchor="ctr">
+            <a:spAutoFit/>
+          </a:bodyPr>
+          <a:lstStyle/>
+          <a:p>
+            <a:pPr>
+              <a:defRPr sz="900">
+                <a:solidFill>
+                  <a:srgbClr val="38BDF8"/>
+                </a:solidFill>
+                <a:latin typeface="Segoe UI"/>
+              </a:defRPr>
+            </a:pPr>
+            <a:r>
+              <a:t>Project: Uplift Modeling &amp; Causal Inference</a:t>
+            </a:r>
+          </a:p>
+        </p:txBody>
+      </p:sp>
+      <p:sp>
+        <p:nvSpPr>
+          <p:cNvPr id="10" name="TextBox 9"/>
+          <p:cNvSpPr txBox="1"/>
+          <p:nvPr/>
+        </p:nvSpPr>
+        <p:spPr>
+          <a:xfrm>
+            <a:off x="7772400" y="6583680"/>
+            <a:ext cx="1280160" cy="274320"/>
+          </a:xfrm>
+          <a:prstGeom prst="rect">
+            <a:avLst/>
+          </a:prstGeom>
+          <a:noFill/>
+        </p:spPr>
+        <p:txBody>
+          <a:bodyPr wrap="none" anchor="ctr">
+            <a:spAutoFit/>
+          </a:bodyPr>
+          <a:lstStyle/>
+          <a:p>
+            <a:pPr algn="r">
+              <a:defRPr sz="900" b="1">
+                <a:solidFill>
+                  <a:srgbClr val="FFFFFF"/>
+                </a:solidFill>
+                <a:latin typeface="Segoe UI"/>
+              </a:defRPr>
+            </a:pPr>
+            <a:r>
+              <a:t>04 / 05</a:t>
+            </a:r>
+          </a:p>
+        </p:txBody>
+      </p:sp>
+      <p:sp>
+        <p:nvSpPr>
+          <p:cNvPr id="11" name="Rounded Rectangle 10"/>
+          <p:cNvSpPr/>
+          <p:nvPr/>
+        </p:nvSpPr>
+        <p:spPr>
+          <a:xfrm>
+            <a:off x="640080" y="1463040"/>
+            <a:ext cx="3840480" cy="2240280"/>
+          </a:xfrm>
+          <a:prstGeom prst="roundRect">
+            <a:avLst/>
+          </a:prstGeom>
+          <a:solidFill>
+            <a:srgbClr val="172545"/>
+          </a:solidFill>
+          <a:ln>
+            <a:noFill/>
+          </a:ln>
+        </p:spPr>
+        <p:style>
+          <a:lnRef idx="1">
+            <a:schemeClr val="accent1"/>
+          </a:lnRef>
+          <a:fillRef idx="3">
+            <a:schemeClr val="accent1"/>
+          </a:fillRef>
+          <a:effectRef idx="2">
+            <a:schemeClr val="accent1"/>
+          </a:effectRef>
+          <a:fontRef idx="minor">
+            <a:schemeClr val="lt1"/>
+          </a:fontRef>
+        </p:style>
+        <p:txBody>
+          <a:bodyPr rtlCol="0" anchor="ctr"/>
+          <a:lstStyle/>
+          <a:p>
+            <a:pPr algn="ctr"/>
+            <a:endParaRPr/>
+          </a:p>
+        </p:txBody>
+      </p:sp>
+      <p:sp>
+        <p:nvSpPr>
+          <p:cNvPr id="12" name="Rectangle 11"/>
+          <p:cNvSpPr/>
+          <p:nvPr/>
+        </p:nvSpPr>
+        <p:spPr>
+          <a:xfrm>
+            <a:off x="777240" y="1828800"/>
+            <a:ext cx="3566160" cy="36576"/>
+          </a:xfrm>
+          <a:prstGeom prst="rect">
+            <a:avLst/>
+          </a:prstGeom>
+          <a:solidFill>
+            <a:srgbClr val="FFB800"/>
+          </a:solidFill>
+          <a:ln>
+            <a:noFill/>
+          </a:ln>
+        </p:spPr>
+        <p:style>
+          <a:lnRef idx="1">
+            <a:schemeClr val="accent1"/>
+          </a:lnRef>
+          <a:fillRef idx="3">
+            <a:schemeClr val="accent1"/>
+          </a:fillRef>
+          <a:effectRef idx="2">
+            <a:schemeClr val="accent1"/>
+          </a:effectRef>
+          <a:fontRef idx="minor">
+            <a:schemeClr val="lt1"/>
+          </a:fontRef>
+        </p:style>
+        <p:txBody>
+          <a:bodyPr rtlCol="0" anchor="ctr"/>
+          <a:lstStyle/>
+          <a:p>
+            <a:pPr algn="ctr"/>
+            <a:endParaRPr/>
+          </a:p>
+        </p:txBody>
+      </p:sp>
+      <p:sp>
+        <p:nvSpPr>
+          <p:cNvPr id="13" name="TextBox 12"/>
+          <p:cNvSpPr txBox="1"/>
+          <p:nvPr/>
+        </p:nvSpPr>
+        <p:spPr>
+          <a:xfrm>
+            <a:off x="685800" y="1508760"/>
+            <a:ext cx="3749040" cy="365760"/>
+          </a:xfrm>
+          <a:prstGeom prst="rect">
+            <a:avLst/>
+          </a:prstGeom>
+          <a:noFill/>
+        </p:spPr>
+        <p:txBody>
+          <a:bodyPr wrap="square">
+            <a:spAutoFit/>
+          </a:bodyPr>
+          <a:lstStyle/>
+          <a:p>
+            <a:pPr>
+              <a:defRPr sz="1600" b="1">
+                <a:solidFill>
+                  <a:srgbClr val="FFB800"/>
+                </a:solidFill>
+                <a:latin typeface="Segoe UI"/>
+              </a:defRPr>
+            </a:pPr>
+            <a:r>
+              <a:t>Kiểm soát Covariates</a:t>
+            </a:r>
+          </a:p>
+        </p:txBody>
+      </p:sp>
+      <p:sp>
+        <p:nvSpPr>
+          <p:cNvPr id="14" name="TextBox 13"/>
+          <p:cNvSpPr txBox="1"/>
+          <p:nvPr/>
+        </p:nvSpPr>
+        <p:spPr>
+          <a:xfrm>
+            <a:off x="685800" y="1874520"/>
+            <a:ext cx="3749040" cy="1783080"/>
+          </a:xfrm>
+          <a:prstGeom prst="rect">
+            <a:avLst/>
+          </a:prstGeom>
+          <a:noFill/>
+        </p:spPr>
+        <p:txBody>
+          <a:bodyPr wrap="square">
+            <a:spAutoFit/>
+          </a:bodyPr>
+          <a:lstStyle/>
+          <a:p>
+            <a:pPr>
+              <a:spcAft>
+                <a:spcPts val="400"/>
+              </a:spcAft>
+              <a:defRPr sz="1400">
+                <a:solidFill>
+                  <a:srgbClr val="FFFFFF"/>
+                </a:solidFill>
+                <a:latin typeface="Segoe UI"/>
+              </a:defRPr>
+            </a:pPr>
+            <a:r>
+              <a:t>• Hồi quy OLS cho phép cô lập tác động của Voucher khỏi các biến nhiễu ngoại cảnh (Thời tiết, Vị trí).</a:t>
+            </a:r>
+          </a:p>
+        </p:txBody>
+      </p:sp>
+      <p:sp>
+        <p:nvSpPr>
+          <p:cNvPr id="15" name="Rounded Rectangle 14"/>
+          <p:cNvSpPr/>
+          <p:nvPr/>
+        </p:nvSpPr>
+        <p:spPr>
+          <a:xfrm>
+            <a:off x="640080" y="3840480"/>
+            <a:ext cx="3840480" cy="2240280"/>
+          </a:xfrm>
+          <a:prstGeom prst="roundRect">
+            <a:avLst/>
+          </a:prstGeom>
+          <a:solidFill>
+            <a:srgbClr val="172545"/>
+          </a:solidFill>
+          <a:ln>
+            <a:noFill/>
+          </a:ln>
+        </p:spPr>
+        <p:style>
+          <a:lnRef idx="1">
+            <a:schemeClr val="accent1"/>
+          </a:lnRef>
+          <a:fillRef idx="3">
+            <a:schemeClr val="accent1"/>
+          </a:fillRef>
+          <a:effectRef idx="2">
+            <a:schemeClr val="accent1"/>
+          </a:effectRef>
+          <a:fontRef idx="minor">
+            <a:schemeClr val="lt1"/>
+          </a:fontRef>
+        </p:style>
+        <p:txBody>
+          <a:bodyPr rtlCol="0" anchor="ctr"/>
+          <a:lstStyle/>
+          <a:p>
+            <a:pPr algn="ctr"/>
+            <a:endParaRPr/>
+          </a:p>
+        </p:txBody>
+      </p:sp>
+      <p:sp>
+        <p:nvSpPr>
+          <p:cNvPr id="16" name="Rectangle 15"/>
+          <p:cNvSpPr/>
+          <p:nvPr/>
+        </p:nvSpPr>
+        <p:spPr>
+          <a:xfrm>
+            <a:off x="777240" y="4206240"/>
+            <a:ext cx="3566160" cy="36576"/>
+          </a:xfrm>
+          <a:prstGeom prst="rect">
+            <a:avLst/>
+          </a:prstGeom>
+          <a:solidFill>
+            <a:srgbClr val="38BDF8"/>
+          </a:solidFill>
+          <a:ln>
+            <a:noFill/>
+          </a:ln>
+        </p:spPr>
+        <p:style>
+          <a:lnRef idx="1">
+            <a:schemeClr val="accent1"/>
+          </a:lnRef>
+          <a:fillRef idx="3">
+            <a:schemeClr val="accent1"/>
+          </a:fillRef>
+          <a:effectRef idx="2">
+            <a:schemeClr val="accent1"/>
+          </a:effectRef>
+          <a:fontRef idx="minor">
+            <a:schemeClr val="lt1"/>
+          </a:fontRef>
+        </p:style>
+        <p:txBody>
+          <a:bodyPr rtlCol="0" anchor="ctr"/>
+          <a:lstStyle/>
+          <a:p>
+            <a:pPr algn="ctr"/>
+            <a:endParaRPr/>
+          </a:p>
+        </p:txBody>
+      </p:sp>
+      <p:sp>
+        <p:nvSpPr>
+          <p:cNvPr id="17" name="TextBox 16"/>
+          <p:cNvSpPr txBox="1"/>
+          <p:nvPr/>
+        </p:nvSpPr>
+        <p:spPr>
+          <a:xfrm>
+            <a:off x="685800" y="3886200"/>
+            <a:ext cx="3749040" cy="365760"/>
+          </a:xfrm>
+          <a:prstGeom prst="rect">
+            <a:avLst/>
+          </a:prstGeom>
+          <a:noFill/>
+        </p:spPr>
+        <p:txBody>
+          <a:bodyPr wrap="square">
+            <a:spAutoFit/>
+          </a:bodyPr>
+          <a:lstStyle/>
+          <a:p>
+            <a:pPr>
+              <a:defRPr sz="1600" b="1">
+                <a:solidFill>
+                  <a:srgbClr val="38BDF8"/>
+                </a:solidFill>
+                <a:latin typeface="Segoe UI"/>
+              </a:defRPr>
+            </a:pPr>
+            <a:r>
+              <a:t>Tác động Ròng</a:t>
+            </a:r>
+          </a:p>
+        </p:txBody>
+      </p:sp>
+      <p:sp>
+        <p:nvSpPr>
+          <p:cNvPr id="18" name="TextBox 17"/>
+          <p:cNvSpPr txBox="1"/>
+          <p:nvPr/>
+        </p:nvSpPr>
+        <p:spPr>
+          <a:xfrm>
+            <a:off x="685800" y="4251960"/>
+            <a:ext cx="3749040" cy="1783080"/>
+          </a:xfrm>
+          <a:prstGeom prst="rect">
+            <a:avLst/>
+          </a:prstGeom>
+          <a:noFill/>
+        </p:spPr>
+        <p:txBody>
+          <a:bodyPr wrap="square">
+            <a:spAutoFit/>
+          </a:bodyPr>
+          <a:lstStyle/>
+          <a:p>
+            <a:pPr>
+              <a:spcAft>
+                <a:spcPts val="400"/>
+              </a:spcAft>
+              <a:defRPr sz="1400">
+                <a:solidFill>
+                  <a:srgbClr val="FFFFFF"/>
+                </a:solidFill>
+                <a:latin typeface="Segoe UI"/>
+              </a:defRPr>
+            </a:pPr>
+            <a:r>
+              <a:t>• Chỉ số Uplift đo lường được là chính xác tuyệt đối, loại bỏ sự may mắn ngẫu nhiên.</a:t>
+            </a:r>
+          </a:p>
+        </p:txBody>
+      </p:sp>
+      <p:pic>
+        <p:nvPicPr>
+          <p:cNvPr id="19" name="Picture 18" descr="week4_ab_testing_1.png"/>
+          <p:cNvPicPr>
+            <a:picLocks noChangeAspect="1"/>
+          </p:cNvPicPr>
+          <p:nvPr/>
+        </p:nvPicPr>
+        <p:blipFill>
+          <a:blip r:embed="rId2"/>
+          <a:stretch>
+            <a:fillRect/>
+          </a:stretch>
+        </p:blipFill>
+        <p:spPr>
+          <a:xfrm>
+            <a:off x="4572000" y="2286000"/>
+            <a:ext cx="4206240" cy="2343898"/>
+          </a:xfrm>
+          <a:prstGeom prst="rect">
+            <a:avLst/>
+          </a:prstGeom>
+        </p:spPr>
+      </p:pic>
+    </p:spTree>
+    <p:extLst>
+      <p:ext uri="{BB962C8B-B14F-4D97-AF65-F5344CB8AC3E}">
+        <p14:creationId xmlns:p14="http://schemas.microsoft.com/office/powerpoint/2010/main" val="946038184"/>
+      </p:ext>
+    </p:extLst>
+  </p:cSld>
+  <p:clrMapOvr>
+    <a:masterClrMapping/>
+  </p:clrMapOvr>
+</p:sld>
+</file>
+
+<file path=ppt/slides/slide9.xml><?xml version="1.0" encoding="utf-8"?>
+<p:sld xmlns:a="http://schemas.openxmlformats.org/drawingml/2006/main" xmlns:r="http://schemas.openxmlformats.org/officeDocument/2006/relationships" xmlns:p="http://schemas.openxmlformats.org/presentationml/2006/main">
+  <p:cSld>
+    <p:spTree>
+      <p:nvGrpSpPr>
+        <p:cNvPr id="1" name=""/>
+        <p:cNvGrpSpPr/>
+        <p:nvPr/>
+      </p:nvGrpSpPr>
+      <p:grpSpPr>
+        <a:xfrm>
+          <a:off x="0" y="0"/>
+          <a:ext cx="0" cy="0"/>
+          <a:chOff x="0" y="0"/>
+          <a:chExt cx="0" cy="0"/>
+        </a:xfrm>
+      </p:grpSpPr>
+      <p:sp>
+        <p:nvSpPr>
+          <p:cNvPr id="2" name="Rectangle 1"/>
+          <p:cNvSpPr/>
+          <p:nvPr/>
+        </p:nvSpPr>
+        <p:spPr>
+          <a:xfrm>
+            <a:off x="365760" y="0"/>
+            <a:ext cx="137160" cy="6858000"/>
+          </a:xfrm>
+          <a:prstGeom prst="rect">
+            <a:avLst/>
+          </a:prstGeom>
+          <a:solidFill>
+            <a:srgbClr val="FFB800"/>
+          </a:solidFill>
+          <a:ln>
+            <a:noFill/>
+          </a:ln>
+        </p:spPr>
+        <p:style>
+          <a:lnRef idx="1">
+            <a:schemeClr val="accent1"/>
+          </a:lnRef>
+          <a:fillRef idx="3">
+            <a:schemeClr val="accent1"/>
+          </a:fillRef>
+          <a:effectRef idx="2">
+            <a:schemeClr val="accent1"/>
+          </a:effectRef>
+          <a:fontRef idx="minor">
+            <a:schemeClr val="lt1"/>
+          </a:fontRef>
+        </p:style>
+        <p:txBody>
+          <a:bodyPr rtlCol="0" anchor="ctr"/>
+          <a:lstStyle/>
+          <a:p>
+            <a:pPr algn="ctr"/>
+            <a:endParaRPr/>
+          </a:p>
+        </p:txBody>
+      </p:sp>
+      <p:sp>
+        <p:nvSpPr>
+          <p:cNvPr id="3" name="TextBox 2"/>
+          <p:cNvSpPr txBox="1"/>
+          <p:nvPr/>
+        </p:nvSpPr>
+        <p:spPr>
+          <a:xfrm>
+            <a:off x="640080" y="182880"/>
+            <a:ext cx="7772400" cy="731520"/>
+          </a:xfrm>
+          <a:prstGeom prst="rect">
+            <a:avLst/>
+          </a:prstGeom>
+          <a:noFill/>
+        </p:spPr>
+        <p:txBody>
+          <a:bodyPr wrap="none">
+            <a:spAutoFit/>
+          </a:bodyPr>
+          <a:lstStyle/>
+          <a:p>
+            <a:pPr>
+              <a:defRPr sz="2600" b="1">
+                <a:solidFill>
+                  <a:srgbClr val="FFFFFF"/>
+                </a:solidFill>
+                <a:latin typeface="Segoe UI"/>
+              </a:defRPr>
+            </a:pPr>
+            <a:r>
+              <a:t>5. Khám phá Tác động Dị thể (HTE)</a:t>
+            </a:r>
+          </a:p>
+        </p:txBody>
+      </p:sp>
+      <p:sp>
+        <p:nvSpPr>
+          <p:cNvPr id="4" name="TextBox 3"/>
+          <p:cNvSpPr txBox="1"/>
+          <p:nvPr/>
+        </p:nvSpPr>
+        <p:spPr>
+          <a:xfrm>
+            <a:off x="640080" y="731520"/>
+            <a:ext cx="7772400" cy="365760"/>
+          </a:xfrm>
+          <a:prstGeom prst="rect">
+            <a:avLst/>
+          </a:prstGeom>
+          <a:noFill/>
+        </p:spPr>
+        <p:txBody>
+          <a:bodyPr wrap="none">
+            <a:spAutoFit/>
+          </a:bodyPr>
+          <a:lstStyle/>
+          <a:p>
+            <a:pPr>
+              <a:defRPr sz="1300">
+                <a:solidFill>
+                  <a:srgbClr val="FFB800"/>
+                </a:solidFill>
+                <a:latin typeface="Segoe UI"/>
+              </a:defRPr>
+            </a:pPr>
+            <a:r>
+              <a:t>Causal Trees</a:t>
+            </a:r>
+          </a:p>
+        </p:txBody>
+      </p:sp>
+      <p:sp>
+        <p:nvSpPr>
+          <p:cNvPr id="5" name="Rectangle 4"/>
+          <p:cNvSpPr/>
+          <p:nvPr/>
+        </p:nvSpPr>
+        <p:spPr>
+          <a:xfrm>
+            <a:off x="640080" y="1188720"/>
+            <a:ext cx="2286000" cy="36576"/>
+          </a:xfrm>
+          <a:prstGeom prst="rect">
+            <a:avLst/>
+          </a:prstGeom>
+          <a:solidFill>
+            <a:srgbClr val="FFB800"/>
+          </a:solidFill>
+          <a:ln>
+            <a:noFill/>
+          </a:ln>
+        </p:spPr>
+        <p:style>
+          <a:lnRef idx="1">
+            <a:schemeClr val="accent1"/>
+          </a:lnRef>
+          <a:fillRef idx="3">
+            <a:schemeClr val="accent1"/>
+          </a:fillRef>
+          <a:effectRef idx="2">
+            <a:schemeClr val="accent1"/>
+          </a:effectRef>
+          <a:fontRef idx="minor">
+            <a:schemeClr val="lt1"/>
+          </a:fontRef>
+        </p:style>
+        <p:txBody>
+          <a:bodyPr rtlCol="0" anchor="ctr"/>
+          <a:lstStyle/>
+          <a:p>
+            <a:pPr algn="ctr"/>
+            <a:endParaRPr/>
+          </a:p>
+        </p:txBody>
+      </p:sp>
+      <p:sp>
+        <p:nvSpPr>
+          <p:cNvPr id="6" name="Rectangle 5"/>
+          <p:cNvSpPr/>
+          <p:nvPr/>
+        </p:nvSpPr>
+        <p:spPr>
+          <a:xfrm>
+            <a:off x="365760" y="6217920"/>
+            <a:ext cx="8778240" cy="365760"/>
+          </a:xfrm>
+          <a:prstGeom prst="rect">
+            <a:avLst/>
+          </a:prstGeom>
+          <a:solidFill>
+            <a:srgbClr val="1C4E80"/>
+          </a:solidFill>
+          <a:ln>
+            <a:noFill/>
+          </a:ln>
+        </p:spPr>
+        <p:style>
+          <a:lnRef idx="1">
+            <a:schemeClr val="accent1"/>
+          </a:lnRef>
+          <a:fillRef idx="3">
+            <a:schemeClr val="accent1"/>
+          </a:fillRef>
+          <a:effectRef idx="2">
+            <a:schemeClr val="accent1"/>
+          </a:effectRef>
+          <a:fontRef idx="minor">
+            <a:schemeClr val="lt1"/>
+          </a:fontRef>
+        </p:style>
+        <p:txBody>
+          <a:bodyPr rtlCol="0" anchor="ctr"/>
+          <a:lstStyle/>
+          <a:p>
+            <a:pPr algn="ctr"/>
+            <a:endParaRPr/>
+          </a:p>
+        </p:txBody>
+      </p:sp>
+      <p:sp>
+        <p:nvSpPr>
+          <p:cNvPr id="7" name="TextBox 6"/>
+          <p:cNvSpPr txBox="1"/>
+          <p:nvPr/>
+        </p:nvSpPr>
+        <p:spPr>
+          <a:xfrm>
+            <a:off x="457200" y="6217920"/>
+            <a:ext cx="7315200" cy="365760"/>
+          </a:xfrm>
+          <a:prstGeom prst="rect">
+            <a:avLst/>
+          </a:prstGeom>
+          <a:noFill/>
+        </p:spPr>
+        <p:txBody>
+          <a:bodyPr wrap="none" anchor="ctr">
+            <a:spAutoFit/>
+          </a:bodyPr>
+          <a:lstStyle/>
+          <a:p>
+            <a:pPr>
+              <a:defRPr sz="1000">
+                <a:solidFill>
+                  <a:srgbClr val="FFFFFF"/>
+                </a:solidFill>
+                <a:latin typeface="Segoe UI"/>
+              </a:defRPr>
+            </a:pPr>
+            <a:r>
+              <a:t>GSM Promotion Experimentation • Báo cáo Chuyên môn • Data Science Team</a:t>
+            </a:r>
+          </a:p>
+        </p:txBody>
+      </p:sp>
+      <p:sp>
+        <p:nvSpPr>
+          <p:cNvPr id="8" name="Rectangle 7"/>
+          <p:cNvSpPr/>
+          <p:nvPr/>
+        </p:nvSpPr>
+        <p:spPr>
+          <a:xfrm>
+            <a:off x="365760" y="6583680"/>
+            <a:ext cx="8778240" cy="274320"/>
+          </a:xfrm>
+          <a:prstGeom prst="rect">
+            <a:avLst/>
+          </a:prstGeom>
+          <a:solidFill>
+            <a:srgbClr val="070D17"/>
+          </a:solidFill>
+          <a:ln>
+            <a:noFill/>
+          </a:ln>
+        </p:spPr>
+        <p:style>
+          <a:lnRef idx="1">
+            <a:schemeClr val="accent1"/>
+          </a:lnRef>
+          <a:fillRef idx="3">
+            <a:schemeClr val="accent1"/>
+          </a:fillRef>
+          <a:effectRef idx="2">
+            <a:schemeClr val="accent1"/>
+          </a:effectRef>
+          <a:fontRef idx="minor">
+            <a:schemeClr val="lt1"/>
+          </a:fontRef>
+        </p:style>
+        <p:txBody>
+          <a:bodyPr rtlCol="0" anchor="ctr"/>
+          <a:lstStyle/>
+          <a:p>
+            <a:pPr algn="ctr"/>
+            <a:endParaRPr/>
+          </a:p>
+        </p:txBody>
+      </p:sp>
+      <p:sp>
+        <p:nvSpPr>
+          <p:cNvPr id="9" name="TextBox 8"/>
+          <p:cNvSpPr txBox="1"/>
+          <p:nvPr/>
+        </p:nvSpPr>
+        <p:spPr>
+          <a:xfrm>
+            <a:off x="457200" y="6583680"/>
+            <a:ext cx="4572000" cy="274320"/>
+          </a:xfrm>
+          <a:prstGeom prst="rect">
+            <a:avLst/>
+          </a:prstGeom>
+          <a:noFill/>
+        </p:spPr>
+        <p:txBody>
+          <a:bodyPr wrap="none" anchor="ctr">
+            <a:spAutoFit/>
+          </a:bodyPr>
+          <a:lstStyle/>
+          <a:p>
+            <a:pPr>
+              <a:defRPr sz="900">
+                <a:solidFill>
+                  <a:srgbClr val="38BDF8"/>
+                </a:solidFill>
+                <a:latin typeface="Segoe UI"/>
+              </a:defRPr>
+            </a:pPr>
+            <a:r>
+              <a:t>Project: Uplift Modeling &amp; Causal Inference</a:t>
+            </a:r>
+          </a:p>
+        </p:txBody>
+      </p:sp>
+      <p:sp>
+        <p:nvSpPr>
+          <p:cNvPr id="10" name="TextBox 9"/>
+          <p:cNvSpPr txBox="1"/>
+          <p:nvPr/>
+        </p:nvSpPr>
+        <p:spPr>
+          <a:xfrm>
+            <a:off x="7772400" y="6583680"/>
+            <a:ext cx="1280160" cy="274320"/>
+          </a:xfrm>
+          <a:prstGeom prst="rect">
+            <a:avLst/>
+          </a:prstGeom>
+          <a:noFill/>
+        </p:spPr>
+        <p:txBody>
+          <a:bodyPr wrap="none" anchor="ctr">
+            <a:spAutoFit/>
+          </a:bodyPr>
+          <a:lstStyle/>
+          <a:p>
+            <a:pPr algn="r">
+              <a:defRPr sz="900" b="1">
+                <a:solidFill>
+                  <a:srgbClr val="FFFFFF"/>
+                </a:solidFill>
+                <a:latin typeface="Segoe UI"/>
+              </a:defRPr>
+            </a:pPr>
+            <a:r>
+              <a:t>05 / 05</a:t>
+            </a:r>
+          </a:p>
+        </p:txBody>
+      </p:sp>
+      <p:sp>
+        <p:nvSpPr>
+          <p:cNvPr id="11" name="Rounded Rectangle 10"/>
+          <p:cNvSpPr/>
+          <p:nvPr/>
+        </p:nvSpPr>
+        <p:spPr>
+          <a:xfrm>
+            <a:off x="640080" y="1463040"/>
+            <a:ext cx="3840480" cy="2240280"/>
+          </a:xfrm>
+          <a:prstGeom prst="roundRect">
+            <a:avLst/>
+          </a:prstGeom>
+          <a:solidFill>
+            <a:srgbClr val="172545"/>
+          </a:solidFill>
+          <a:ln>
+            <a:noFill/>
+          </a:ln>
+        </p:spPr>
+        <p:style>
+          <a:lnRef idx="1">
+            <a:schemeClr val="accent1"/>
+          </a:lnRef>
+          <a:fillRef idx="3">
+            <a:schemeClr val="accent1"/>
+          </a:fillRef>
+          <a:effectRef idx="2">
+            <a:schemeClr val="accent1"/>
+          </a:effectRef>
+          <a:fontRef idx="minor">
+            <a:schemeClr val="lt1"/>
+          </a:fontRef>
+        </p:style>
+        <p:txBody>
+          <a:bodyPr rtlCol="0" anchor="ctr"/>
+          <a:lstStyle/>
+          <a:p>
+            <a:pPr algn="ctr"/>
+            <a:endParaRPr/>
+          </a:p>
+        </p:txBody>
+      </p:sp>
+      <p:sp>
+        <p:nvSpPr>
+          <p:cNvPr id="12" name="Rectangle 11"/>
+          <p:cNvSpPr/>
+          <p:nvPr/>
+        </p:nvSpPr>
+        <p:spPr>
+          <a:xfrm>
+            <a:off x="777240" y="1828800"/>
+            <a:ext cx="3566160" cy="36576"/>
+          </a:xfrm>
+          <a:prstGeom prst="rect">
+            <a:avLst/>
+          </a:prstGeom>
+          <a:solidFill>
+            <a:srgbClr val="F472B6"/>
+          </a:solidFill>
+          <a:ln>
+            <a:noFill/>
+          </a:ln>
+        </p:spPr>
+        <p:style>
+          <a:lnRef idx="1">
+            <a:schemeClr val="accent1"/>
+          </a:lnRef>
+          <a:fillRef idx="3">
+            <a:schemeClr val="accent1"/>
+          </a:fillRef>
+          <a:effectRef idx="2">
+            <a:schemeClr val="accent1"/>
+          </a:effectRef>
+          <a:fontRef idx="minor">
+            <a:schemeClr val="lt1"/>
+          </a:fontRef>
+        </p:style>
+        <p:txBody>
+          <a:bodyPr rtlCol="0" anchor="ctr"/>
+          <a:lstStyle/>
+          <a:p>
+            <a:pPr algn="ctr"/>
+            <a:endParaRPr/>
+          </a:p>
+        </p:txBody>
+      </p:sp>
+      <p:sp>
+        <p:nvSpPr>
+          <p:cNvPr id="13" name="TextBox 12"/>
+          <p:cNvSpPr txBox="1"/>
+          <p:nvPr/>
+        </p:nvSpPr>
+        <p:spPr>
+          <a:xfrm>
+            <a:off x="685800" y="1508760"/>
+            <a:ext cx="3749040" cy="365760"/>
+          </a:xfrm>
+          <a:prstGeom prst="rect">
+            <a:avLst/>
+          </a:prstGeom>
+          <a:noFill/>
+        </p:spPr>
+        <p:txBody>
+          <a:bodyPr wrap="square">
+            <a:spAutoFit/>
+          </a:bodyPr>
+          <a:lstStyle/>
+          <a:p>
+            <a:pPr>
+              <a:defRPr sz="1600" b="1">
+                <a:solidFill>
+                  <a:srgbClr val="F472B6"/>
+                </a:solidFill>
+                <a:latin typeface="Segoe UI"/>
+              </a:defRPr>
+            </a:pPr>
+            <a:r>
+              <a:t>Heterogeneous Effect</a:t>
+            </a:r>
+          </a:p>
+        </p:txBody>
+      </p:sp>
+      <p:sp>
+        <p:nvSpPr>
+          <p:cNvPr id="14" name="TextBox 13"/>
+          <p:cNvSpPr txBox="1"/>
+          <p:nvPr/>
+        </p:nvSpPr>
+        <p:spPr>
+          <a:xfrm>
+            <a:off x="685800" y="1874520"/>
+            <a:ext cx="3749040" cy="1783080"/>
+          </a:xfrm>
+          <a:prstGeom prst="rect">
+            <a:avLst/>
+          </a:prstGeom>
+          <a:noFill/>
+        </p:spPr>
+        <p:txBody>
+          <a:bodyPr wrap="square">
+            <a:spAutoFit/>
+          </a:bodyPr>
+          <a:lstStyle/>
+          <a:p>
+            <a:pPr>
+              <a:spcAft>
+                <a:spcPts val="400"/>
+              </a:spcAft>
+              <a:defRPr sz="1400">
+                <a:solidFill>
+                  <a:srgbClr val="FFFFFF"/>
+                </a:solidFill>
+                <a:latin typeface="Segoe UI"/>
+              </a:defRPr>
+            </a:pPr>
+            <a:r>
+              <a:t>• Tác động của Voucher không phân bổ đều. Sẽ có nhóm cực kỳ nhạy cảm và nhóm hoàn toàn thờ ơ.</a:t>
+            </a:r>
+          </a:p>
+        </p:txBody>
+      </p:sp>
+      <p:sp>
+        <p:nvSpPr>
+          <p:cNvPr id="15" name="Rounded Rectangle 14"/>
+          <p:cNvSpPr/>
+          <p:nvPr/>
+        </p:nvSpPr>
+        <p:spPr>
+          <a:xfrm>
+            <a:off x="640080" y="3840480"/>
+            <a:ext cx="3840480" cy="2240280"/>
+          </a:xfrm>
+          <a:prstGeom prst="roundRect">
+            <a:avLst/>
+          </a:prstGeom>
+          <a:solidFill>
+            <a:srgbClr val="172545"/>
+          </a:solidFill>
+          <a:ln>
+            <a:noFill/>
+          </a:ln>
+        </p:spPr>
+        <p:style>
+          <a:lnRef idx="1">
+            <a:schemeClr val="accent1"/>
+          </a:lnRef>
+          <a:fillRef idx="3">
+            <a:schemeClr val="accent1"/>
+          </a:fillRef>
+          <a:effectRef idx="2">
+            <a:schemeClr val="accent1"/>
+          </a:effectRef>
+          <a:fontRef idx="minor">
+            <a:schemeClr val="lt1"/>
+          </a:fontRef>
+        </p:style>
+        <p:txBody>
+          <a:bodyPr rtlCol="0" anchor="ctr"/>
+          <a:lstStyle/>
+          <a:p>
+            <a:pPr algn="ctr"/>
+            <a:endParaRPr/>
+          </a:p>
+        </p:txBody>
+      </p:sp>
+      <p:sp>
+        <p:nvSpPr>
+          <p:cNvPr id="16" name="Rectangle 15"/>
+          <p:cNvSpPr/>
+          <p:nvPr/>
+        </p:nvSpPr>
+        <p:spPr>
+          <a:xfrm>
+            <a:off x="777240" y="4206240"/>
+            <a:ext cx="3566160" cy="36576"/>
+          </a:xfrm>
+          <a:prstGeom prst="rect">
+            <a:avLst/>
+          </a:prstGeom>
+          <a:solidFill>
+            <a:srgbClr val="34D399"/>
+          </a:solidFill>
+          <a:ln>
+            <a:noFill/>
+          </a:ln>
+        </p:spPr>
+        <p:style>
+          <a:lnRef idx="1">
+            <a:schemeClr val="accent1"/>
+          </a:lnRef>
+          <a:fillRef idx="3">
+            <a:schemeClr val="accent1"/>
+          </a:fillRef>
+          <a:effectRef idx="2">
+            <a:schemeClr val="accent1"/>
+          </a:effectRef>
+          <a:fontRef idx="minor">
+            <a:schemeClr val="lt1"/>
+          </a:fontRef>
+        </p:style>
+        <p:txBody>
+          <a:bodyPr rtlCol="0" anchor="ctr"/>
+          <a:lstStyle/>
+          <a:p>
+            <a:pPr algn="ctr"/>
+            <a:endParaRPr/>
+          </a:p>
+        </p:txBody>
+      </p:sp>
+      <p:sp>
+        <p:nvSpPr>
+          <p:cNvPr id="17" name="TextBox 16"/>
+          <p:cNvSpPr txBox="1"/>
+          <p:nvPr/>
+        </p:nvSpPr>
+        <p:spPr>
+          <a:xfrm>
+            <a:off x="685800" y="3886200"/>
+            <a:ext cx="3749040" cy="365760"/>
+          </a:xfrm>
+          <a:prstGeom prst="rect">
+            <a:avLst/>
+          </a:prstGeom>
+          <a:noFill/>
+        </p:spPr>
+        <p:txBody>
+          <a:bodyPr wrap="square">
+            <a:spAutoFit/>
+          </a:bodyPr>
+          <a:lstStyle/>
+          <a:p>
+            <a:pPr>
+              <a:defRPr sz="1600" b="1">
+                <a:solidFill>
+                  <a:srgbClr val="34D399"/>
+                </a:solidFill>
+                <a:latin typeface="Segoe UI"/>
+              </a:defRPr>
+            </a:pPr>
+            <a:r>
+              <a:t>Cây Quyết định Nhân quả</a:t>
+            </a:r>
+          </a:p>
+        </p:txBody>
+      </p:sp>
+      <p:sp>
+        <p:nvSpPr>
+          <p:cNvPr id="18" name="TextBox 17"/>
+          <p:cNvSpPr txBox="1"/>
+          <p:nvPr/>
+        </p:nvSpPr>
+        <p:spPr>
+          <a:xfrm>
+            <a:off x="685800" y="4251960"/>
+            <a:ext cx="3749040" cy="1783080"/>
+          </a:xfrm>
+          <a:prstGeom prst="rect">
+            <a:avLst/>
+          </a:prstGeom>
+          <a:noFill/>
+        </p:spPr>
+        <p:txBody>
+          <a:bodyPr wrap="square">
+            <a:spAutoFit/>
+          </a:bodyPr>
+          <a:lstStyle/>
+          <a:p>
+            <a:pPr>
+              <a:spcAft>
+                <a:spcPts val="400"/>
+              </a:spcAft>
+              <a:defRPr sz="1400">
+                <a:solidFill>
+                  <a:srgbClr val="FFFFFF"/>
+                </a:solidFill>
+                <a:latin typeface="Segoe UI"/>
+              </a:defRPr>
+            </a:pPr>
+            <a:r>
+              <a:t>• Thuật toán tự động tìm ra các nhánh (Segments) có CATE (Conditional ATE) cao nhất để nhắm mục tiêu.</a:t>
+            </a:r>
+          </a:p>
+        </p:txBody>
+      </p:sp>
+      <p:pic>
+        <p:nvPicPr>
+          <p:cNvPr id="19" name="Picture 18" descr="week4_ab_testing_2.png"/>
+          <p:cNvPicPr>
+            <a:picLocks noChangeAspect="1"/>
+          </p:cNvPicPr>
+          <p:nvPr/>
+        </p:nvPicPr>
+        <p:blipFill>
+          <a:blip r:embed="rId2"/>
+          <a:stretch>
+            <a:fillRect/>
+          </a:stretch>
+        </p:blipFill>
+        <p:spPr>
+          <a:xfrm>
+            <a:off x="4572000" y="2286000"/>
+            <a:ext cx="4206240" cy="2402808"/>
+          </a:xfrm>
+          <a:prstGeom prst="rect">
+            <a:avLst/>
+          </a:prstGeom>
+        </p:spPr>
+      </p:pic>
+    </p:spTree>
+    <p:extLst>
+      <p:ext uri="{BB962C8B-B14F-4D97-AF65-F5344CB8AC3E}">
+        <p14:creationId xmlns:p14="http://schemas.microsoft.com/office/powerpoint/2010/main" val="4268617702"/>
+      </p:ext>
+    </p:extLst>
   </p:cSld>
   <p:clrMapOvr>
     <a:masterClrMapping/>

</xml_diff>

<commit_message>
Replace PPTX charts with updated figures via COM Interop
</commit_message>
<xml_diff>
--- a/docs/Week4_AA_AB_Testing_Summary.pptx
+++ b/docs/Week4_AA_AB_Testing_Summary.pptx
@@ -310,7 +310,7 @@
           <a:p>
             <a:fld id="{5BCAD085-E8A6-8845-BD4E-CB4CCA059FC4}" type="datetimeFigureOut">
               <a:rPr lang="en-US" smtClean="0"/>
-              <a:t>8/10/2026</a:t>
+              <a:t>8/11/2026</a:t>
             </a:fld>
             <a:endParaRPr lang="en-US"/>
           </a:p>
@@ -478,7 +478,7 @@
           <a:p>
             <a:fld id="{5BCAD085-E8A6-8845-BD4E-CB4CCA059FC4}" type="datetimeFigureOut">
               <a:rPr lang="en-US" smtClean="0"/>
-              <a:t>8/10/2026</a:t>
+              <a:t>8/11/2026</a:t>
             </a:fld>
             <a:endParaRPr lang="en-US"/>
           </a:p>
@@ -656,7 +656,7 @@
           <a:p>
             <a:fld id="{5BCAD085-E8A6-8845-BD4E-CB4CCA059FC4}" type="datetimeFigureOut">
               <a:rPr lang="en-US" smtClean="0"/>
-              <a:t>8/10/2026</a:t>
+              <a:t>8/11/2026</a:t>
             </a:fld>
             <a:endParaRPr lang="en-US"/>
           </a:p>
@@ -824,7 +824,7 @@
           <a:p>
             <a:fld id="{5BCAD085-E8A6-8845-BD4E-CB4CCA059FC4}" type="datetimeFigureOut">
               <a:rPr lang="en-US" smtClean="0"/>
-              <a:t>8/10/2026</a:t>
+              <a:t>8/11/2026</a:t>
             </a:fld>
             <a:endParaRPr lang="en-US"/>
           </a:p>
@@ -1069,7 +1069,7 @@
           <a:p>
             <a:fld id="{5BCAD085-E8A6-8845-BD4E-CB4CCA059FC4}" type="datetimeFigureOut">
               <a:rPr lang="en-US" smtClean="0"/>
-              <a:t>8/10/2026</a:t>
+              <a:t>8/11/2026</a:t>
             </a:fld>
             <a:endParaRPr lang="en-US"/>
           </a:p>
@@ -1354,7 +1354,7 @@
           <a:p>
             <a:fld id="{5BCAD085-E8A6-8845-BD4E-CB4CCA059FC4}" type="datetimeFigureOut">
               <a:rPr lang="en-US" smtClean="0"/>
-              <a:t>8/10/2026</a:t>
+              <a:t>8/11/2026</a:t>
             </a:fld>
             <a:endParaRPr lang="en-US"/>
           </a:p>
@@ -1773,7 +1773,7 @@
           <a:p>
             <a:fld id="{5BCAD085-E8A6-8845-BD4E-CB4CCA059FC4}" type="datetimeFigureOut">
               <a:rPr lang="en-US" smtClean="0"/>
-              <a:t>8/10/2026</a:t>
+              <a:t>8/11/2026</a:t>
             </a:fld>
             <a:endParaRPr lang="en-US"/>
           </a:p>
@@ -1890,7 +1890,7 @@
           <a:p>
             <a:fld id="{5BCAD085-E8A6-8845-BD4E-CB4CCA059FC4}" type="datetimeFigureOut">
               <a:rPr lang="en-US" smtClean="0"/>
-              <a:t>8/10/2026</a:t>
+              <a:t>8/11/2026</a:t>
             </a:fld>
             <a:endParaRPr lang="en-US"/>
           </a:p>
@@ -1985,7 +1985,7 @@
           <a:p>
             <a:fld id="{5BCAD085-E8A6-8845-BD4E-CB4CCA059FC4}" type="datetimeFigureOut">
               <a:rPr lang="en-US" smtClean="0"/>
-              <a:t>8/10/2026</a:t>
+              <a:t>8/11/2026</a:t>
             </a:fld>
             <a:endParaRPr lang="en-US"/>
           </a:p>
@@ -2260,7 +2260,7 @@
           <a:p>
             <a:fld id="{5BCAD085-E8A6-8845-BD4E-CB4CCA059FC4}" type="datetimeFigureOut">
               <a:rPr lang="en-US" smtClean="0"/>
-              <a:t>8/10/2026</a:t>
+              <a:t>8/11/2026</a:t>
             </a:fld>
             <a:endParaRPr lang="en-US"/>
           </a:p>
@@ -2512,7 +2512,7 @@
           <a:p>
             <a:fld id="{5BCAD085-E8A6-8845-BD4E-CB4CCA059FC4}" type="datetimeFigureOut">
               <a:rPr lang="en-US" smtClean="0"/>
-              <a:t>8/10/2026</a:t>
+              <a:t>8/11/2026</a:t>
             </a:fld>
             <a:endParaRPr lang="en-US"/>
           </a:p>
@@ -2723,7 +2723,7 @@
           <a:p>
             <a:fld id="{5BCAD085-E8A6-8845-BD4E-CB4CCA059FC4}" type="datetimeFigureOut">
               <a:rPr lang="en-US" smtClean="0"/>
-              <a:t>8/10/2026</a:t>
+              <a:t>8/11/2026</a:t>
             </a:fld>
             <a:endParaRPr lang="en-US"/>
           </a:p>
@@ -7561,9 +7561,15 @@
       </p:sp>
       <p:pic>
         <p:nvPicPr>
-          <p:cNvPr id="19" name="Picture 18" descr="week4_ab_testing_0.png"/>
+          <p:cNvPr id="21" name="Picture 20">
+            <a:extLst>
+              <a:ext uri="{FF2B5EF4-FFF2-40B4-BE49-F238E27FC236}">
+                <a16:creationId xmlns:a16="http://schemas.microsoft.com/office/drawing/2014/main" id="{09DEAACA-E72A-F50F-A01F-3F2F5D19B010}"/>
+              </a:ext>
+            </a:extLst>
+          </p:cNvPr>
           <p:cNvPicPr>
-            <a:picLocks noChangeAspect="1"/>
+            <a:picLocks/>
           </p:cNvPicPr>
           <p:nvPr/>
         </p:nvPicPr>
@@ -8297,9 +8303,15 @@
       </p:sp>
       <p:pic>
         <p:nvPicPr>
-          <p:cNvPr id="19" name="Picture 18" descr="week4_ab_testing_1.png"/>
+          <p:cNvPr id="21" name="Picture 20">
+            <a:extLst>
+              <a:ext uri="{FF2B5EF4-FFF2-40B4-BE49-F238E27FC236}">
+                <a16:creationId xmlns:a16="http://schemas.microsoft.com/office/drawing/2014/main" id="{55EC8432-B28A-A35D-9CE8-450BA360DE20}"/>
+              </a:ext>
+            </a:extLst>
+          </p:cNvPr>
           <p:cNvPicPr>
-            <a:picLocks noChangeAspect="1"/>
+            <a:picLocks/>
           </p:cNvPicPr>
           <p:nvPr/>
         </p:nvPicPr>
@@ -9033,9 +9045,15 @@
       </p:sp>
       <p:pic>
         <p:nvPicPr>
-          <p:cNvPr id="19" name="Picture 18" descr="week4_ab_testing_2.png"/>
+          <p:cNvPr id="21" name="Picture 20">
+            <a:extLst>
+              <a:ext uri="{FF2B5EF4-FFF2-40B4-BE49-F238E27FC236}">
+                <a16:creationId xmlns:a16="http://schemas.microsoft.com/office/drawing/2014/main" id="{D376AA35-6A87-9217-EF6E-A0A93B31FF1A}"/>
+              </a:ext>
+            </a:extLst>
+          </p:cNvPr>
           <p:cNvPicPr>
-            <a:picLocks noChangeAspect="1"/>
+            <a:picLocks/>
           </p:cNvPicPr>
           <p:nvPr/>
         </p:nvPicPr>

</xml_diff>

<commit_message>
Extract new images from AB test notebook and inject them into PPTX via COM
</commit_message>
<xml_diff>
--- a/docs/Week4_AA_AB_Testing_Summary.pptx
+++ b/docs/Week4_AA_AB_Testing_Summary.pptx
@@ -7561,10 +7561,10 @@
       </p:sp>
       <p:pic>
         <p:nvPicPr>
-          <p:cNvPr id="21" name="Picture 20">
+          <p:cNvPr id="20" name="Picture 19">
             <a:extLst>
               <a:ext uri="{FF2B5EF4-FFF2-40B4-BE49-F238E27FC236}">
-                <a16:creationId xmlns:a16="http://schemas.microsoft.com/office/drawing/2014/main" id="{09DEAACA-E72A-F50F-A01F-3F2F5D19B010}"/>
+                <a16:creationId xmlns:a16="http://schemas.microsoft.com/office/drawing/2014/main" id="{7FA9759F-5050-24D0-A001-29BA7BDA5A2D}"/>
               </a:ext>
             </a:extLst>
           </p:cNvPr>
@@ -8303,10 +8303,10 @@
       </p:sp>
       <p:pic>
         <p:nvPicPr>
-          <p:cNvPr id="21" name="Picture 20">
+          <p:cNvPr id="20" name="Picture 19">
             <a:extLst>
               <a:ext uri="{FF2B5EF4-FFF2-40B4-BE49-F238E27FC236}">
-                <a16:creationId xmlns:a16="http://schemas.microsoft.com/office/drawing/2014/main" id="{55EC8432-B28A-A35D-9CE8-450BA360DE20}"/>
+                <a16:creationId xmlns:a16="http://schemas.microsoft.com/office/drawing/2014/main" id="{6AD519B0-8F8B-01DF-1E79-B51A188B5408}"/>
               </a:ext>
             </a:extLst>
           </p:cNvPr>
@@ -9045,10 +9045,10 @@
       </p:sp>
       <p:pic>
         <p:nvPicPr>
-          <p:cNvPr id="21" name="Picture 20">
+          <p:cNvPr id="20" name="Picture 19">
             <a:extLst>
               <a:ext uri="{FF2B5EF4-FFF2-40B4-BE49-F238E27FC236}">
-                <a16:creationId xmlns:a16="http://schemas.microsoft.com/office/drawing/2014/main" id="{D376AA35-6A87-9217-EF6E-A0A93B31FF1A}"/>
+                <a16:creationId xmlns:a16="http://schemas.microsoft.com/office/drawing/2014/main" id="{A0D0333D-6384-F0B1-512C-C382D38DF8CA}"/>
               </a:ext>
             </a:extLst>
           </p:cNvPr>

</xml_diff>

<commit_message>
Fix PPTX title to include A/B and reduce font size to prevent overflow
</commit_message>
<xml_diff>
--- a/docs/Week4_AA_AB_Testing_Summary.pptx
+++ b/docs/Week4_AA_AB_Testing_Summary.pptx
@@ -3128,16 +3128,8 @@
           </a:bodyPr>
           <a:lstStyle/>
           <a:p>
-            <a:pPr algn="ctr">
-              <a:defRPr sz="3600" b="1">
-                <a:solidFill>
-                  <a:srgbClr val="FFFFFF"/>
-                </a:solidFill>
-                <a:latin typeface="Segoe UI"/>
-              </a:defRPr>
-            </a:pPr>
-            <a:r>
-              <a:t>BÁO CÁO TUẦN 5: A/A TESTING</a:t>
+            <a:r>
+              <a:t>BÁO CÁO TUẦN 4: A/A &amp; A/B TESTING</a:t>
             </a:r>
           </a:p>
         </p:txBody>
@@ -5361,7 +5353,7 @@
         <p:spPr>
           <a:xfrm>
             <a:off x="4892040" y="2286000"/>
-            <a:ext cx="3931920" cy="3383280"/>
+            <a:ext cx="3931920" cy="923330"/>
           </a:xfrm>
           <a:prstGeom prst="rect">
             <a:avLst/>
@@ -5375,7 +5367,300 @@
           <a:lstStyle/>
           <a:p>
             <a:r>
-              <a:t>• Tỷ lệ hệ thống kết luận nhầm "Có khác biệt" duy trì ở mức ~4.80% (Sát với ngưỡng lý tưởng 5%).</a:t>
+              <a:rPr dirty="0">
+                <a:solidFill>
+                  <a:schemeClr val="bg1"/>
+                </a:solidFill>
+              </a:rPr>
+              <a:t>• </a:t>
+            </a:r>
+            <a:r>
+              <a:rPr dirty="0" err="1">
+                <a:solidFill>
+                  <a:schemeClr val="bg1"/>
+                </a:solidFill>
+              </a:rPr>
+              <a:t>Tỷ</a:t>
+            </a:r>
+            <a:r>
+              <a:rPr dirty="0">
+                <a:solidFill>
+                  <a:schemeClr val="bg1"/>
+                </a:solidFill>
+              </a:rPr>
+              <a:t> </a:t>
+            </a:r>
+            <a:r>
+              <a:rPr dirty="0" err="1">
+                <a:solidFill>
+                  <a:schemeClr val="bg1"/>
+                </a:solidFill>
+              </a:rPr>
+              <a:t>lệ</a:t>
+            </a:r>
+            <a:r>
+              <a:rPr dirty="0">
+                <a:solidFill>
+                  <a:schemeClr val="bg1"/>
+                </a:solidFill>
+              </a:rPr>
+              <a:t> </a:t>
+            </a:r>
+            <a:r>
+              <a:rPr dirty="0" err="1">
+                <a:solidFill>
+                  <a:schemeClr val="bg1"/>
+                </a:solidFill>
+              </a:rPr>
+              <a:t>hệ</a:t>
+            </a:r>
+            <a:r>
+              <a:rPr dirty="0">
+                <a:solidFill>
+                  <a:schemeClr val="bg1"/>
+                </a:solidFill>
+              </a:rPr>
+              <a:t> </a:t>
+            </a:r>
+            <a:r>
+              <a:rPr dirty="0" err="1">
+                <a:solidFill>
+                  <a:schemeClr val="bg1"/>
+                </a:solidFill>
+              </a:rPr>
+              <a:t>thống</a:t>
+            </a:r>
+            <a:r>
+              <a:rPr dirty="0">
+                <a:solidFill>
+                  <a:schemeClr val="bg1"/>
+                </a:solidFill>
+              </a:rPr>
+              <a:t> </a:t>
+            </a:r>
+            <a:r>
+              <a:rPr dirty="0" err="1">
+                <a:solidFill>
+                  <a:schemeClr val="bg1"/>
+                </a:solidFill>
+              </a:rPr>
+              <a:t>kết</a:t>
+            </a:r>
+            <a:r>
+              <a:rPr dirty="0">
+                <a:solidFill>
+                  <a:schemeClr val="bg1"/>
+                </a:solidFill>
+              </a:rPr>
+              <a:t> </a:t>
+            </a:r>
+            <a:r>
+              <a:rPr dirty="0" err="1">
+                <a:solidFill>
+                  <a:schemeClr val="bg1"/>
+                </a:solidFill>
+              </a:rPr>
+              <a:t>luận</a:t>
+            </a:r>
+            <a:r>
+              <a:rPr dirty="0">
+                <a:solidFill>
+                  <a:schemeClr val="bg1"/>
+                </a:solidFill>
+              </a:rPr>
+              <a:t> </a:t>
+            </a:r>
+            <a:r>
+              <a:rPr dirty="0" err="1">
+                <a:solidFill>
+                  <a:schemeClr val="bg1"/>
+                </a:solidFill>
+              </a:rPr>
+              <a:t>nhầm</a:t>
+            </a:r>
+            <a:r>
+              <a:rPr dirty="0">
+                <a:solidFill>
+                  <a:schemeClr val="bg1"/>
+                </a:solidFill>
+              </a:rPr>
+              <a:t> "</a:t>
+            </a:r>
+            <a:r>
+              <a:rPr dirty="0" err="1">
+                <a:solidFill>
+                  <a:schemeClr val="bg1"/>
+                </a:solidFill>
+              </a:rPr>
+              <a:t>Có</a:t>
+            </a:r>
+            <a:r>
+              <a:rPr dirty="0">
+                <a:solidFill>
+                  <a:schemeClr val="bg1"/>
+                </a:solidFill>
+              </a:rPr>
+              <a:t> </a:t>
+            </a:r>
+            <a:r>
+              <a:rPr dirty="0" err="1">
+                <a:solidFill>
+                  <a:schemeClr val="bg1"/>
+                </a:solidFill>
+              </a:rPr>
+              <a:t>khác</a:t>
+            </a:r>
+            <a:r>
+              <a:rPr dirty="0">
+                <a:solidFill>
+                  <a:schemeClr val="bg1"/>
+                </a:solidFill>
+              </a:rPr>
+              <a:t> </a:t>
+            </a:r>
+            <a:r>
+              <a:rPr dirty="0" err="1">
+                <a:solidFill>
+                  <a:schemeClr val="bg1"/>
+                </a:solidFill>
+              </a:rPr>
+              <a:t>biệt</a:t>
+            </a:r>
+            <a:r>
+              <a:rPr dirty="0">
+                <a:solidFill>
+                  <a:schemeClr val="bg1"/>
+                </a:solidFill>
+              </a:rPr>
+              <a:t>" </a:t>
+            </a:r>
+            <a:r>
+              <a:rPr dirty="0" err="1">
+                <a:solidFill>
+                  <a:schemeClr val="bg1"/>
+                </a:solidFill>
+              </a:rPr>
+              <a:t>duy</a:t>
+            </a:r>
+            <a:r>
+              <a:rPr dirty="0">
+                <a:solidFill>
+                  <a:schemeClr val="bg1"/>
+                </a:solidFill>
+              </a:rPr>
+              <a:t> </a:t>
+            </a:r>
+            <a:r>
+              <a:rPr dirty="0" err="1">
+                <a:solidFill>
+                  <a:schemeClr val="bg1"/>
+                </a:solidFill>
+              </a:rPr>
+              <a:t>trì</a:t>
+            </a:r>
+            <a:r>
+              <a:rPr dirty="0">
+                <a:solidFill>
+                  <a:schemeClr val="bg1"/>
+                </a:solidFill>
+              </a:rPr>
+              <a:t> ở </a:t>
+            </a:r>
+            <a:r>
+              <a:rPr dirty="0" err="1">
+                <a:solidFill>
+                  <a:schemeClr val="bg1"/>
+                </a:solidFill>
+              </a:rPr>
+              <a:t>mức</a:t>
+            </a:r>
+            <a:r>
+              <a:rPr dirty="0">
+                <a:solidFill>
+                  <a:schemeClr val="bg1"/>
+                </a:solidFill>
+              </a:rPr>
+              <a:t> ~4.80% (</a:t>
+            </a:r>
+            <a:r>
+              <a:rPr dirty="0" err="1">
+                <a:solidFill>
+                  <a:schemeClr val="bg1"/>
+                </a:solidFill>
+              </a:rPr>
+              <a:t>Sát</a:t>
+            </a:r>
+            <a:r>
+              <a:rPr dirty="0">
+                <a:solidFill>
+                  <a:schemeClr val="bg1"/>
+                </a:solidFill>
+              </a:rPr>
+              <a:t> </a:t>
+            </a:r>
+            <a:r>
+              <a:rPr dirty="0" err="1">
+                <a:solidFill>
+                  <a:schemeClr val="bg1"/>
+                </a:solidFill>
+              </a:rPr>
+              <a:t>với</a:t>
+            </a:r>
+            <a:r>
+              <a:rPr dirty="0">
+                <a:solidFill>
+                  <a:schemeClr val="bg1"/>
+                </a:solidFill>
+              </a:rPr>
+              <a:t> </a:t>
+            </a:r>
+            <a:r>
+              <a:rPr dirty="0" err="1">
+                <a:solidFill>
+                  <a:schemeClr val="bg1"/>
+                </a:solidFill>
+              </a:rPr>
+              <a:t>ngưỡng</a:t>
+            </a:r>
+            <a:r>
+              <a:rPr dirty="0">
+                <a:solidFill>
+                  <a:schemeClr val="bg1"/>
+                </a:solidFill>
+              </a:rPr>
+              <a:t> </a:t>
+            </a:r>
+            <a:r>
+              <a:rPr dirty="0" err="1">
+                <a:solidFill>
+                  <a:schemeClr val="bg1"/>
+                </a:solidFill>
+              </a:rPr>
+              <a:t>lý</a:t>
+            </a:r>
+            <a:r>
+              <a:rPr dirty="0">
+                <a:solidFill>
+                  <a:schemeClr val="bg1"/>
+                </a:solidFill>
+              </a:rPr>
+              <a:t> </a:t>
+            </a:r>
+            <a:r>
+              <a:rPr dirty="0" err="1">
+                <a:solidFill>
+                  <a:schemeClr val="bg1"/>
+                </a:solidFill>
+              </a:rPr>
+              <a:t>tưởng</a:t>
+            </a:r>
+            <a:r>
+              <a:rPr dirty="0">
+                <a:solidFill>
+                  <a:schemeClr val="bg1"/>
+                </a:solidFill>
+              </a:rPr>
+              <a:t> 5%.</a:t>
             </a:r>
           </a:p>
         </p:txBody>
@@ -6647,6 +6932,7 @@
               </a:defRPr>
             </a:pPr>
             <a:r>
+              <a:rPr sz="1400"/>
               <a:t>• Kiểm tra độ cân bằng hệ thống (Sample Ratio, Covariates).</a:t>
             </a:r>
           </a:p>
@@ -6663,6 +6949,7 @@
               </a:defRPr>
             </a:pPr>
             <a:r>
+              <a:rPr sz="1400"/>
               <a:t>• Kỳ vọng P-value &gt; 0.05 (Không bác bỏ H0) để chứng minh hệ thống không bị lệch.</a:t>
             </a:r>
           </a:p>
@@ -6826,6 +7113,7 @@
               </a:defRPr>
             </a:pPr>
             <a:r>
+              <a:rPr sz="1400"/>
               <a:t>• Đo lường tác động lên chỉ số cốt lõi (Incremental Rides).</a:t>
             </a:r>
           </a:p>
@@ -6842,6 +7130,7 @@
               </a:defRPr>
             </a:pPr>
             <a:r>
+              <a:rPr sz="1400"/>
               <a:t>• Kỳ vọng P-value &lt; 0.05 (Bác bỏ H0) để chứng minh Voucher có hiệu quả.</a:t>
             </a:r>
           </a:p>

</xml_diff>

<commit_message>
Safely fix PPTX title and auto-fit to preserve font styling
</commit_message>
<xml_diff>
--- a/docs/Week4_AA_AB_Testing_Summary.pptx
+++ b/docs/Week4_AA_AB_Testing_Summary.pptx
@@ -3124,10 +3124,18 @@
         </p:spPr>
         <p:txBody>
           <a:bodyPr wrap="square" anchor="b">
-            <a:spAutoFit/>
-          </a:bodyPr>
-          <a:lstStyle/>
-          <a:p>
+            <a:normAutofit/>
+          </a:bodyPr>
+          <a:lstStyle/>
+          <a:p>
+            <a:pPr algn="ctr">
+              <a:defRPr sz="3600" b="1">
+                <a:solidFill>
+                  <a:srgbClr val="FFFFFF"/>
+                </a:solidFill>
+                <a:latin typeface="Segoe UI"/>
+              </a:defRPr>
+            </a:pPr>
             <a:r>
               <a:t>BÁO CÁO TUẦN 4: A/A &amp; A/B TESTING</a:t>
             </a:r>
@@ -3170,7 +3178,9 @@
           </a:fontRef>
         </p:style>
         <p:txBody>
-          <a:bodyPr rtlCol="0" anchor="ctr"/>
+          <a:bodyPr rtlCol="0" anchor="ctr" wrap="square">
+            <a:normAutofit/>
+          </a:bodyPr>
           <a:lstStyle/>
           <a:p>
             <a:pPr algn="ctr"/>
@@ -3195,8 +3205,8 @@
           <a:noFill/>
         </p:spPr>
         <p:txBody>
-          <a:bodyPr wrap="none" anchor="t">
-            <a:spAutoFit/>
+          <a:bodyPr wrap="square" anchor="t">
+            <a:normAutofit/>
           </a:bodyPr>
           <a:lstStyle/>
           <a:p>
@@ -3283,7 +3293,9 @@
           </a:fontRef>
         </p:style>
         <p:txBody>
-          <a:bodyPr rtlCol="0" anchor="ctr"/>
+          <a:bodyPr rtlCol="0" anchor="ctr" wrap="square">
+            <a:normAutofit/>
+          </a:bodyPr>
           <a:lstStyle/>
           <a:p>
             <a:pPr algn="ctr"/>
@@ -3308,8 +3320,8 @@
           <a:noFill/>
         </p:spPr>
         <p:txBody>
-          <a:bodyPr wrap="none">
-            <a:spAutoFit/>
+          <a:bodyPr wrap="square">
+            <a:normAutofit/>
           </a:bodyPr>
           <a:lstStyle/>
           <a:p>
@@ -3344,8 +3356,8 @@
           <a:noFill/>
         </p:spPr>
         <p:txBody>
-          <a:bodyPr wrap="none">
-            <a:spAutoFit/>
+          <a:bodyPr wrap="square">
+            <a:normAutofit/>
           </a:bodyPr>
           <a:lstStyle/>
           <a:p>
@@ -3399,7 +3411,9 @@
           </a:fontRef>
         </p:style>
         <p:txBody>
-          <a:bodyPr rtlCol="0" anchor="ctr"/>
+          <a:bodyPr rtlCol="0" anchor="ctr" wrap="square">
+            <a:normAutofit/>
+          </a:bodyPr>
           <a:lstStyle/>
           <a:p>
             <a:pPr algn="ctr"/>
@@ -3443,7 +3457,9 @@
           </a:fontRef>
         </p:style>
         <p:txBody>
-          <a:bodyPr rtlCol="0" anchor="ctr"/>
+          <a:bodyPr rtlCol="0" anchor="ctr" wrap="square">
+            <a:normAutofit/>
+          </a:bodyPr>
           <a:lstStyle/>
           <a:p>
             <a:pPr algn="ctr"/>
@@ -3468,8 +3484,8 @@
           <a:noFill/>
         </p:spPr>
         <p:txBody>
-          <a:bodyPr wrap="none" anchor="ctr">
-            <a:spAutoFit/>
+          <a:bodyPr wrap="square" anchor="ctr">
+            <a:normAutofit/>
           </a:bodyPr>
           <a:lstStyle/>
           <a:p>
@@ -3523,7 +3539,9 @@
           </a:fontRef>
         </p:style>
         <p:txBody>
-          <a:bodyPr rtlCol="0" anchor="ctr"/>
+          <a:bodyPr rtlCol="0" anchor="ctr" wrap="square">
+            <a:normAutofit/>
+          </a:bodyPr>
           <a:lstStyle/>
           <a:p>
             <a:pPr algn="ctr"/>
@@ -3548,8 +3566,8 @@
           <a:noFill/>
         </p:spPr>
         <p:txBody>
-          <a:bodyPr wrap="none" anchor="ctr">
-            <a:spAutoFit/>
+          <a:bodyPr wrap="square" anchor="ctr">
+            <a:normAutofit/>
           </a:bodyPr>
           <a:lstStyle/>
           <a:p>
@@ -3584,8 +3602,8 @@
           <a:noFill/>
         </p:spPr>
         <p:txBody>
-          <a:bodyPr wrap="none" anchor="ctr">
-            <a:spAutoFit/>
+          <a:bodyPr wrap="square" anchor="ctr">
+            <a:normAutofit/>
           </a:bodyPr>
           <a:lstStyle/>
           <a:p>
@@ -3639,7 +3657,9 @@
           </a:fontRef>
         </p:style>
         <p:txBody>
-          <a:bodyPr rtlCol="0" anchor="ctr"/>
+          <a:bodyPr rtlCol="0" anchor="ctr" wrap="square">
+            <a:normAutofit/>
+          </a:bodyPr>
           <a:lstStyle/>
           <a:p>
             <a:pPr algn="ctr"/>
@@ -3683,7 +3703,9 @@
           </a:fontRef>
         </p:style>
         <p:txBody>
-          <a:bodyPr rtlCol="0" anchor="ctr"/>
+          <a:bodyPr rtlCol="0" anchor="ctr" wrap="square">
+            <a:normAutofit/>
+          </a:bodyPr>
           <a:lstStyle/>
           <a:p>
             <a:pPr algn="ctr"/>
@@ -3709,7 +3731,7 @@
         </p:spPr>
         <p:txBody>
           <a:bodyPr wrap="square">
-            <a:spAutoFit/>
+            <a:normAutofit/>
           </a:bodyPr>
           <a:lstStyle/>
           <a:p>
@@ -3745,7 +3767,7 @@
         </p:spPr>
         <p:txBody>
           <a:bodyPr wrap="square">
-            <a:spAutoFit/>
+            <a:normAutofit/>
           </a:bodyPr>
           <a:lstStyle/>
           <a:p>
@@ -3802,7 +3824,9 @@
           </a:fontRef>
         </p:style>
         <p:txBody>
-          <a:bodyPr rtlCol="0" anchor="ctr"/>
+          <a:bodyPr rtlCol="0" anchor="ctr" wrap="square">
+            <a:normAutofit/>
+          </a:bodyPr>
           <a:lstStyle/>
           <a:p>
             <a:pPr algn="ctr"/>
@@ -3846,7 +3870,9 @@
           </a:fontRef>
         </p:style>
         <p:txBody>
-          <a:bodyPr rtlCol="0" anchor="ctr"/>
+          <a:bodyPr rtlCol="0" anchor="ctr" wrap="square">
+            <a:normAutofit/>
+          </a:bodyPr>
           <a:lstStyle/>
           <a:p>
             <a:pPr algn="ctr"/>
@@ -3872,7 +3898,7 @@
         </p:spPr>
         <p:txBody>
           <a:bodyPr wrap="square">
-            <a:spAutoFit/>
+            <a:normAutofit/>
           </a:bodyPr>
           <a:lstStyle/>
           <a:p>
@@ -3908,7 +3934,7 @@
         </p:spPr>
         <p:txBody>
           <a:bodyPr wrap="square">
-            <a:spAutoFit/>
+            <a:normAutofit/>
           </a:bodyPr>
           <a:lstStyle/>
           <a:p>
@@ -3998,7 +4024,9 @@
           </a:fontRef>
         </p:style>
         <p:txBody>
-          <a:bodyPr rtlCol="0" anchor="ctr"/>
+          <a:bodyPr rtlCol="0" anchor="ctr" wrap="square">
+            <a:normAutofit/>
+          </a:bodyPr>
           <a:lstStyle/>
           <a:p>
             <a:pPr algn="ctr"/>
@@ -4023,8 +4051,8 @@
           <a:noFill/>
         </p:spPr>
         <p:txBody>
-          <a:bodyPr wrap="none">
-            <a:spAutoFit/>
+          <a:bodyPr wrap="square">
+            <a:normAutofit/>
           </a:bodyPr>
           <a:lstStyle/>
           <a:p>
@@ -4059,8 +4087,8 @@
           <a:noFill/>
         </p:spPr>
         <p:txBody>
-          <a:bodyPr wrap="none">
-            <a:spAutoFit/>
+          <a:bodyPr wrap="square">
+            <a:normAutofit/>
           </a:bodyPr>
           <a:lstStyle/>
           <a:p>
@@ -4114,7 +4142,9 @@
           </a:fontRef>
         </p:style>
         <p:txBody>
-          <a:bodyPr rtlCol="0" anchor="ctr"/>
+          <a:bodyPr rtlCol="0" anchor="ctr" wrap="square">
+            <a:normAutofit/>
+          </a:bodyPr>
           <a:lstStyle/>
           <a:p>
             <a:pPr algn="ctr"/>
@@ -4158,7 +4188,9 @@
           </a:fontRef>
         </p:style>
         <p:txBody>
-          <a:bodyPr rtlCol="0" anchor="ctr"/>
+          <a:bodyPr rtlCol="0" anchor="ctr" wrap="square">
+            <a:normAutofit/>
+          </a:bodyPr>
           <a:lstStyle/>
           <a:p>
             <a:pPr algn="ctr"/>
@@ -4183,8 +4215,8 @@
           <a:noFill/>
         </p:spPr>
         <p:txBody>
-          <a:bodyPr wrap="none" anchor="ctr">
-            <a:spAutoFit/>
+          <a:bodyPr wrap="square" anchor="ctr">
+            <a:normAutofit/>
           </a:bodyPr>
           <a:lstStyle/>
           <a:p>
@@ -4238,7 +4270,9 @@
           </a:fontRef>
         </p:style>
         <p:txBody>
-          <a:bodyPr rtlCol="0" anchor="ctr"/>
+          <a:bodyPr rtlCol="0" anchor="ctr" wrap="square">
+            <a:normAutofit/>
+          </a:bodyPr>
           <a:lstStyle/>
           <a:p>
             <a:pPr algn="ctr"/>
@@ -4263,8 +4297,8 @@
           <a:noFill/>
         </p:spPr>
         <p:txBody>
-          <a:bodyPr wrap="none" anchor="ctr">
-            <a:spAutoFit/>
+          <a:bodyPr wrap="square" anchor="ctr">
+            <a:normAutofit/>
           </a:bodyPr>
           <a:lstStyle/>
           <a:p>
@@ -4299,8 +4333,8 @@
           <a:noFill/>
         </p:spPr>
         <p:txBody>
-          <a:bodyPr wrap="none" anchor="ctr">
-            <a:spAutoFit/>
+          <a:bodyPr wrap="square" anchor="ctr">
+            <a:normAutofit/>
           </a:bodyPr>
           <a:lstStyle/>
           <a:p>
@@ -4354,7 +4388,9 @@
           </a:fontRef>
         </p:style>
         <p:txBody>
-          <a:bodyPr rtlCol="0" anchor="ctr"/>
+          <a:bodyPr rtlCol="0" anchor="ctr" wrap="square">
+            <a:normAutofit/>
+          </a:bodyPr>
           <a:lstStyle/>
           <a:p>
             <a:pPr algn="ctr"/>
@@ -4398,7 +4434,9 @@
           </a:fontRef>
         </p:style>
         <p:txBody>
-          <a:bodyPr rtlCol="0" anchor="ctr"/>
+          <a:bodyPr rtlCol="0" anchor="ctr" wrap="square">
+            <a:normAutofit/>
+          </a:bodyPr>
           <a:lstStyle/>
           <a:p>
             <a:pPr algn="ctr"/>
@@ -4424,7 +4462,7 @@
         </p:spPr>
         <p:txBody>
           <a:bodyPr wrap="square">
-            <a:spAutoFit/>
+            <a:normAutofit/>
           </a:bodyPr>
           <a:lstStyle/>
           <a:p>
@@ -4460,7 +4498,7 @@
         </p:spPr>
         <p:txBody>
           <a:bodyPr wrap="square">
-            <a:spAutoFit/>
+            <a:normAutofit/>
           </a:bodyPr>
           <a:lstStyle/>
           <a:p>
@@ -4517,7 +4555,9 @@
           </a:fontRef>
         </p:style>
         <p:txBody>
-          <a:bodyPr rtlCol="0" anchor="ctr"/>
+          <a:bodyPr rtlCol="0" anchor="ctr" wrap="square">
+            <a:normAutofit/>
+          </a:bodyPr>
           <a:lstStyle/>
           <a:p>
             <a:pPr algn="ctr"/>
@@ -4561,7 +4601,9 @@
           </a:fontRef>
         </p:style>
         <p:txBody>
-          <a:bodyPr rtlCol="0" anchor="ctr"/>
+          <a:bodyPr rtlCol="0" anchor="ctr" wrap="square">
+            <a:normAutofit/>
+          </a:bodyPr>
           <a:lstStyle/>
           <a:p>
             <a:pPr algn="ctr"/>
@@ -4587,7 +4629,7 @@
         </p:spPr>
         <p:txBody>
           <a:bodyPr wrap="square">
-            <a:spAutoFit/>
+            <a:normAutofit/>
           </a:bodyPr>
           <a:lstStyle/>
           <a:p>
@@ -4623,7 +4665,7 @@
         </p:spPr>
         <p:txBody>
           <a:bodyPr wrap="square">
-            <a:spAutoFit/>
+            <a:normAutofit/>
           </a:bodyPr>
           <a:lstStyle/>
           <a:p>
@@ -4737,7 +4779,9 @@
           </a:fontRef>
         </p:style>
         <p:txBody>
-          <a:bodyPr rtlCol="0" anchor="ctr"/>
+          <a:bodyPr rtlCol="0" anchor="ctr" wrap="square">
+            <a:normAutofit/>
+          </a:bodyPr>
           <a:lstStyle/>
           <a:p>
             <a:pPr algn="ctr"/>
@@ -4762,8 +4806,8 @@
           <a:noFill/>
         </p:spPr>
         <p:txBody>
-          <a:bodyPr wrap="none">
-            <a:spAutoFit/>
+          <a:bodyPr wrap="square">
+            <a:normAutofit/>
           </a:bodyPr>
           <a:lstStyle/>
           <a:p>
@@ -4798,8 +4842,8 @@
           <a:noFill/>
         </p:spPr>
         <p:txBody>
-          <a:bodyPr wrap="none">
-            <a:spAutoFit/>
+          <a:bodyPr wrap="square">
+            <a:normAutofit/>
           </a:bodyPr>
           <a:lstStyle/>
           <a:p>
@@ -4853,7 +4897,9 @@
           </a:fontRef>
         </p:style>
         <p:txBody>
-          <a:bodyPr rtlCol="0" anchor="ctr"/>
+          <a:bodyPr rtlCol="0" anchor="ctr" wrap="square">
+            <a:normAutofit/>
+          </a:bodyPr>
           <a:lstStyle/>
           <a:p>
             <a:pPr algn="ctr"/>
@@ -4897,7 +4943,9 @@
           </a:fontRef>
         </p:style>
         <p:txBody>
-          <a:bodyPr rtlCol="0" anchor="ctr"/>
+          <a:bodyPr rtlCol="0" anchor="ctr" wrap="square">
+            <a:normAutofit/>
+          </a:bodyPr>
           <a:lstStyle/>
           <a:p>
             <a:pPr algn="ctr"/>
@@ -4922,8 +4970,8 @@
           <a:noFill/>
         </p:spPr>
         <p:txBody>
-          <a:bodyPr wrap="none" anchor="ctr">
-            <a:spAutoFit/>
+          <a:bodyPr wrap="square" anchor="ctr">
+            <a:normAutofit/>
           </a:bodyPr>
           <a:lstStyle/>
           <a:p>
@@ -4977,7 +5025,9 @@
           </a:fontRef>
         </p:style>
         <p:txBody>
-          <a:bodyPr rtlCol="0" anchor="ctr"/>
+          <a:bodyPr rtlCol="0" anchor="ctr" wrap="square">
+            <a:normAutofit/>
+          </a:bodyPr>
           <a:lstStyle/>
           <a:p>
             <a:pPr algn="ctr"/>
@@ -5002,8 +5052,8 @@
           <a:noFill/>
         </p:spPr>
         <p:txBody>
-          <a:bodyPr wrap="none" anchor="ctr">
-            <a:spAutoFit/>
+          <a:bodyPr wrap="square" anchor="ctr">
+            <a:normAutofit/>
           </a:bodyPr>
           <a:lstStyle/>
           <a:p>
@@ -5038,8 +5088,8 @@
           <a:noFill/>
         </p:spPr>
         <p:txBody>
-          <a:bodyPr wrap="none" anchor="ctr">
-            <a:spAutoFit/>
+          <a:bodyPr wrap="square" anchor="ctr">
+            <a:normAutofit/>
           </a:bodyPr>
           <a:lstStyle/>
           <a:p>
@@ -5093,7 +5143,9 @@
           </a:fontRef>
         </p:style>
         <p:txBody>
-          <a:bodyPr rtlCol="0" anchor="ctr"/>
+          <a:bodyPr rtlCol="0" anchor="ctr" wrap="square">
+            <a:normAutofit/>
+          </a:bodyPr>
           <a:lstStyle/>
           <a:p>
             <a:pPr algn="ctr"/>
@@ -5137,7 +5189,9 @@
           </a:fontRef>
         </p:style>
         <p:txBody>
-          <a:bodyPr rtlCol="0" anchor="ctr"/>
+          <a:bodyPr rtlCol="0" anchor="ctr" wrap="square">
+            <a:normAutofit/>
+          </a:bodyPr>
           <a:lstStyle/>
           <a:p>
             <a:pPr algn="ctr"/>
@@ -5163,7 +5217,7 @@
         </p:spPr>
         <p:txBody>
           <a:bodyPr wrap="square">
-            <a:spAutoFit/>
+            <a:normAutofit/>
           </a:bodyPr>
           <a:lstStyle/>
           <a:p>
@@ -5199,7 +5253,7 @@
         </p:spPr>
         <p:txBody>
           <a:bodyPr wrap="square">
-            <a:spAutoFit/>
+            <a:normAutofit/>
           </a:bodyPr>
           <a:lstStyle/>
           <a:p>
@@ -5256,7 +5310,9 @@
           </a:fontRef>
         </p:style>
         <p:txBody>
-          <a:bodyPr rtlCol="0" anchor="ctr"/>
+          <a:bodyPr rtlCol="0" anchor="ctr" wrap="square">
+            <a:normAutofit/>
+          </a:bodyPr>
           <a:lstStyle/>
           <a:p>
             <a:pPr algn="ctr"/>
@@ -5300,7 +5356,9 @@
           </a:fontRef>
         </p:style>
         <p:txBody>
-          <a:bodyPr rtlCol="0" anchor="ctr"/>
+          <a:bodyPr rtlCol="0" anchor="ctr" wrap="square">
+            <a:normAutofit/>
+          </a:bodyPr>
           <a:lstStyle/>
           <a:p>
             <a:pPr algn="ctr"/>
@@ -5326,7 +5384,7 @@
         </p:spPr>
         <p:txBody>
           <a:bodyPr wrap="square">
-            <a:spAutoFit/>
+            <a:normAutofit/>
           </a:bodyPr>
           <a:lstStyle/>
           <a:p>
@@ -5353,7 +5411,7 @@
         <p:spPr>
           <a:xfrm>
             <a:off x="4892040" y="2286000"/>
-            <a:ext cx="3931920" cy="923330"/>
+            <a:ext cx="3931920" cy="3383280"/>
           </a:xfrm>
           <a:prstGeom prst="rect">
             <a:avLst/>
@@ -5362,305 +5420,12 @@
         </p:spPr>
         <p:txBody>
           <a:bodyPr wrap="square">
-            <a:spAutoFit/>
-          </a:bodyPr>
-          <a:lstStyle/>
-          <a:p>
-            <a:r>
-              <a:rPr dirty="0">
-                <a:solidFill>
-                  <a:schemeClr val="bg1"/>
-                </a:solidFill>
-              </a:rPr>
-              <a:t>• </a:t>
-            </a:r>
-            <a:r>
-              <a:rPr dirty="0" err="1">
-                <a:solidFill>
-                  <a:schemeClr val="bg1"/>
-                </a:solidFill>
-              </a:rPr>
-              <a:t>Tỷ</a:t>
-            </a:r>
-            <a:r>
-              <a:rPr dirty="0">
-                <a:solidFill>
-                  <a:schemeClr val="bg1"/>
-                </a:solidFill>
-              </a:rPr>
-              <a:t> </a:t>
-            </a:r>
-            <a:r>
-              <a:rPr dirty="0" err="1">
-                <a:solidFill>
-                  <a:schemeClr val="bg1"/>
-                </a:solidFill>
-              </a:rPr>
-              <a:t>lệ</a:t>
-            </a:r>
-            <a:r>
-              <a:rPr dirty="0">
-                <a:solidFill>
-                  <a:schemeClr val="bg1"/>
-                </a:solidFill>
-              </a:rPr>
-              <a:t> </a:t>
-            </a:r>
-            <a:r>
-              <a:rPr dirty="0" err="1">
-                <a:solidFill>
-                  <a:schemeClr val="bg1"/>
-                </a:solidFill>
-              </a:rPr>
-              <a:t>hệ</a:t>
-            </a:r>
-            <a:r>
-              <a:rPr dirty="0">
-                <a:solidFill>
-                  <a:schemeClr val="bg1"/>
-                </a:solidFill>
-              </a:rPr>
-              <a:t> </a:t>
-            </a:r>
-            <a:r>
-              <a:rPr dirty="0" err="1">
-                <a:solidFill>
-                  <a:schemeClr val="bg1"/>
-                </a:solidFill>
-              </a:rPr>
-              <a:t>thống</a:t>
-            </a:r>
-            <a:r>
-              <a:rPr dirty="0">
-                <a:solidFill>
-                  <a:schemeClr val="bg1"/>
-                </a:solidFill>
-              </a:rPr>
-              <a:t> </a:t>
-            </a:r>
-            <a:r>
-              <a:rPr dirty="0" err="1">
-                <a:solidFill>
-                  <a:schemeClr val="bg1"/>
-                </a:solidFill>
-              </a:rPr>
-              <a:t>kết</a:t>
-            </a:r>
-            <a:r>
-              <a:rPr dirty="0">
-                <a:solidFill>
-                  <a:schemeClr val="bg1"/>
-                </a:solidFill>
-              </a:rPr>
-              <a:t> </a:t>
-            </a:r>
-            <a:r>
-              <a:rPr dirty="0" err="1">
-                <a:solidFill>
-                  <a:schemeClr val="bg1"/>
-                </a:solidFill>
-              </a:rPr>
-              <a:t>luận</a:t>
-            </a:r>
-            <a:r>
-              <a:rPr dirty="0">
-                <a:solidFill>
-                  <a:schemeClr val="bg1"/>
-                </a:solidFill>
-              </a:rPr>
-              <a:t> </a:t>
-            </a:r>
-            <a:r>
-              <a:rPr dirty="0" err="1">
-                <a:solidFill>
-                  <a:schemeClr val="bg1"/>
-                </a:solidFill>
-              </a:rPr>
-              <a:t>nhầm</a:t>
-            </a:r>
-            <a:r>
-              <a:rPr dirty="0">
-                <a:solidFill>
-                  <a:schemeClr val="bg1"/>
-                </a:solidFill>
-              </a:rPr>
-              <a:t> "</a:t>
-            </a:r>
-            <a:r>
-              <a:rPr dirty="0" err="1">
-                <a:solidFill>
-                  <a:schemeClr val="bg1"/>
-                </a:solidFill>
-              </a:rPr>
-              <a:t>Có</a:t>
-            </a:r>
-            <a:r>
-              <a:rPr dirty="0">
-                <a:solidFill>
-                  <a:schemeClr val="bg1"/>
-                </a:solidFill>
-              </a:rPr>
-              <a:t> </a:t>
-            </a:r>
-            <a:r>
-              <a:rPr dirty="0" err="1">
-                <a:solidFill>
-                  <a:schemeClr val="bg1"/>
-                </a:solidFill>
-              </a:rPr>
-              <a:t>khác</a:t>
-            </a:r>
-            <a:r>
-              <a:rPr dirty="0">
-                <a:solidFill>
-                  <a:schemeClr val="bg1"/>
-                </a:solidFill>
-              </a:rPr>
-              <a:t> </a:t>
-            </a:r>
-            <a:r>
-              <a:rPr dirty="0" err="1">
-                <a:solidFill>
-                  <a:schemeClr val="bg1"/>
-                </a:solidFill>
-              </a:rPr>
-              <a:t>biệt</a:t>
-            </a:r>
-            <a:r>
-              <a:rPr dirty="0">
-                <a:solidFill>
-                  <a:schemeClr val="bg1"/>
-                </a:solidFill>
-              </a:rPr>
-              <a:t>" </a:t>
-            </a:r>
-            <a:r>
-              <a:rPr dirty="0" err="1">
-                <a:solidFill>
-                  <a:schemeClr val="bg1"/>
-                </a:solidFill>
-              </a:rPr>
-              <a:t>duy</a:t>
-            </a:r>
-            <a:r>
-              <a:rPr dirty="0">
-                <a:solidFill>
-                  <a:schemeClr val="bg1"/>
-                </a:solidFill>
-              </a:rPr>
-              <a:t> </a:t>
-            </a:r>
-            <a:r>
-              <a:rPr dirty="0" err="1">
-                <a:solidFill>
-                  <a:schemeClr val="bg1"/>
-                </a:solidFill>
-              </a:rPr>
-              <a:t>trì</a:t>
-            </a:r>
-            <a:r>
-              <a:rPr dirty="0">
-                <a:solidFill>
-                  <a:schemeClr val="bg1"/>
-                </a:solidFill>
-              </a:rPr>
-              <a:t> ở </a:t>
-            </a:r>
-            <a:r>
-              <a:rPr dirty="0" err="1">
-                <a:solidFill>
-                  <a:schemeClr val="bg1"/>
-                </a:solidFill>
-              </a:rPr>
-              <a:t>mức</a:t>
-            </a:r>
-            <a:r>
-              <a:rPr dirty="0">
-                <a:solidFill>
-                  <a:schemeClr val="bg1"/>
-                </a:solidFill>
-              </a:rPr>
-              <a:t> ~4.80% (</a:t>
-            </a:r>
-            <a:r>
-              <a:rPr dirty="0" err="1">
-                <a:solidFill>
-                  <a:schemeClr val="bg1"/>
-                </a:solidFill>
-              </a:rPr>
-              <a:t>Sát</a:t>
-            </a:r>
-            <a:r>
-              <a:rPr dirty="0">
-                <a:solidFill>
-                  <a:schemeClr val="bg1"/>
-                </a:solidFill>
-              </a:rPr>
-              <a:t> </a:t>
-            </a:r>
-            <a:r>
-              <a:rPr dirty="0" err="1">
-                <a:solidFill>
-                  <a:schemeClr val="bg1"/>
-                </a:solidFill>
-              </a:rPr>
-              <a:t>với</a:t>
-            </a:r>
-            <a:r>
-              <a:rPr dirty="0">
-                <a:solidFill>
-                  <a:schemeClr val="bg1"/>
-                </a:solidFill>
-              </a:rPr>
-              <a:t> </a:t>
-            </a:r>
-            <a:r>
-              <a:rPr dirty="0" err="1">
-                <a:solidFill>
-                  <a:schemeClr val="bg1"/>
-                </a:solidFill>
-              </a:rPr>
-              <a:t>ngưỡng</a:t>
-            </a:r>
-            <a:r>
-              <a:rPr dirty="0">
-                <a:solidFill>
-                  <a:schemeClr val="bg1"/>
-                </a:solidFill>
-              </a:rPr>
-              <a:t> </a:t>
-            </a:r>
-            <a:r>
-              <a:rPr dirty="0" err="1">
-                <a:solidFill>
-                  <a:schemeClr val="bg1"/>
-                </a:solidFill>
-              </a:rPr>
-              <a:t>lý</a:t>
-            </a:r>
-            <a:r>
-              <a:rPr dirty="0">
-                <a:solidFill>
-                  <a:schemeClr val="bg1"/>
-                </a:solidFill>
-              </a:rPr>
-              <a:t> </a:t>
-            </a:r>
-            <a:r>
-              <a:rPr dirty="0" err="1">
-                <a:solidFill>
-                  <a:schemeClr val="bg1"/>
-                </a:solidFill>
-              </a:rPr>
-              <a:t>tưởng</a:t>
-            </a:r>
-            <a:r>
-              <a:rPr dirty="0">
-                <a:solidFill>
-                  <a:schemeClr val="bg1"/>
-                </a:solidFill>
-              </a:rPr>
-              <a:t> 5%.</a:t>
+            <a:normAutofit/>
+          </a:bodyPr>
+          <a:lstStyle/>
+          <a:p>
+            <a:r>
+              <a:t>• Tỷ lệ hệ thống kết luận nhầm "Có khác biệt" duy trì ở mức ~4.80% (Sát với ngưỡng lý tưởng 5%).</a:t>
             </a:r>
           </a:p>
         </p:txBody>
@@ -5726,7 +5491,9 @@
           </a:fontRef>
         </p:style>
         <p:txBody>
-          <a:bodyPr rtlCol="0" anchor="ctr"/>
+          <a:bodyPr rtlCol="0" anchor="ctr" wrap="square">
+            <a:normAutofit/>
+          </a:bodyPr>
           <a:lstStyle/>
           <a:p>
             <a:pPr algn="ctr"/>
@@ -5751,8 +5518,8 @@
           <a:noFill/>
         </p:spPr>
         <p:txBody>
-          <a:bodyPr wrap="none">
-            <a:spAutoFit/>
+          <a:bodyPr wrap="square">
+            <a:normAutofit/>
           </a:bodyPr>
           <a:lstStyle/>
           <a:p>
@@ -5787,8 +5554,8 @@
           <a:noFill/>
         </p:spPr>
         <p:txBody>
-          <a:bodyPr wrap="none">
-            <a:spAutoFit/>
+          <a:bodyPr wrap="square">
+            <a:normAutofit/>
           </a:bodyPr>
           <a:lstStyle/>
           <a:p>
@@ -5842,7 +5609,9 @@
           </a:fontRef>
         </p:style>
         <p:txBody>
-          <a:bodyPr rtlCol="0" anchor="ctr"/>
+          <a:bodyPr rtlCol="0" anchor="ctr" wrap="square">
+            <a:normAutofit/>
+          </a:bodyPr>
           <a:lstStyle/>
           <a:p>
             <a:pPr algn="ctr"/>
@@ -5886,7 +5655,9 @@
           </a:fontRef>
         </p:style>
         <p:txBody>
-          <a:bodyPr rtlCol="0" anchor="ctr"/>
+          <a:bodyPr rtlCol="0" anchor="ctr" wrap="square">
+            <a:normAutofit/>
+          </a:bodyPr>
           <a:lstStyle/>
           <a:p>
             <a:pPr algn="ctr"/>
@@ -5911,8 +5682,8 @@
           <a:noFill/>
         </p:spPr>
         <p:txBody>
-          <a:bodyPr wrap="none" anchor="ctr">
-            <a:spAutoFit/>
+          <a:bodyPr wrap="square" anchor="ctr">
+            <a:normAutofit/>
           </a:bodyPr>
           <a:lstStyle/>
           <a:p>
@@ -5966,7 +5737,9 @@
           </a:fontRef>
         </p:style>
         <p:txBody>
-          <a:bodyPr rtlCol="0" anchor="ctr"/>
+          <a:bodyPr rtlCol="0" anchor="ctr" wrap="square">
+            <a:normAutofit/>
+          </a:bodyPr>
           <a:lstStyle/>
           <a:p>
             <a:pPr algn="ctr"/>
@@ -5991,8 +5764,8 @@
           <a:noFill/>
         </p:spPr>
         <p:txBody>
-          <a:bodyPr wrap="none" anchor="ctr">
-            <a:spAutoFit/>
+          <a:bodyPr wrap="square" anchor="ctr">
+            <a:normAutofit/>
           </a:bodyPr>
           <a:lstStyle/>
           <a:p>
@@ -6027,8 +5800,8 @@
           <a:noFill/>
         </p:spPr>
         <p:txBody>
-          <a:bodyPr wrap="none" anchor="ctr">
-            <a:spAutoFit/>
+          <a:bodyPr wrap="square" anchor="ctr">
+            <a:normAutofit/>
           </a:bodyPr>
           <a:lstStyle/>
           <a:p>
@@ -6082,7 +5855,9 @@
           </a:fontRef>
         </p:style>
         <p:txBody>
-          <a:bodyPr rtlCol="0" anchor="ctr"/>
+          <a:bodyPr rtlCol="0" anchor="ctr" wrap="square">
+            <a:normAutofit/>
+          </a:bodyPr>
           <a:lstStyle/>
           <a:p>
             <a:pPr algn="ctr"/>
@@ -6126,7 +5901,9 @@
           </a:fontRef>
         </p:style>
         <p:txBody>
-          <a:bodyPr rtlCol="0" anchor="ctr"/>
+          <a:bodyPr rtlCol="0" anchor="ctr" wrap="square">
+            <a:normAutofit/>
+          </a:bodyPr>
           <a:lstStyle/>
           <a:p>
             <a:pPr algn="ctr"/>
@@ -6152,7 +5929,7 @@
         </p:spPr>
         <p:txBody>
           <a:bodyPr wrap="square">
-            <a:spAutoFit/>
+            <a:normAutofit/>
           </a:bodyPr>
           <a:lstStyle/>
           <a:p>
@@ -6188,7 +5965,7 @@
         </p:spPr>
         <p:txBody>
           <a:bodyPr wrap="square">
-            <a:spAutoFit/>
+            <a:normAutofit/>
           </a:bodyPr>
           <a:lstStyle/>
           <a:p>
@@ -6245,7 +6022,9 @@
           </a:fontRef>
         </p:style>
         <p:txBody>
-          <a:bodyPr rtlCol="0" anchor="ctr"/>
+          <a:bodyPr rtlCol="0" anchor="ctr" wrap="square">
+            <a:normAutofit/>
+          </a:bodyPr>
           <a:lstStyle/>
           <a:p>
             <a:pPr algn="ctr"/>
@@ -6289,7 +6068,9 @@
           </a:fontRef>
         </p:style>
         <p:txBody>
-          <a:bodyPr rtlCol="0" anchor="ctr"/>
+          <a:bodyPr rtlCol="0" anchor="ctr" wrap="square">
+            <a:normAutofit/>
+          </a:bodyPr>
           <a:lstStyle/>
           <a:p>
             <a:pPr algn="ctr"/>
@@ -6315,7 +6096,7 @@
         </p:spPr>
         <p:txBody>
           <a:bodyPr wrap="square">
-            <a:spAutoFit/>
+            <a:normAutofit/>
           </a:bodyPr>
           <a:lstStyle/>
           <a:p>
@@ -6351,7 +6132,7 @@
         </p:spPr>
         <p:txBody>
           <a:bodyPr wrap="square">
-            <a:spAutoFit/>
+            <a:normAutofit/>
           </a:bodyPr>
           <a:lstStyle/>
           <a:p>
@@ -6454,7 +6235,9 @@
           </a:fontRef>
         </p:style>
         <p:txBody>
-          <a:bodyPr rtlCol="0" anchor="ctr"/>
+          <a:bodyPr rtlCol="0" anchor="ctr" wrap="square">
+            <a:normAutofit/>
+          </a:bodyPr>
           <a:lstStyle/>
           <a:p>
             <a:pPr algn="ctr"/>
@@ -6479,8 +6262,8 @@
           <a:noFill/>
         </p:spPr>
         <p:txBody>
-          <a:bodyPr wrap="none">
-            <a:spAutoFit/>
+          <a:bodyPr wrap="square">
+            <a:normAutofit/>
           </a:bodyPr>
           <a:lstStyle/>
           <a:p>
@@ -6515,8 +6298,8 @@
           <a:noFill/>
         </p:spPr>
         <p:txBody>
-          <a:bodyPr wrap="none">
-            <a:spAutoFit/>
+          <a:bodyPr wrap="square">
+            <a:normAutofit/>
           </a:bodyPr>
           <a:lstStyle/>
           <a:p>
@@ -6570,7 +6353,9 @@
           </a:fontRef>
         </p:style>
         <p:txBody>
-          <a:bodyPr rtlCol="0" anchor="ctr"/>
+          <a:bodyPr rtlCol="0" anchor="ctr" wrap="square">
+            <a:normAutofit/>
+          </a:bodyPr>
           <a:lstStyle/>
           <a:p>
             <a:pPr algn="ctr"/>
@@ -6614,7 +6399,9 @@
           </a:fontRef>
         </p:style>
         <p:txBody>
-          <a:bodyPr rtlCol="0" anchor="ctr"/>
+          <a:bodyPr rtlCol="0" anchor="ctr" wrap="square">
+            <a:normAutofit/>
+          </a:bodyPr>
           <a:lstStyle/>
           <a:p>
             <a:pPr algn="ctr"/>
@@ -6639,8 +6426,8 @@
           <a:noFill/>
         </p:spPr>
         <p:txBody>
-          <a:bodyPr wrap="none" anchor="ctr">
-            <a:spAutoFit/>
+          <a:bodyPr wrap="square" anchor="ctr">
+            <a:normAutofit/>
           </a:bodyPr>
           <a:lstStyle/>
           <a:p>
@@ -6694,7 +6481,9 @@
           </a:fontRef>
         </p:style>
         <p:txBody>
-          <a:bodyPr rtlCol="0" anchor="ctr"/>
+          <a:bodyPr rtlCol="0" anchor="ctr" wrap="square">
+            <a:normAutofit/>
+          </a:bodyPr>
           <a:lstStyle/>
           <a:p>
             <a:pPr algn="ctr"/>
@@ -6719,8 +6508,8 @@
           <a:noFill/>
         </p:spPr>
         <p:txBody>
-          <a:bodyPr wrap="none" anchor="ctr">
-            <a:spAutoFit/>
+          <a:bodyPr wrap="square" anchor="ctr">
+            <a:normAutofit/>
           </a:bodyPr>
           <a:lstStyle/>
           <a:p>
@@ -6755,8 +6544,8 @@
           <a:noFill/>
         </p:spPr>
         <p:txBody>
-          <a:bodyPr wrap="none" anchor="ctr">
-            <a:spAutoFit/>
+          <a:bodyPr wrap="square" anchor="ctr">
+            <a:normAutofit/>
           </a:bodyPr>
           <a:lstStyle/>
           <a:p>
@@ -6810,7 +6599,9 @@
           </a:fontRef>
         </p:style>
         <p:txBody>
-          <a:bodyPr rtlCol="0" anchor="ctr"/>
+          <a:bodyPr rtlCol="0" anchor="ctr" wrap="square">
+            <a:normAutofit/>
+          </a:bodyPr>
           <a:lstStyle/>
           <a:p>
             <a:pPr algn="ctr"/>
@@ -6854,7 +6645,9 @@
           </a:fontRef>
         </p:style>
         <p:txBody>
-          <a:bodyPr rtlCol="0" anchor="ctr"/>
+          <a:bodyPr rtlCol="0" anchor="ctr" wrap="square">
+            <a:normAutofit/>
+          </a:bodyPr>
           <a:lstStyle/>
           <a:p>
             <a:pPr algn="ctr"/>
@@ -6880,7 +6673,7 @@
         </p:spPr>
         <p:txBody>
           <a:bodyPr wrap="square">
-            <a:spAutoFit/>
+            <a:normAutofit/>
           </a:bodyPr>
           <a:lstStyle/>
           <a:p>
@@ -6916,7 +6709,7 @@
         </p:spPr>
         <p:txBody>
           <a:bodyPr wrap="square">
-            <a:spAutoFit/>
+            <a:normAutofit/>
           </a:bodyPr>
           <a:lstStyle/>
           <a:p>
@@ -6932,7 +6725,6 @@
               </a:defRPr>
             </a:pPr>
             <a:r>
-              <a:rPr sz="1400"/>
               <a:t>• Kiểm tra độ cân bằng hệ thống (Sample Ratio, Covariates).</a:t>
             </a:r>
           </a:p>
@@ -6949,7 +6741,6 @@
               </a:defRPr>
             </a:pPr>
             <a:r>
-              <a:rPr sz="1400"/>
               <a:t>• Kỳ vọng P-value &gt; 0.05 (Không bác bỏ H0) để chứng minh hệ thống không bị lệch.</a:t>
             </a:r>
           </a:p>
@@ -6991,7 +6782,9 @@
           </a:fontRef>
         </p:style>
         <p:txBody>
-          <a:bodyPr rtlCol="0" anchor="ctr"/>
+          <a:bodyPr rtlCol="0" anchor="ctr" wrap="square">
+            <a:normAutofit/>
+          </a:bodyPr>
           <a:lstStyle/>
           <a:p>
             <a:pPr algn="ctr"/>
@@ -7035,7 +6828,9 @@
           </a:fontRef>
         </p:style>
         <p:txBody>
-          <a:bodyPr rtlCol="0" anchor="ctr"/>
+          <a:bodyPr rtlCol="0" anchor="ctr" wrap="square">
+            <a:normAutofit/>
+          </a:bodyPr>
           <a:lstStyle/>
           <a:p>
             <a:pPr algn="ctr"/>
@@ -7061,7 +6856,7 @@
         </p:spPr>
         <p:txBody>
           <a:bodyPr wrap="square">
-            <a:spAutoFit/>
+            <a:normAutofit/>
           </a:bodyPr>
           <a:lstStyle/>
           <a:p>
@@ -7097,7 +6892,7 @@
         </p:spPr>
         <p:txBody>
           <a:bodyPr wrap="square">
-            <a:spAutoFit/>
+            <a:normAutofit/>
           </a:bodyPr>
           <a:lstStyle/>
           <a:p>
@@ -7113,7 +6908,6 @@
               </a:defRPr>
             </a:pPr>
             <a:r>
-              <a:rPr sz="1400"/>
               <a:t>• Đo lường tác động lên chỉ số cốt lõi (Incremental Rides).</a:t>
             </a:r>
           </a:p>
@@ -7130,7 +6924,6 @@
               </a:defRPr>
             </a:pPr>
             <a:r>
-              <a:rPr sz="1400"/>
               <a:t>• Kỳ vọng P-value &lt; 0.05 (Bác bỏ H0) để chứng minh Voucher có hiệu quả.</a:t>
             </a:r>
           </a:p>
@@ -7202,7 +6995,9 @@
           </a:fontRef>
         </p:style>
         <p:txBody>
-          <a:bodyPr rtlCol="0" anchor="ctr"/>
+          <a:bodyPr rtlCol="0" anchor="ctr" wrap="square">
+            <a:normAutofit/>
+          </a:bodyPr>
           <a:lstStyle/>
           <a:p>
             <a:pPr algn="ctr"/>
@@ -7227,8 +7022,8 @@
           <a:noFill/>
         </p:spPr>
         <p:txBody>
-          <a:bodyPr wrap="none">
-            <a:spAutoFit/>
+          <a:bodyPr wrap="square">
+            <a:normAutofit/>
           </a:bodyPr>
           <a:lstStyle/>
           <a:p>
@@ -7263,8 +7058,8 @@
           <a:noFill/>
         </p:spPr>
         <p:txBody>
-          <a:bodyPr wrap="none">
-            <a:spAutoFit/>
+          <a:bodyPr wrap="square">
+            <a:normAutofit/>
           </a:bodyPr>
           <a:lstStyle/>
           <a:p>
@@ -7318,7 +7113,9 @@
           </a:fontRef>
         </p:style>
         <p:txBody>
-          <a:bodyPr rtlCol="0" anchor="ctr"/>
+          <a:bodyPr rtlCol="0" anchor="ctr" wrap="square">
+            <a:normAutofit/>
+          </a:bodyPr>
           <a:lstStyle/>
           <a:p>
             <a:pPr algn="ctr"/>
@@ -7362,7 +7159,9 @@
           </a:fontRef>
         </p:style>
         <p:txBody>
-          <a:bodyPr rtlCol="0" anchor="ctr"/>
+          <a:bodyPr rtlCol="0" anchor="ctr" wrap="square">
+            <a:normAutofit/>
+          </a:bodyPr>
           <a:lstStyle/>
           <a:p>
             <a:pPr algn="ctr"/>
@@ -7387,8 +7186,8 @@
           <a:noFill/>
         </p:spPr>
         <p:txBody>
-          <a:bodyPr wrap="none" anchor="ctr">
-            <a:spAutoFit/>
+          <a:bodyPr wrap="square" anchor="ctr">
+            <a:normAutofit/>
           </a:bodyPr>
           <a:lstStyle/>
           <a:p>
@@ -7442,7 +7241,9 @@
           </a:fontRef>
         </p:style>
         <p:txBody>
-          <a:bodyPr rtlCol="0" anchor="ctr"/>
+          <a:bodyPr rtlCol="0" anchor="ctr" wrap="square">
+            <a:normAutofit/>
+          </a:bodyPr>
           <a:lstStyle/>
           <a:p>
             <a:pPr algn="ctr"/>
@@ -7467,8 +7268,8 @@
           <a:noFill/>
         </p:spPr>
         <p:txBody>
-          <a:bodyPr wrap="none" anchor="ctr">
-            <a:spAutoFit/>
+          <a:bodyPr wrap="square" anchor="ctr">
+            <a:normAutofit/>
           </a:bodyPr>
           <a:lstStyle/>
           <a:p>
@@ -7503,8 +7304,8 @@
           <a:noFill/>
         </p:spPr>
         <p:txBody>
-          <a:bodyPr wrap="none" anchor="ctr">
-            <a:spAutoFit/>
+          <a:bodyPr wrap="square" anchor="ctr">
+            <a:normAutofit/>
           </a:bodyPr>
           <a:lstStyle/>
           <a:p>
@@ -7558,7 +7359,9 @@
           </a:fontRef>
         </p:style>
         <p:txBody>
-          <a:bodyPr rtlCol="0" anchor="ctr"/>
+          <a:bodyPr rtlCol="0" anchor="ctr" wrap="square">
+            <a:normAutofit/>
+          </a:bodyPr>
           <a:lstStyle/>
           <a:p>
             <a:pPr algn="ctr"/>
@@ -7602,7 +7405,9 @@
           </a:fontRef>
         </p:style>
         <p:txBody>
-          <a:bodyPr rtlCol="0" anchor="ctr"/>
+          <a:bodyPr rtlCol="0" anchor="ctr" wrap="square">
+            <a:normAutofit/>
+          </a:bodyPr>
           <a:lstStyle/>
           <a:p>
             <a:pPr algn="ctr"/>
@@ -7628,7 +7433,7 @@
         </p:spPr>
         <p:txBody>
           <a:bodyPr wrap="square">
-            <a:spAutoFit/>
+            <a:normAutofit/>
           </a:bodyPr>
           <a:lstStyle/>
           <a:p>
@@ -7664,7 +7469,7 @@
         </p:spPr>
         <p:txBody>
           <a:bodyPr wrap="square">
-            <a:spAutoFit/>
+            <a:normAutofit/>
           </a:bodyPr>
           <a:lstStyle/>
           <a:p>
@@ -7721,7 +7526,9 @@
           </a:fontRef>
         </p:style>
         <p:txBody>
-          <a:bodyPr rtlCol="0" anchor="ctr"/>
+          <a:bodyPr rtlCol="0" anchor="ctr" wrap="square">
+            <a:normAutofit/>
+          </a:bodyPr>
           <a:lstStyle/>
           <a:p>
             <a:pPr algn="ctr"/>
@@ -7765,7 +7572,9 @@
           </a:fontRef>
         </p:style>
         <p:txBody>
-          <a:bodyPr rtlCol="0" anchor="ctr"/>
+          <a:bodyPr rtlCol="0" anchor="ctr" wrap="square">
+            <a:normAutofit/>
+          </a:bodyPr>
           <a:lstStyle/>
           <a:p>
             <a:pPr algn="ctr"/>
@@ -7791,7 +7600,7 @@
         </p:spPr>
         <p:txBody>
           <a:bodyPr wrap="square">
-            <a:spAutoFit/>
+            <a:normAutofit/>
           </a:bodyPr>
           <a:lstStyle/>
           <a:p>
@@ -7827,7 +7636,7 @@
         </p:spPr>
         <p:txBody>
           <a:bodyPr wrap="square">
-            <a:spAutoFit/>
+            <a:normAutofit/>
           </a:bodyPr>
           <a:lstStyle/>
           <a:p>
@@ -7944,7 +7753,9 @@
           </a:fontRef>
         </p:style>
         <p:txBody>
-          <a:bodyPr rtlCol="0" anchor="ctr"/>
+          <a:bodyPr rtlCol="0" anchor="ctr" wrap="square">
+            <a:normAutofit/>
+          </a:bodyPr>
           <a:lstStyle/>
           <a:p>
             <a:pPr algn="ctr"/>
@@ -7969,8 +7780,8 @@
           <a:noFill/>
         </p:spPr>
         <p:txBody>
-          <a:bodyPr wrap="none">
-            <a:spAutoFit/>
+          <a:bodyPr wrap="square">
+            <a:normAutofit/>
           </a:bodyPr>
           <a:lstStyle/>
           <a:p>
@@ -8005,8 +7816,8 @@
           <a:noFill/>
         </p:spPr>
         <p:txBody>
-          <a:bodyPr wrap="none">
-            <a:spAutoFit/>
+          <a:bodyPr wrap="square">
+            <a:normAutofit/>
           </a:bodyPr>
           <a:lstStyle/>
           <a:p>
@@ -8060,7 +7871,9 @@
           </a:fontRef>
         </p:style>
         <p:txBody>
-          <a:bodyPr rtlCol="0" anchor="ctr"/>
+          <a:bodyPr rtlCol="0" anchor="ctr" wrap="square">
+            <a:normAutofit/>
+          </a:bodyPr>
           <a:lstStyle/>
           <a:p>
             <a:pPr algn="ctr"/>
@@ -8104,7 +7917,9 @@
           </a:fontRef>
         </p:style>
         <p:txBody>
-          <a:bodyPr rtlCol="0" anchor="ctr"/>
+          <a:bodyPr rtlCol="0" anchor="ctr" wrap="square">
+            <a:normAutofit/>
+          </a:bodyPr>
           <a:lstStyle/>
           <a:p>
             <a:pPr algn="ctr"/>
@@ -8129,8 +7944,8 @@
           <a:noFill/>
         </p:spPr>
         <p:txBody>
-          <a:bodyPr wrap="none" anchor="ctr">
-            <a:spAutoFit/>
+          <a:bodyPr wrap="square" anchor="ctr">
+            <a:normAutofit/>
           </a:bodyPr>
           <a:lstStyle/>
           <a:p>
@@ -8184,7 +7999,9 @@
           </a:fontRef>
         </p:style>
         <p:txBody>
-          <a:bodyPr rtlCol="0" anchor="ctr"/>
+          <a:bodyPr rtlCol="0" anchor="ctr" wrap="square">
+            <a:normAutofit/>
+          </a:bodyPr>
           <a:lstStyle/>
           <a:p>
             <a:pPr algn="ctr"/>
@@ -8209,8 +8026,8 @@
           <a:noFill/>
         </p:spPr>
         <p:txBody>
-          <a:bodyPr wrap="none" anchor="ctr">
-            <a:spAutoFit/>
+          <a:bodyPr wrap="square" anchor="ctr">
+            <a:normAutofit/>
           </a:bodyPr>
           <a:lstStyle/>
           <a:p>
@@ -8245,8 +8062,8 @@
           <a:noFill/>
         </p:spPr>
         <p:txBody>
-          <a:bodyPr wrap="none" anchor="ctr">
-            <a:spAutoFit/>
+          <a:bodyPr wrap="square" anchor="ctr">
+            <a:normAutofit/>
           </a:bodyPr>
           <a:lstStyle/>
           <a:p>
@@ -8300,7 +8117,9 @@
           </a:fontRef>
         </p:style>
         <p:txBody>
-          <a:bodyPr rtlCol="0" anchor="ctr"/>
+          <a:bodyPr rtlCol="0" anchor="ctr" wrap="square">
+            <a:normAutofit/>
+          </a:bodyPr>
           <a:lstStyle/>
           <a:p>
             <a:pPr algn="ctr"/>
@@ -8344,7 +8163,9 @@
           </a:fontRef>
         </p:style>
         <p:txBody>
-          <a:bodyPr rtlCol="0" anchor="ctr"/>
+          <a:bodyPr rtlCol="0" anchor="ctr" wrap="square">
+            <a:normAutofit/>
+          </a:bodyPr>
           <a:lstStyle/>
           <a:p>
             <a:pPr algn="ctr"/>
@@ -8370,7 +8191,7 @@
         </p:spPr>
         <p:txBody>
           <a:bodyPr wrap="square">
-            <a:spAutoFit/>
+            <a:normAutofit/>
           </a:bodyPr>
           <a:lstStyle/>
           <a:p>
@@ -8406,7 +8227,7 @@
         </p:spPr>
         <p:txBody>
           <a:bodyPr wrap="square">
-            <a:spAutoFit/>
+            <a:normAutofit/>
           </a:bodyPr>
           <a:lstStyle/>
           <a:p>
@@ -8463,7 +8284,9 @@
           </a:fontRef>
         </p:style>
         <p:txBody>
-          <a:bodyPr rtlCol="0" anchor="ctr"/>
+          <a:bodyPr rtlCol="0" anchor="ctr" wrap="square">
+            <a:normAutofit/>
+          </a:bodyPr>
           <a:lstStyle/>
           <a:p>
             <a:pPr algn="ctr"/>
@@ -8507,7 +8330,9 @@
           </a:fontRef>
         </p:style>
         <p:txBody>
-          <a:bodyPr rtlCol="0" anchor="ctr"/>
+          <a:bodyPr rtlCol="0" anchor="ctr" wrap="square">
+            <a:normAutofit/>
+          </a:bodyPr>
           <a:lstStyle/>
           <a:p>
             <a:pPr algn="ctr"/>
@@ -8533,7 +8358,7 @@
         </p:spPr>
         <p:txBody>
           <a:bodyPr wrap="square">
-            <a:spAutoFit/>
+            <a:normAutofit/>
           </a:bodyPr>
           <a:lstStyle/>
           <a:p>
@@ -8569,7 +8394,7 @@
         </p:spPr>
         <p:txBody>
           <a:bodyPr wrap="square">
-            <a:spAutoFit/>
+            <a:normAutofit/>
           </a:bodyPr>
           <a:lstStyle/>
           <a:p>
@@ -8686,7 +8511,9 @@
           </a:fontRef>
         </p:style>
         <p:txBody>
-          <a:bodyPr rtlCol="0" anchor="ctr"/>
+          <a:bodyPr rtlCol="0" anchor="ctr" wrap="square">
+            <a:normAutofit/>
+          </a:bodyPr>
           <a:lstStyle/>
           <a:p>
             <a:pPr algn="ctr"/>
@@ -8711,8 +8538,8 @@
           <a:noFill/>
         </p:spPr>
         <p:txBody>
-          <a:bodyPr wrap="none">
-            <a:spAutoFit/>
+          <a:bodyPr wrap="square">
+            <a:normAutofit/>
           </a:bodyPr>
           <a:lstStyle/>
           <a:p>
@@ -8747,8 +8574,8 @@
           <a:noFill/>
         </p:spPr>
         <p:txBody>
-          <a:bodyPr wrap="none">
-            <a:spAutoFit/>
+          <a:bodyPr wrap="square">
+            <a:normAutofit/>
           </a:bodyPr>
           <a:lstStyle/>
           <a:p>
@@ -8802,7 +8629,9 @@
           </a:fontRef>
         </p:style>
         <p:txBody>
-          <a:bodyPr rtlCol="0" anchor="ctr"/>
+          <a:bodyPr rtlCol="0" anchor="ctr" wrap="square">
+            <a:normAutofit/>
+          </a:bodyPr>
           <a:lstStyle/>
           <a:p>
             <a:pPr algn="ctr"/>
@@ -8846,7 +8675,9 @@
           </a:fontRef>
         </p:style>
         <p:txBody>
-          <a:bodyPr rtlCol="0" anchor="ctr"/>
+          <a:bodyPr rtlCol="0" anchor="ctr" wrap="square">
+            <a:normAutofit/>
+          </a:bodyPr>
           <a:lstStyle/>
           <a:p>
             <a:pPr algn="ctr"/>
@@ -8871,8 +8702,8 @@
           <a:noFill/>
         </p:spPr>
         <p:txBody>
-          <a:bodyPr wrap="none" anchor="ctr">
-            <a:spAutoFit/>
+          <a:bodyPr wrap="square" anchor="ctr">
+            <a:normAutofit/>
           </a:bodyPr>
           <a:lstStyle/>
           <a:p>
@@ -8926,7 +8757,9 @@
           </a:fontRef>
         </p:style>
         <p:txBody>
-          <a:bodyPr rtlCol="0" anchor="ctr"/>
+          <a:bodyPr rtlCol="0" anchor="ctr" wrap="square">
+            <a:normAutofit/>
+          </a:bodyPr>
           <a:lstStyle/>
           <a:p>
             <a:pPr algn="ctr"/>
@@ -8951,8 +8784,8 @@
           <a:noFill/>
         </p:spPr>
         <p:txBody>
-          <a:bodyPr wrap="none" anchor="ctr">
-            <a:spAutoFit/>
+          <a:bodyPr wrap="square" anchor="ctr">
+            <a:normAutofit/>
           </a:bodyPr>
           <a:lstStyle/>
           <a:p>
@@ -8987,8 +8820,8 @@
           <a:noFill/>
         </p:spPr>
         <p:txBody>
-          <a:bodyPr wrap="none" anchor="ctr">
-            <a:spAutoFit/>
+          <a:bodyPr wrap="square" anchor="ctr">
+            <a:normAutofit/>
           </a:bodyPr>
           <a:lstStyle/>
           <a:p>
@@ -9042,7 +8875,9 @@
           </a:fontRef>
         </p:style>
         <p:txBody>
-          <a:bodyPr rtlCol="0" anchor="ctr"/>
+          <a:bodyPr rtlCol="0" anchor="ctr" wrap="square">
+            <a:normAutofit/>
+          </a:bodyPr>
           <a:lstStyle/>
           <a:p>
             <a:pPr algn="ctr"/>
@@ -9086,7 +8921,9 @@
           </a:fontRef>
         </p:style>
         <p:txBody>
-          <a:bodyPr rtlCol="0" anchor="ctr"/>
+          <a:bodyPr rtlCol="0" anchor="ctr" wrap="square">
+            <a:normAutofit/>
+          </a:bodyPr>
           <a:lstStyle/>
           <a:p>
             <a:pPr algn="ctr"/>
@@ -9112,7 +8949,7 @@
         </p:spPr>
         <p:txBody>
           <a:bodyPr wrap="square">
-            <a:spAutoFit/>
+            <a:normAutofit/>
           </a:bodyPr>
           <a:lstStyle/>
           <a:p>
@@ -9148,7 +8985,7 @@
         </p:spPr>
         <p:txBody>
           <a:bodyPr wrap="square">
-            <a:spAutoFit/>
+            <a:normAutofit/>
           </a:bodyPr>
           <a:lstStyle/>
           <a:p>
@@ -9205,7 +9042,9 @@
           </a:fontRef>
         </p:style>
         <p:txBody>
-          <a:bodyPr rtlCol="0" anchor="ctr"/>
+          <a:bodyPr rtlCol="0" anchor="ctr" wrap="square">
+            <a:normAutofit/>
+          </a:bodyPr>
           <a:lstStyle/>
           <a:p>
             <a:pPr algn="ctr"/>
@@ -9249,7 +9088,9 @@
           </a:fontRef>
         </p:style>
         <p:txBody>
-          <a:bodyPr rtlCol="0" anchor="ctr"/>
+          <a:bodyPr rtlCol="0" anchor="ctr" wrap="square">
+            <a:normAutofit/>
+          </a:bodyPr>
           <a:lstStyle/>
           <a:p>
             <a:pPr algn="ctr"/>
@@ -9275,7 +9116,7 @@
         </p:spPr>
         <p:txBody>
           <a:bodyPr wrap="square">
-            <a:spAutoFit/>
+            <a:normAutofit/>
           </a:bodyPr>
           <a:lstStyle/>
           <a:p>
@@ -9311,7 +9152,7 @@
         </p:spPr>
         <p:txBody>
           <a:bodyPr wrap="square">
-            <a:spAutoFit/>
+            <a:normAutofit/>
           </a:bodyPr>
           <a:lstStyle/>
           <a:p>

</xml_diff>

<commit_message>
Update Week 4 PPTX with manual user formatting fixes
</commit_message>
<xml_diff>
--- a/docs/Week4_AA_AB_Testing_Summary.pptx
+++ b/docs/Week4_AA_AB_Testing_Summary.pptx
@@ -3178,7 +3178,7 @@
           </a:fontRef>
         </p:style>
         <p:txBody>
-          <a:bodyPr rtlCol="0" anchor="ctr" wrap="square">
+          <a:bodyPr wrap="square" rtlCol="0" anchor="ctr">
             <a:normAutofit/>
           </a:bodyPr>
           <a:lstStyle/>
@@ -3293,7 +3293,7 @@
           </a:fontRef>
         </p:style>
         <p:txBody>
-          <a:bodyPr rtlCol="0" anchor="ctr" wrap="square">
+          <a:bodyPr wrap="square" rtlCol="0" anchor="ctr">
             <a:normAutofit/>
           </a:bodyPr>
           <a:lstStyle/>
@@ -3411,7 +3411,7 @@
           </a:fontRef>
         </p:style>
         <p:txBody>
-          <a:bodyPr rtlCol="0" anchor="ctr" wrap="square">
+          <a:bodyPr wrap="square" rtlCol="0" anchor="ctr">
             <a:normAutofit/>
           </a:bodyPr>
           <a:lstStyle/>
@@ -3457,7 +3457,7 @@
           </a:fontRef>
         </p:style>
         <p:txBody>
-          <a:bodyPr rtlCol="0" anchor="ctr" wrap="square">
+          <a:bodyPr wrap="square" rtlCol="0" anchor="ctr">
             <a:normAutofit/>
           </a:bodyPr>
           <a:lstStyle/>
@@ -3539,7 +3539,7 @@
           </a:fontRef>
         </p:style>
         <p:txBody>
-          <a:bodyPr rtlCol="0" anchor="ctr" wrap="square">
+          <a:bodyPr wrap="square" rtlCol="0" anchor="ctr">
             <a:normAutofit/>
           </a:bodyPr>
           <a:lstStyle/>
@@ -3657,7 +3657,7 @@
           </a:fontRef>
         </p:style>
         <p:txBody>
-          <a:bodyPr rtlCol="0" anchor="ctr" wrap="square">
+          <a:bodyPr wrap="square" rtlCol="0" anchor="ctr">
             <a:normAutofit/>
           </a:bodyPr>
           <a:lstStyle/>
@@ -3703,7 +3703,7 @@
           </a:fontRef>
         </p:style>
         <p:txBody>
-          <a:bodyPr rtlCol="0" anchor="ctr" wrap="square">
+          <a:bodyPr wrap="square" rtlCol="0" anchor="ctr">
             <a:normAutofit/>
           </a:bodyPr>
           <a:lstStyle/>
@@ -3824,7 +3824,7 @@
           </a:fontRef>
         </p:style>
         <p:txBody>
-          <a:bodyPr rtlCol="0" anchor="ctr" wrap="square">
+          <a:bodyPr wrap="square" rtlCol="0" anchor="ctr">
             <a:normAutofit/>
           </a:bodyPr>
           <a:lstStyle/>
@@ -3870,7 +3870,7 @@
           </a:fontRef>
         </p:style>
         <p:txBody>
-          <a:bodyPr rtlCol="0" anchor="ctr" wrap="square">
+          <a:bodyPr wrap="square" rtlCol="0" anchor="ctr">
             <a:normAutofit/>
           </a:bodyPr>
           <a:lstStyle/>
@@ -4024,7 +4024,7 @@
           </a:fontRef>
         </p:style>
         <p:txBody>
-          <a:bodyPr rtlCol="0" anchor="ctr" wrap="square">
+          <a:bodyPr wrap="square" rtlCol="0" anchor="ctr">
             <a:normAutofit/>
           </a:bodyPr>
           <a:lstStyle/>
@@ -4142,7 +4142,7 @@
           </a:fontRef>
         </p:style>
         <p:txBody>
-          <a:bodyPr rtlCol="0" anchor="ctr" wrap="square">
+          <a:bodyPr wrap="square" rtlCol="0" anchor="ctr">
             <a:normAutofit/>
           </a:bodyPr>
           <a:lstStyle/>
@@ -4188,7 +4188,7 @@
           </a:fontRef>
         </p:style>
         <p:txBody>
-          <a:bodyPr rtlCol="0" anchor="ctr" wrap="square">
+          <a:bodyPr wrap="square" rtlCol="0" anchor="ctr">
             <a:normAutofit/>
           </a:bodyPr>
           <a:lstStyle/>
@@ -4270,7 +4270,7 @@
           </a:fontRef>
         </p:style>
         <p:txBody>
-          <a:bodyPr rtlCol="0" anchor="ctr" wrap="square">
+          <a:bodyPr wrap="square" rtlCol="0" anchor="ctr">
             <a:normAutofit/>
           </a:bodyPr>
           <a:lstStyle/>
@@ -4388,7 +4388,7 @@
           </a:fontRef>
         </p:style>
         <p:txBody>
-          <a:bodyPr rtlCol="0" anchor="ctr" wrap="square">
+          <a:bodyPr wrap="square" rtlCol="0" anchor="ctr">
             <a:normAutofit/>
           </a:bodyPr>
           <a:lstStyle/>
@@ -4434,7 +4434,7 @@
           </a:fontRef>
         </p:style>
         <p:txBody>
-          <a:bodyPr rtlCol="0" anchor="ctr" wrap="square">
+          <a:bodyPr wrap="square" rtlCol="0" anchor="ctr">
             <a:normAutofit/>
           </a:bodyPr>
           <a:lstStyle/>
@@ -4555,7 +4555,7 @@
           </a:fontRef>
         </p:style>
         <p:txBody>
-          <a:bodyPr rtlCol="0" anchor="ctr" wrap="square">
+          <a:bodyPr wrap="square" rtlCol="0" anchor="ctr">
             <a:normAutofit/>
           </a:bodyPr>
           <a:lstStyle/>
@@ -4601,7 +4601,7 @@
           </a:fontRef>
         </p:style>
         <p:txBody>
-          <a:bodyPr rtlCol="0" anchor="ctr" wrap="square">
+          <a:bodyPr wrap="square" rtlCol="0" anchor="ctr">
             <a:normAutofit/>
           </a:bodyPr>
           <a:lstStyle/>
@@ -4779,7 +4779,7 @@
           </a:fontRef>
         </p:style>
         <p:txBody>
-          <a:bodyPr rtlCol="0" anchor="ctr" wrap="square">
+          <a:bodyPr wrap="square" rtlCol="0" anchor="ctr">
             <a:normAutofit/>
           </a:bodyPr>
           <a:lstStyle/>
@@ -4897,7 +4897,7 @@
           </a:fontRef>
         </p:style>
         <p:txBody>
-          <a:bodyPr rtlCol="0" anchor="ctr" wrap="square">
+          <a:bodyPr wrap="square" rtlCol="0" anchor="ctr">
             <a:normAutofit/>
           </a:bodyPr>
           <a:lstStyle/>
@@ -4943,7 +4943,7 @@
           </a:fontRef>
         </p:style>
         <p:txBody>
-          <a:bodyPr rtlCol="0" anchor="ctr" wrap="square">
+          <a:bodyPr wrap="square" rtlCol="0" anchor="ctr">
             <a:normAutofit/>
           </a:bodyPr>
           <a:lstStyle/>
@@ -5025,7 +5025,7 @@
           </a:fontRef>
         </p:style>
         <p:txBody>
-          <a:bodyPr rtlCol="0" anchor="ctr" wrap="square">
+          <a:bodyPr wrap="square" rtlCol="0" anchor="ctr">
             <a:normAutofit/>
           </a:bodyPr>
           <a:lstStyle/>
@@ -5143,7 +5143,7 @@
           </a:fontRef>
         </p:style>
         <p:txBody>
-          <a:bodyPr rtlCol="0" anchor="ctr" wrap="square">
+          <a:bodyPr wrap="square" rtlCol="0" anchor="ctr">
             <a:normAutofit/>
           </a:bodyPr>
           <a:lstStyle/>
@@ -5189,7 +5189,7 @@
           </a:fontRef>
         </p:style>
         <p:txBody>
-          <a:bodyPr rtlCol="0" anchor="ctr" wrap="square">
+          <a:bodyPr wrap="square" rtlCol="0" anchor="ctr">
             <a:normAutofit/>
           </a:bodyPr>
           <a:lstStyle/>
@@ -5310,7 +5310,7 @@
           </a:fontRef>
         </p:style>
         <p:txBody>
-          <a:bodyPr rtlCol="0" anchor="ctr" wrap="square">
+          <a:bodyPr wrap="square" rtlCol="0" anchor="ctr">
             <a:normAutofit/>
           </a:bodyPr>
           <a:lstStyle/>
@@ -5356,7 +5356,7 @@
           </a:fontRef>
         </p:style>
         <p:txBody>
-          <a:bodyPr rtlCol="0" anchor="ctr" wrap="square">
+          <a:bodyPr wrap="square" rtlCol="0" anchor="ctr">
             <a:normAutofit/>
           </a:bodyPr>
           <a:lstStyle/>
@@ -5425,7 +5425,300 @@
           <a:lstStyle/>
           <a:p>
             <a:r>
-              <a:t>• Tỷ lệ hệ thống kết luận nhầm "Có khác biệt" duy trì ở mức ~4.80% (Sát với ngưỡng lý tưởng 5%).</a:t>
+              <a:rPr dirty="0">
+                <a:solidFill>
+                  <a:schemeClr val="bg1"/>
+                </a:solidFill>
+              </a:rPr>
+              <a:t>• </a:t>
+            </a:r>
+            <a:r>
+              <a:rPr dirty="0" err="1">
+                <a:solidFill>
+                  <a:schemeClr val="bg1"/>
+                </a:solidFill>
+              </a:rPr>
+              <a:t>Tỷ</a:t>
+            </a:r>
+            <a:r>
+              <a:rPr dirty="0">
+                <a:solidFill>
+                  <a:schemeClr val="bg1"/>
+                </a:solidFill>
+              </a:rPr>
+              <a:t> </a:t>
+            </a:r>
+            <a:r>
+              <a:rPr dirty="0" err="1">
+                <a:solidFill>
+                  <a:schemeClr val="bg1"/>
+                </a:solidFill>
+              </a:rPr>
+              <a:t>lệ</a:t>
+            </a:r>
+            <a:r>
+              <a:rPr dirty="0">
+                <a:solidFill>
+                  <a:schemeClr val="bg1"/>
+                </a:solidFill>
+              </a:rPr>
+              <a:t> </a:t>
+            </a:r>
+            <a:r>
+              <a:rPr dirty="0" err="1">
+                <a:solidFill>
+                  <a:schemeClr val="bg1"/>
+                </a:solidFill>
+              </a:rPr>
+              <a:t>hệ</a:t>
+            </a:r>
+            <a:r>
+              <a:rPr dirty="0">
+                <a:solidFill>
+                  <a:schemeClr val="bg1"/>
+                </a:solidFill>
+              </a:rPr>
+              <a:t> </a:t>
+            </a:r>
+            <a:r>
+              <a:rPr dirty="0" err="1">
+                <a:solidFill>
+                  <a:schemeClr val="bg1"/>
+                </a:solidFill>
+              </a:rPr>
+              <a:t>thống</a:t>
+            </a:r>
+            <a:r>
+              <a:rPr dirty="0">
+                <a:solidFill>
+                  <a:schemeClr val="bg1"/>
+                </a:solidFill>
+              </a:rPr>
+              <a:t> </a:t>
+            </a:r>
+            <a:r>
+              <a:rPr dirty="0" err="1">
+                <a:solidFill>
+                  <a:schemeClr val="bg1"/>
+                </a:solidFill>
+              </a:rPr>
+              <a:t>kết</a:t>
+            </a:r>
+            <a:r>
+              <a:rPr dirty="0">
+                <a:solidFill>
+                  <a:schemeClr val="bg1"/>
+                </a:solidFill>
+              </a:rPr>
+              <a:t> </a:t>
+            </a:r>
+            <a:r>
+              <a:rPr dirty="0" err="1">
+                <a:solidFill>
+                  <a:schemeClr val="bg1"/>
+                </a:solidFill>
+              </a:rPr>
+              <a:t>luận</a:t>
+            </a:r>
+            <a:r>
+              <a:rPr dirty="0">
+                <a:solidFill>
+                  <a:schemeClr val="bg1"/>
+                </a:solidFill>
+              </a:rPr>
+              <a:t> </a:t>
+            </a:r>
+            <a:r>
+              <a:rPr dirty="0" err="1">
+                <a:solidFill>
+                  <a:schemeClr val="bg1"/>
+                </a:solidFill>
+              </a:rPr>
+              <a:t>nhầm</a:t>
+            </a:r>
+            <a:r>
+              <a:rPr dirty="0">
+                <a:solidFill>
+                  <a:schemeClr val="bg1"/>
+                </a:solidFill>
+              </a:rPr>
+              <a:t> "</a:t>
+            </a:r>
+            <a:r>
+              <a:rPr dirty="0" err="1">
+                <a:solidFill>
+                  <a:schemeClr val="bg1"/>
+                </a:solidFill>
+              </a:rPr>
+              <a:t>Có</a:t>
+            </a:r>
+            <a:r>
+              <a:rPr dirty="0">
+                <a:solidFill>
+                  <a:schemeClr val="bg1"/>
+                </a:solidFill>
+              </a:rPr>
+              <a:t> </a:t>
+            </a:r>
+            <a:r>
+              <a:rPr dirty="0" err="1">
+                <a:solidFill>
+                  <a:schemeClr val="bg1"/>
+                </a:solidFill>
+              </a:rPr>
+              <a:t>khác</a:t>
+            </a:r>
+            <a:r>
+              <a:rPr dirty="0">
+                <a:solidFill>
+                  <a:schemeClr val="bg1"/>
+                </a:solidFill>
+              </a:rPr>
+              <a:t> </a:t>
+            </a:r>
+            <a:r>
+              <a:rPr dirty="0" err="1">
+                <a:solidFill>
+                  <a:schemeClr val="bg1"/>
+                </a:solidFill>
+              </a:rPr>
+              <a:t>biệt</a:t>
+            </a:r>
+            <a:r>
+              <a:rPr dirty="0">
+                <a:solidFill>
+                  <a:schemeClr val="bg1"/>
+                </a:solidFill>
+              </a:rPr>
+              <a:t>" </a:t>
+            </a:r>
+            <a:r>
+              <a:rPr dirty="0" err="1">
+                <a:solidFill>
+                  <a:schemeClr val="bg1"/>
+                </a:solidFill>
+              </a:rPr>
+              <a:t>duy</a:t>
+            </a:r>
+            <a:r>
+              <a:rPr dirty="0">
+                <a:solidFill>
+                  <a:schemeClr val="bg1"/>
+                </a:solidFill>
+              </a:rPr>
+              <a:t> </a:t>
+            </a:r>
+            <a:r>
+              <a:rPr dirty="0" err="1">
+                <a:solidFill>
+                  <a:schemeClr val="bg1"/>
+                </a:solidFill>
+              </a:rPr>
+              <a:t>trì</a:t>
+            </a:r>
+            <a:r>
+              <a:rPr dirty="0">
+                <a:solidFill>
+                  <a:schemeClr val="bg1"/>
+                </a:solidFill>
+              </a:rPr>
+              <a:t> ở </a:t>
+            </a:r>
+            <a:r>
+              <a:rPr dirty="0" err="1">
+                <a:solidFill>
+                  <a:schemeClr val="bg1"/>
+                </a:solidFill>
+              </a:rPr>
+              <a:t>mức</a:t>
+            </a:r>
+            <a:r>
+              <a:rPr dirty="0">
+                <a:solidFill>
+                  <a:schemeClr val="bg1"/>
+                </a:solidFill>
+              </a:rPr>
+              <a:t> ~4.80% (</a:t>
+            </a:r>
+            <a:r>
+              <a:rPr dirty="0" err="1">
+                <a:solidFill>
+                  <a:schemeClr val="bg1"/>
+                </a:solidFill>
+              </a:rPr>
+              <a:t>Sát</a:t>
+            </a:r>
+            <a:r>
+              <a:rPr dirty="0">
+                <a:solidFill>
+                  <a:schemeClr val="bg1"/>
+                </a:solidFill>
+              </a:rPr>
+              <a:t> </a:t>
+            </a:r>
+            <a:r>
+              <a:rPr dirty="0" err="1">
+                <a:solidFill>
+                  <a:schemeClr val="bg1"/>
+                </a:solidFill>
+              </a:rPr>
+              <a:t>với</a:t>
+            </a:r>
+            <a:r>
+              <a:rPr dirty="0">
+                <a:solidFill>
+                  <a:schemeClr val="bg1"/>
+                </a:solidFill>
+              </a:rPr>
+              <a:t> </a:t>
+            </a:r>
+            <a:r>
+              <a:rPr dirty="0" err="1">
+                <a:solidFill>
+                  <a:schemeClr val="bg1"/>
+                </a:solidFill>
+              </a:rPr>
+              <a:t>ngưỡng</a:t>
+            </a:r>
+            <a:r>
+              <a:rPr dirty="0">
+                <a:solidFill>
+                  <a:schemeClr val="bg1"/>
+                </a:solidFill>
+              </a:rPr>
+              <a:t> </a:t>
+            </a:r>
+            <a:r>
+              <a:rPr dirty="0" err="1">
+                <a:solidFill>
+                  <a:schemeClr val="bg1"/>
+                </a:solidFill>
+              </a:rPr>
+              <a:t>lý</a:t>
+            </a:r>
+            <a:r>
+              <a:rPr dirty="0">
+                <a:solidFill>
+                  <a:schemeClr val="bg1"/>
+                </a:solidFill>
+              </a:rPr>
+              <a:t> </a:t>
+            </a:r>
+            <a:r>
+              <a:rPr dirty="0" err="1">
+                <a:solidFill>
+                  <a:schemeClr val="bg1"/>
+                </a:solidFill>
+              </a:rPr>
+              <a:t>tưởng</a:t>
+            </a:r>
+            <a:r>
+              <a:rPr dirty="0">
+                <a:solidFill>
+                  <a:schemeClr val="bg1"/>
+                </a:solidFill>
+              </a:rPr>
+              <a:t> 5%).</a:t>
             </a:r>
           </a:p>
         </p:txBody>
@@ -5491,7 +5784,7 @@
           </a:fontRef>
         </p:style>
         <p:txBody>
-          <a:bodyPr rtlCol="0" anchor="ctr" wrap="square">
+          <a:bodyPr wrap="square" rtlCol="0" anchor="ctr">
             <a:normAutofit/>
           </a:bodyPr>
           <a:lstStyle/>
@@ -5609,7 +5902,7 @@
           </a:fontRef>
         </p:style>
         <p:txBody>
-          <a:bodyPr rtlCol="0" anchor="ctr" wrap="square">
+          <a:bodyPr wrap="square" rtlCol="0" anchor="ctr">
             <a:normAutofit/>
           </a:bodyPr>
           <a:lstStyle/>
@@ -5655,7 +5948,7 @@
           </a:fontRef>
         </p:style>
         <p:txBody>
-          <a:bodyPr rtlCol="0" anchor="ctr" wrap="square">
+          <a:bodyPr wrap="square" rtlCol="0" anchor="ctr">
             <a:normAutofit/>
           </a:bodyPr>
           <a:lstStyle/>
@@ -5737,7 +6030,7 @@
           </a:fontRef>
         </p:style>
         <p:txBody>
-          <a:bodyPr rtlCol="0" anchor="ctr" wrap="square">
+          <a:bodyPr wrap="square" rtlCol="0" anchor="ctr">
             <a:normAutofit/>
           </a:bodyPr>
           <a:lstStyle/>
@@ -5855,7 +6148,7 @@
           </a:fontRef>
         </p:style>
         <p:txBody>
-          <a:bodyPr rtlCol="0" anchor="ctr" wrap="square">
+          <a:bodyPr wrap="square" rtlCol="0" anchor="ctr">
             <a:normAutofit/>
           </a:bodyPr>
           <a:lstStyle/>
@@ -5901,7 +6194,7 @@
           </a:fontRef>
         </p:style>
         <p:txBody>
-          <a:bodyPr rtlCol="0" anchor="ctr" wrap="square">
+          <a:bodyPr wrap="square" rtlCol="0" anchor="ctr">
             <a:normAutofit/>
           </a:bodyPr>
           <a:lstStyle/>
@@ -5933,7 +6226,7 @@
           </a:bodyPr>
           <a:lstStyle/>
           <a:p>
-            <a:pPr>
+            <a:pPr algn="ctr">
               <a:defRPr sz="1600" b="1">
                 <a:solidFill>
                   <a:srgbClr val="FFB800"/>
@@ -5942,7 +6235,28 @@
               </a:defRPr>
             </a:pPr>
             <a:r>
-              <a:t>Giả thuyết Không (H0)</a:t>
+              <a:rPr dirty="0" err="1"/>
+              <a:t>Giả</a:t>
+            </a:r>
+            <a:r>
+              <a:rPr dirty="0"/>
+              <a:t> </a:t>
+            </a:r>
+            <a:r>
+              <a:rPr dirty="0" err="1"/>
+              <a:t>thuyết</a:t>
+            </a:r>
+            <a:r>
+              <a:rPr dirty="0"/>
+              <a:t> </a:t>
+            </a:r>
+            <a:r>
+              <a:rPr dirty="0" err="1"/>
+              <a:t>Không</a:t>
+            </a:r>
+            <a:r>
+              <a:rPr dirty="0"/>
+              <a:t> (H0)</a:t>
             </a:r>
           </a:p>
         </p:txBody>
@@ -6022,7 +6336,7 @@
           </a:fontRef>
         </p:style>
         <p:txBody>
-          <a:bodyPr rtlCol="0" anchor="ctr" wrap="square">
+          <a:bodyPr wrap="square" rtlCol="0" anchor="ctr">
             <a:normAutofit/>
           </a:bodyPr>
           <a:lstStyle/>
@@ -6068,7 +6382,7 @@
           </a:fontRef>
         </p:style>
         <p:txBody>
-          <a:bodyPr rtlCol="0" anchor="ctr" wrap="square">
+          <a:bodyPr wrap="square" rtlCol="0" anchor="ctr">
             <a:normAutofit/>
           </a:bodyPr>
           <a:lstStyle/>
@@ -6100,7 +6414,7 @@
           </a:bodyPr>
           <a:lstStyle/>
           <a:p>
-            <a:pPr>
+            <a:pPr algn="ctr">
               <a:defRPr sz="1600" b="1">
                 <a:solidFill>
                   <a:srgbClr val="38BDF8"/>
@@ -6235,7 +6549,7 @@
           </a:fontRef>
         </p:style>
         <p:txBody>
-          <a:bodyPr rtlCol="0" anchor="ctr" wrap="square">
+          <a:bodyPr wrap="square" rtlCol="0" anchor="ctr">
             <a:normAutofit/>
           </a:bodyPr>
           <a:lstStyle/>
@@ -6353,7 +6667,7 @@
           </a:fontRef>
         </p:style>
         <p:txBody>
-          <a:bodyPr rtlCol="0" anchor="ctr" wrap="square">
+          <a:bodyPr wrap="square" rtlCol="0" anchor="ctr">
             <a:normAutofit/>
           </a:bodyPr>
           <a:lstStyle/>
@@ -6399,7 +6713,7 @@
           </a:fontRef>
         </p:style>
         <p:txBody>
-          <a:bodyPr rtlCol="0" anchor="ctr" wrap="square">
+          <a:bodyPr wrap="square" rtlCol="0" anchor="ctr">
             <a:normAutofit/>
           </a:bodyPr>
           <a:lstStyle/>
@@ -6481,7 +6795,7 @@
           </a:fontRef>
         </p:style>
         <p:txBody>
-          <a:bodyPr rtlCol="0" anchor="ctr" wrap="square">
+          <a:bodyPr wrap="square" rtlCol="0" anchor="ctr">
             <a:normAutofit/>
           </a:bodyPr>
           <a:lstStyle/>
@@ -6599,7 +6913,7 @@
           </a:fontRef>
         </p:style>
         <p:txBody>
-          <a:bodyPr rtlCol="0" anchor="ctr" wrap="square">
+          <a:bodyPr wrap="square" rtlCol="0" anchor="ctr">
             <a:normAutofit/>
           </a:bodyPr>
           <a:lstStyle/>
@@ -6645,7 +6959,7 @@
           </a:fontRef>
         </p:style>
         <p:txBody>
-          <a:bodyPr rtlCol="0" anchor="ctr" wrap="square">
+          <a:bodyPr wrap="square" rtlCol="0" anchor="ctr">
             <a:normAutofit/>
           </a:bodyPr>
           <a:lstStyle/>
@@ -6677,7 +6991,7 @@
           </a:bodyPr>
           <a:lstStyle/>
           <a:p>
-            <a:pPr>
+            <a:pPr algn="ctr">
               <a:defRPr sz="1600" b="1">
                 <a:solidFill>
                   <a:srgbClr val="F472B6"/>
@@ -6686,6 +7000,7 @@
               </a:defRPr>
             </a:pPr>
             <a:r>
+              <a:rPr dirty="0"/>
               <a:t>Sanity Checks</a:t>
             </a:r>
           </a:p>
@@ -6782,7 +7097,7 @@
           </a:fontRef>
         </p:style>
         <p:txBody>
-          <a:bodyPr rtlCol="0" anchor="ctr" wrap="square">
+          <a:bodyPr wrap="square" rtlCol="0" anchor="ctr">
             <a:normAutofit/>
           </a:bodyPr>
           <a:lstStyle/>
@@ -6828,7 +7143,7 @@
           </a:fontRef>
         </p:style>
         <p:txBody>
-          <a:bodyPr rtlCol="0" anchor="ctr" wrap="square">
+          <a:bodyPr wrap="square" rtlCol="0" anchor="ctr">
             <a:normAutofit/>
           </a:bodyPr>
           <a:lstStyle/>
@@ -6860,7 +7175,7 @@
           </a:bodyPr>
           <a:lstStyle/>
           <a:p>
-            <a:pPr>
+            <a:pPr algn="ctr">
               <a:defRPr sz="1600" b="1">
                 <a:solidFill>
                   <a:srgbClr val="34D399"/>
@@ -6995,7 +7310,7 @@
           </a:fontRef>
         </p:style>
         <p:txBody>
-          <a:bodyPr rtlCol="0" anchor="ctr" wrap="square">
+          <a:bodyPr wrap="square" rtlCol="0" anchor="ctr">
             <a:normAutofit/>
           </a:bodyPr>
           <a:lstStyle/>
@@ -7113,7 +7428,7 @@
           </a:fontRef>
         </p:style>
         <p:txBody>
-          <a:bodyPr rtlCol="0" anchor="ctr" wrap="square">
+          <a:bodyPr wrap="square" rtlCol="0" anchor="ctr">
             <a:normAutofit/>
           </a:bodyPr>
           <a:lstStyle/>
@@ -7159,7 +7474,7 @@
           </a:fontRef>
         </p:style>
         <p:txBody>
-          <a:bodyPr rtlCol="0" anchor="ctr" wrap="square">
+          <a:bodyPr wrap="square" rtlCol="0" anchor="ctr">
             <a:normAutofit/>
           </a:bodyPr>
           <a:lstStyle/>
@@ -7241,7 +7556,7 @@
           </a:fontRef>
         </p:style>
         <p:txBody>
-          <a:bodyPr rtlCol="0" anchor="ctr" wrap="square">
+          <a:bodyPr wrap="square" rtlCol="0" anchor="ctr">
             <a:normAutofit/>
           </a:bodyPr>
           <a:lstStyle/>
@@ -7359,7 +7674,7 @@
           </a:fontRef>
         </p:style>
         <p:txBody>
-          <a:bodyPr rtlCol="0" anchor="ctr" wrap="square">
+          <a:bodyPr wrap="square" rtlCol="0" anchor="ctr">
             <a:normAutofit/>
           </a:bodyPr>
           <a:lstStyle/>
@@ -7405,7 +7720,7 @@
           </a:fontRef>
         </p:style>
         <p:txBody>
-          <a:bodyPr rtlCol="0" anchor="ctr" wrap="square">
+          <a:bodyPr wrap="square" rtlCol="0" anchor="ctr">
             <a:normAutofit/>
           </a:bodyPr>
           <a:lstStyle/>
@@ -7526,7 +7841,7 @@
           </a:fontRef>
         </p:style>
         <p:txBody>
-          <a:bodyPr rtlCol="0" anchor="ctr" wrap="square">
+          <a:bodyPr wrap="square" rtlCol="0" anchor="ctr">
             <a:normAutofit/>
           </a:bodyPr>
           <a:lstStyle/>
@@ -7572,7 +7887,7 @@
           </a:fontRef>
         </p:style>
         <p:txBody>
-          <a:bodyPr rtlCol="0" anchor="ctr" wrap="square">
+          <a:bodyPr wrap="square" rtlCol="0" anchor="ctr">
             <a:normAutofit/>
           </a:bodyPr>
           <a:lstStyle/>
@@ -7753,7 +8068,7 @@
           </a:fontRef>
         </p:style>
         <p:txBody>
-          <a:bodyPr rtlCol="0" anchor="ctr" wrap="square">
+          <a:bodyPr wrap="square" rtlCol="0" anchor="ctr">
             <a:normAutofit/>
           </a:bodyPr>
           <a:lstStyle/>
@@ -7871,7 +8186,7 @@
           </a:fontRef>
         </p:style>
         <p:txBody>
-          <a:bodyPr rtlCol="0" anchor="ctr" wrap="square">
+          <a:bodyPr wrap="square" rtlCol="0" anchor="ctr">
             <a:normAutofit/>
           </a:bodyPr>
           <a:lstStyle/>
@@ -7917,7 +8232,7 @@
           </a:fontRef>
         </p:style>
         <p:txBody>
-          <a:bodyPr rtlCol="0" anchor="ctr" wrap="square">
+          <a:bodyPr wrap="square" rtlCol="0" anchor="ctr">
             <a:normAutofit/>
           </a:bodyPr>
           <a:lstStyle/>
@@ -7999,7 +8314,7 @@
           </a:fontRef>
         </p:style>
         <p:txBody>
-          <a:bodyPr rtlCol="0" anchor="ctr" wrap="square">
+          <a:bodyPr wrap="square" rtlCol="0" anchor="ctr">
             <a:normAutofit/>
           </a:bodyPr>
           <a:lstStyle/>
@@ -8117,7 +8432,7 @@
           </a:fontRef>
         </p:style>
         <p:txBody>
-          <a:bodyPr rtlCol="0" anchor="ctr" wrap="square">
+          <a:bodyPr wrap="square" rtlCol="0" anchor="ctr">
             <a:normAutofit/>
           </a:bodyPr>
           <a:lstStyle/>
@@ -8163,7 +8478,7 @@
           </a:fontRef>
         </p:style>
         <p:txBody>
-          <a:bodyPr rtlCol="0" anchor="ctr" wrap="square">
+          <a:bodyPr wrap="square" rtlCol="0" anchor="ctr">
             <a:normAutofit/>
           </a:bodyPr>
           <a:lstStyle/>
@@ -8284,7 +8599,7 @@
           </a:fontRef>
         </p:style>
         <p:txBody>
-          <a:bodyPr rtlCol="0" anchor="ctr" wrap="square">
+          <a:bodyPr wrap="square" rtlCol="0" anchor="ctr">
             <a:normAutofit/>
           </a:bodyPr>
           <a:lstStyle/>
@@ -8330,7 +8645,7 @@
           </a:fontRef>
         </p:style>
         <p:txBody>
-          <a:bodyPr rtlCol="0" anchor="ctr" wrap="square">
+          <a:bodyPr wrap="square" rtlCol="0" anchor="ctr">
             <a:normAutofit/>
           </a:bodyPr>
           <a:lstStyle/>
@@ -8511,7 +8826,7 @@
           </a:fontRef>
         </p:style>
         <p:txBody>
-          <a:bodyPr rtlCol="0" anchor="ctr" wrap="square">
+          <a:bodyPr wrap="square" rtlCol="0" anchor="ctr">
             <a:normAutofit/>
           </a:bodyPr>
           <a:lstStyle/>
@@ -8629,7 +8944,7 @@
           </a:fontRef>
         </p:style>
         <p:txBody>
-          <a:bodyPr rtlCol="0" anchor="ctr" wrap="square">
+          <a:bodyPr wrap="square" rtlCol="0" anchor="ctr">
             <a:normAutofit/>
           </a:bodyPr>
           <a:lstStyle/>
@@ -8675,7 +8990,7 @@
           </a:fontRef>
         </p:style>
         <p:txBody>
-          <a:bodyPr rtlCol="0" anchor="ctr" wrap="square">
+          <a:bodyPr wrap="square" rtlCol="0" anchor="ctr">
             <a:normAutofit/>
           </a:bodyPr>
           <a:lstStyle/>
@@ -8757,7 +9072,7 @@
           </a:fontRef>
         </p:style>
         <p:txBody>
-          <a:bodyPr rtlCol="0" anchor="ctr" wrap="square">
+          <a:bodyPr wrap="square" rtlCol="0" anchor="ctr">
             <a:normAutofit/>
           </a:bodyPr>
           <a:lstStyle/>
@@ -8875,7 +9190,7 @@
           </a:fontRef>
         </p:style>
         <p:txBody>
-          <a:bodyPr rtlCol="0" anchor="ctr" wrap="square">
+          <a:bodyPr wrap="square" rtlCol="0" anchor="ctr">
             <a:normAutofit/>
           </a:bodyPr>
           <a:lstStyle/>
@@ -8921,7 +9236,7 @@
           </a:fontRef>
         </p:style>
         <p:txBody>
-          <a:bodyPr rtlCol="0" anchor="ctr" wrap="square">
+          <a:bodyPr wrap="square" rtlCol="0" anchor="ctr">
             <a:normAutofit/>
           </a:bodyPr>
           <a:lstStyle/>
@@ -9042,7 +9357,7 @@
           </a:fontRef>
         </p:style>
         <p:txBody>
-          <a:bodyPr rtlCol="0" anchor="ctr" wrap="square">
+          <a:bodyPr wrap="square" rtlCol="0" anchor="ctr">
             <a:normAutofit/>
           </a:bodyPr>
           <a:lstStyle/>
@@ -9088,7 +9403,7 @@
           </a:fontRef>
         </p:style>
         <p:txBody>
-          <a:bodyPr rtlCol="0" anchor="ctr" wrap="square">
+          <a:bodyPr wrap="square" rtlCol="0" anchor="ctr">
             <a:normAutofit/>
           </a:bodyPr>
           <a:lstStyle/>

</xml_diff>

<commit_message>
Update Week 4 A/A and A/B Testing: Fix plots, notebook outputs, and presentation slides
</commit_message>
<xml_diff>
--- a/docs/Week4_AA_AB_Testing_Summary.pptx
+++ b/docs/Week4_AA_AB_Testing_Summary.pptx
@@ -4681,21 +4681,21 @@
               </a:defRPr>
             </a:pPr>
             <a:r>
-              <a:t>• Hệ thống vượt qua kiểm định Sample Ratio Mismatch, tỷ lệ chia luôn duy trì ở mức 50.0/50.0.</a:t>
+              <a:t>• Hệ thống đo lường Covariate Balance bằng SMD (Standardized Mean Difference) và vượt qua SRM, tỷ lệ chia luôn duy trì ở mức 50.0/50.0.</a:t>
             </a:r>
           </a:p>
         </p:txBody>
       </p:sp>
       <p:pic>
         <p:nvPicPr>
-          <p:cNvPr id="19" name="Picture 18" descr="week5_aa_testing_0.png"/>
+          <p:cNvPr id="19" name="Picture 18" descr="smd_plot_styled.png"/>
           <p:cNvPicPr>
             <a:picLocks noChangeAspect="1"/>
           </p:cNvPicPr>
           <p:nvPr/>
         </p:nvPicPr>
         <p:blipFill>
-          <a:blip r:embed="rId2"/>
+          <a:blip r:embed="rId5"/>
           <a:stretch>
             <a:fillRect/>
           </a:stretch>
@@ -4703,7 +4703,7 @@
         <p:spPr>
           <a:xfrm>
             <a:off x="4572000" y="2286000"/>
-            <a:ext cx="4206240" cy="2733064"/>
+            <a:ext cx="4206240" cy="2103120"/>
           </a:xfrm>
           <a:prstGeom prst="rect">
             <a:avLst/>
@@ -5430,295 +5430,7 @@
                   <a:schemeClr val="bg1"/>
                 </a:solidFill>
               </a:rPr>
-              <a:t>• </a:t>
-            </a:r>
-            <a:r>
-              <a:rPr dirty="0" err="1">
-                <a:solidFill>
-                  <a:schemeClr val="bg1"/>
-                </a:solidFill>
-              </a:rPr>
-              <a:t>Tỷ</a:t>
-            </a:r>
-            <a:r>
-              <a:rPr dirty="0">
-                <a:solidFill>
-                  <a:schemeClr val="bg1"/>
-                </a:solidFill>
-              </a:rPr>
-              <a:t> </a:t>
-            </a:r>
-            <a:r>
-              <a:rPr dirty="0" err="1">
-                <a:solidFill>
-                  <a:schemeClr val="bg1"/>
-                </a:solidFill>
-              </a:rPr>
-              <a:t>lệ</a:t>
-            </a:r>
-            <a:r>
-              <a:rPr dirty="0">
-                <a:solidFill>
-                  <a:schemeClr val="bg1"/>
-                </a:solidFill>
-              </a:rPr>
-              <a:t> </a:t>
-            </a:r>
-            <a:r>
-              <a:rPr dirty="0" err="1">
-                <a:solidFill>
-                  <a:schemeClr val="bg1"/>
-                </a:solidFill>
-              </a:rPr>
-              <a:t>hệ</a:t>
-            </a:r>
-            <a:r>
-              <a:rPr dirty="0">
-                <a:solidFill>
-                  <a:schemeClr val="bg1"/>
-                </a:solidFill>
-              </a:rPr>
-              <a:t> </a:t>
-            </a:r>
-            <a:r>
-              <a:rPr dirty="0" err="1">
-                <a:solidFill>
-                  <a:schemeClr val="bg1"/>
-                </a:solidFill>
-              </a:rPr>
-              <a:t>thống</a:t>
-            </a:r>
-            <a:r>
-              <a:rPr dirty="0">
-                <a:solidFill>
-                  <a:schemeClr val="bg1"/>
-                </a:solidFill>
-              </a:rPr>
-              <a:t> </a:t>
-            </a:r>
-            <a:r>
-              <a:rPr dirty="0" err="1">
-                <a:solidFill>
-                  <a:schemeClr val="bg1"/>
-                </a:solidFill>
-              </a:rPr>
-              <a:t>kết</a:t>
-            </a:r>
-            <a:r>
-              <a:rPr dirty="0">
-                <a:solidFill>
-                  <a:schemeClr val="bg1"/>
-                </a:solidFill>
-              </a:rPr>
-              <a:t> </a:t>
-            </a:r>
-            <a:r>
-              <a:rPr dirty="0" err="1">
-                <a:solidFill>
-                  <a:schemeClr val="bg1"/>
-                </a:solidFill>
-              </a:rPr>
-              <a:t>luận</a:t>
-            </a:r>
-            <a:r>
-              <a:rPr dirty="0">
-                <a:solidFill>
-                  <a:schemeClr val="bg1"/>
-                </a:solidFill>
-              </a:rPr>
-              <a:t> </a:t>
-            </a:r>
-            <a:r>
-              <a:rPr dirty="0" err="1">
-                <a:solidFill>
-                  <a:schemeClr val="bg1"/>
-                </a:solidFill>
-              </a:rPr>
-              <a:t>nhầm</a:t>
-            </a:r>
-            <a:r>
-              <a:rPr dirty="0">
-                <a:solidFill>
-                  <a:schemeClr val="bg1"/>
-                </a:solidFill>
-              </a:rPr>
-              <a:t> "</a:t>
-            </a:r>
-            <a:r>
-              <a:rPr dirty="0" err="1">
-                <a:solidFill>
-                  <a:schemeClr val="bg1"/>
-                </a:solidFill>
-              </a:rPr>
-              <a:t>Có</a:t>
-            </a:r>
-            <a:r>
-              <a:rPr dirty="0">
-                <a:solidFill>
-                  <a:schemeClr val="bg1"/>
-                </a:solidFill>
-              </a:rPr>
-              <a:t> </a:t>
-            </a:r>
-            <a:r>
-              <a:rPr dirty="0" err="1">
-                <a:solidFill>
-                  <a:schemeClr val="bg1"/>
-                </a:solidFill>
-              </a:rPr>
-              <a:t>khác</a:t>
-            </a:r>
-            <a:r>
-              <a:rPr dirty="0">
-                <a:solidFill>
-                  <a:schemeClr val="bg1"/>
-                </a:solidFill>
-              </a:rPr>
-              <a:t> </a:t>
-            </a:r>
-            <a:r>
-              <a:rPr dirty="0" err="1">
-                <a:solidFill>
-                  <a:schemeClr val="bg1"/>
-                </a:solidFill>
-              </a:rPr>
-              <a:t>biệt</a:t>
-            </a:r>
-            <a:r>
-              <a:rPr dirty="0">
-                <a:solidFill>
-                  <a:schemeClr val="bg1"/>
-                </a:solidFill>
-              </a:rPr>
-              <a:t>" </a:t>
-            </a:r>
-            <a:r>
-              <a:rPr dirty="0" err="1">
-                <a:solidFill>
-                  <a:schemeClr val="bg1"/>
-                </a:solidFill>
-              </a:rPr>
-              <a:t>duy</a:t>
-            </a:r>
-            <a:r>
-              <a:rPr dirty="0">
-                <a:solidFill>
-                  <a:schemeClr val="bg1"/>
-                </a:solidFill>
-              </a:rPr>
-              <a:t> </a:t>
-            </a:r>
-            <a:r>
-              <a:rPr dirty="0" err="1">
-                <a:solidFill>
-                  <a:schemeClr val="bg1"/>
-                </a:solidFill>
-              </a:rPr>
-              <a:t>trì</a:t>
-            </a:r>
-            <a:r>
-              <a:rPr dirty="0">
-                <a:solidFill>
-                  <a:schemeClr val="bg1"/>
-                </a:solidFill>
-              </a:rPr>
-              <a:t> ở </a:t>
-            </a:r>
-            <a:r>
-              <a:rPr dirty="0" err="1">
-                <a:solidFill>
-                  <a:schemeClr val="bg1"/>
-                </a:solidFill>
-              </a:rPr>
-              <a:t>mức</a:t>
-            </a:r>
-            <a:r>
-              <a:rPr dirty="0">
-                <a:solidFill>
-                  <a:schemeClr val="bg1"/>
-                </a:solidFill>
-              </a:rPr>
-              <a:t> ~4.80% (</a:t>
-            </a:r>
-            <a:r>
-              <a:rPr dirty="0" err="1">
-                <a:solidFill>
-                  <a:schemeClr val="bg1"/>
-                </a:solidFill>
-              </a:rPr>
-              <a:t>Sát</a:t>
-            </a:r>
-            <a:r>
-              <a:rPr dirty="0">
-                <a:solidFill>
-                  <a:schemeClr val="bg1"/>
-                </a:solidFill>
-              </a:rPr>
-              <a:t> </a:t>
-            </a:r>
-            <a:r>
-              <a:rPr dirty="0" err="1">
-                <a:solidFill>
-                  <a:schemeClr val="bg1"/>
-                </a:solidFill>
-              </a:rPr>
-              <a:t>với</a:t>
-            </a:r>
-            <a:r>
-              <a:rPr dirty="0">
-                <a:solidFill>
-                  <a:schemeClr val="bg1"/>
-                </a:solidFill>
-              </a:rPr>
-              <a:t> </a:t>
-            </a:r>
-            <a:r>
-              <a:rPr dirty="0" err="1">
-                <a:solidFill>
-                  <a:schemeClr val="bg1"/>
-                </a:solidFill>
-              </a:rPr>
-              <a:t>ngưỡng</a:t>
-            </a:r>
-            <a:r>
-              <a:rPr dirty="0">
-                <a:solidFill>
-                  <a:schemeClr val="bg1"/>
-                </a:solidFill>
-              </a:rPr>
-              <a:t> </a:t>
-            </a:r>
-            <a:r>
-              <a:rPr dirty="0" err="1">
-                <a:solidFill>
-                  <a:schemeClr val="bg1"/>
-                </a:solidFill>
-              </a:rPr>
-              <a:t>lý</a:t>
-            </a:r>
-            <a:r>
-              <a:rPr dirty="0">
-                <a:solidFill>
-                  <a:schemeClr val="bg1"/>
-                </a:solidFill>
-              </a:rPr>
-              <a:t> </a:t>
-            </a:r>
-            <a:r>
-              <a:rPr dirty="0" err="1">
-                <a:solidFill>
-                  <a:schemeClr val="bg1"/>
-                </a:solidFill>
-              </a:rPr>
-              <a:t>tưởng</a:t>
-            </a:r>
-            <a:r>
-              <a:rPr dirty="0">
-                <a:solidFill>
-                  <a:schemeClr val="bg1"/>
-                </a:solidFill>
-              </a:rPr>
-              <a:t> 5%).</a:t>
+              <a:t>• FPR = 5.08% (KS-test P-value=0.5691). Monte Carlo Stress Test 1.000 vòng xác nhận OLS HC1 Bias = gần 0.</a:t>
             </a:r>
           </a:p>
         </p:txBody>
@@ -7974,20 +7686,14 @@
       </p:sp>
       <p:pic>
         <p:nvPicPr>
-          <p:cNvPr id="20" name="Picture 19">
-            <a:extLst>
-              <a:ext uri="{FF2B5EF4-FFF2-40B4-BE49-F238E27FC236}">
-                <a16:creationId xmlns:a16="http://schemas.microsoft.com/office/drawing/2014/main" id="{7FA9759F-5050-24D0-A001-29BA7BDA5A2D}"/>
-              </a:ext>
-            </a:extLst>
-          </p:cNvPr>
+          <p:cNvPr id="19" name="Picture 18" descr="dist_plot_styled.png"/>
           <p:cNvPicPr>
-            <a:picLocks/>
+            <a:picLocks noChangeAspect="1"/>
           </p:cNvPicPr>
           <p:nvPr/>
         </p:nvPicPr>
         <p:blipFill>
-          <a:blip r:embed="rId2"/>
+          <a:blip r:embed="rId4"/>
           <a:stretch>
             <a:fillRect/>
           </a:stretch>
@@ -7995,7 +7701,7 @@
         <p:spPr>
           <a:xfrm>
             <a:off x="4572000" y="2286000"/>
-            <a:ext cx="4206240" cy="2272824"/>
+            <a:ext cx="4206240" cy="2103120"/>
           </a:xfrm>
           <a:prstGeom prst="rect">
             <a:avLst/>
@@ -8109,7 +7815,7 @@
               </a:defRPr>
             </a:pPr>
             <a:r>
-              <a:t>4. Phân tích Hồi quy Tuyến tính (OLS)</a:t>
+              <a:t>4. Hồi quy OLS với HC1 (Robust SE)</a:t>
             </a:r>
           </a:p>
         </p:txBody>
@@ -8145,7 +7851,7 @@
               </a:defRPr>
             </a:pPr>
             <a:r>
-              <a:t>Đo lường Net Effect</a:t>
+              <a:t>Giảm Phương sai + HC1 Robust SE</a:t>
             </a:r>
           </a:p>
         </p:txBody>
@@ -8519,7 +8225,7 @@
               </a:defRPr>
             </a:pPr>
             <a:r>
-              <a:t>Kiểm soát Covariates</a:t>
+              <a:t>Kiểm soát Covariates (Giảm Phương Sai)</a:t>
             </a:r>
           </a:p>
         </p:txBody>
@@ -8558,7 +8264,7 @@
               </a:defRPr>
             </a:pPr>
             <a:r>
-              <a:t>• Hồi quy OLS cho phép cô lập tác động của Voucher khỏi các biến nhiễu ngoại cảnh (Thời tiết, Vị trí).</a:t>
+              <a:t>• OLS đưa lịch sử chuyến đi vào làm Covariate để giảm phương sai (CUPED technique). HC1 xử lý Heteroskedasticity.</a:t>
             </a:r>
           </a:p>
         </p:txBody>
@@ -8571,7 +8277,7 @@
         </p:nvSpPr>
         <p:spPr>
           <a:xfrm>
-            <a:off x="640080" y="3840480"/>
+            <a:off x="4663440" y="1463040"/>
             <a:ext cx="3840480" cy="2240280"/>
           </a:xfrm>
           <a:prstGeom prst="roundRect">
@@ -8617,7 +8323,7 @@
         </p:nvSpPr>
         <p:spPr>
           <a:xfrm>
-            <a:off x="777240" y="4206240"/>
+            <a:off x="4800600" y="1828800"/>
             <a:ext cx="3566160" cy="36576"/>
           </a:xfrm>
           <a:prstGeom prst="rect">
@@ -8663,7 +8369,7 @@
         </p:nvSpPr>
         <p:spPr>
           <a:xfrm>
-            <a:off x="685800" y="3886200"/>
+            <a:off x="4709160" y="1508760"/>
             <a:ext cx="3749040" cy="365760"/>
           </a:xfrm>
           <a:prstGeom prst="rect">
@@ -8699,7 +8405,7 @@
         </p:nvSpPr>
         <p:spPr>
           <a:xfrm>
-            <a:off x="685800" y="4251960"/>
+            <a:off x="4709160" y="1874520"/>
             <a:ext cx="3749040" cy="1783080"/>
           </a:xfrm>
           <a:prstGeom prst="rect">
@@ -8725,41 +8431,11 @@
               </a:defRPr>
             </a:pPr>
             <a:r>
-              <a:t>• Chỉ số Uplift đo lường được là chính xác tuyệt đối, loại bỏ sự may mắn ngẫu nhiên.</a:t>
-            </a:r>
-          </a:p>
-        </p:txBody>
-      </p:sp>
-      <p:pic>
-        <p:nvPicPr>
-          <p:cNvPr id="20" name="Picture 19">
-            <a:extLst>
-              <a:ext uri="{FF2B5EF4-FFF2-40B4-BE49-F238E27FC236}">
-                <a16:creationId xmlns:a16="http://schemas.microsoft.com/office/drawing/2014/main" id="{6AD519B0-8F8B-01DF-1E79-B51A188B5408}"/>
-              </a:ext>
-            </a:extLst>
-          </p:cNvPr>
-          <p:cNvPicPr>
-            <a:picLocks/>
-          </p:cNvPicPr>
-          <p:nvPr/>
-        </p:nvPicPr>
-        <p:blipFill>
-          <a:blip r:embed="rId2"/>
-          <a:stretch>
-            <a:fillRect/>
-          </a:stretch>
-        </p:blipFill>
-        <p:spPr>
-          <a:xfrm>
-            <a:off x="4572000" y="2286000"/>
-            <a:ext cx="4206240" cy="2343898"/>
-          </a:xfrm>
-          <a:prstGeom prst="rect">
-            <a:avLst/>
-          </a:prstGeom>
-        </p:spPr>
-      </p:pic>
+              <a:t>• ATE = +1.12 chuyến/user (P-value = 2.15e-10). 99% CI: [0.67, 1.57]. Kết quả vững chắc tuyệt đối!</a:t>
+            </a:r>
+          </a:p>
+        </p:txBody>
+      </p:sp>
     </p:spTree>
     <p:extLst>
       <p:ext uri="{BB962C8B-B14F-4D97-AF65-F5344CB8AC3E}">
@@ -9316,7 +8992,7 @@
               </a:defRPr>
             </a:pPr>
             <a:r>
-              <a:t>• Tác động của Voucher không phân bổ đều. Sẽ có nhóm cực kỳ nhạy cảm và nhóm hoàn toàn thờ ơ.</a:t>
+              <a:t>• Suburban Card: ROI +20.7% (Winner). Mass Voucher toàn bộ: Lỗ -$116,338. Chỉ Segment Targeting mang lại lợi nhuận!</a:t>
             </a:r>
           </a:p>
         </p:txBody>
@@ -9483,27 +9159,21 @@
               </a:defRPr>
             </a:pPr>
             <a:r>
-              <a:t>• Thuật toán tự động tìm ra các nhánh (Segments) có CATE (Conditional ATE) cao nhất để nhắm mục tiêu.</a:t>
+              <a:t>• Segment Targeting vào Suburban Card mang về +$13,993 lợi nhuận ròng (ROI +20.7%). Minh chứng HTE rõ ràng!</a:t>
             </a:r>
           </a:p>
         </p:txBody>
       </p:sp>
       <p:pic>
         <p:nvPicPr>
-          <p:cNvPr id="20" name="Picture 19">
-            <a:extLst>
-              <a:ext uri="{FF2B5EF4-FFF2-40B4-BE49-F238E27FC236}">
-                <a16:creationId xmlns:a16="http://schemas.microsoft.com/office/drawing/2014/main" id="{A0D0333D-6384-F0B1-512C-C382D38DF8CA}"/>
-              </a:ext>
-            </a:extLst>
-          </p:cNvPr>
+          <p:cNvPr id="19" name="Picture 18" descr="w4_new_img_1.png"/>
           <p:cNvPicPr>
-            <a:picLocks/>
+            <a:picLocks noChangeAspect="1"/>
           </p:cNvPicPr>
           <p:nvPr/>
         </p:nvPicPr>
         <p:blipFill>
-          <a:blip r:embed="rId2"/>
+          <a:blip r:embed="rId4"/>
           <a:stretch>
             <a:fillRect/>
           </a:stretch>

</xml_diff>